<commit_message>
docs(slide): restore and embed complete slide transitions across 21 slides
- Embed professional slide transitions (fracture cover, pageCurlDouble dividers, morph for math/pipelines, split, wipe)
- Regenerate high-resolution vector PDF export from Microsoft PowerPoint
</commit_message>
<xml_diff>
--- a/draft/fraud-detection/slide/[Nhom9]_Slide_FraudDetection_Academic_VN.pptx
+++ b/draft/fraud-detection/slide/[Nhom9]_Slide_FraudDetection_Academic_VN.pptx
@@ -3025,6 +3025,9 @@
   <p:clrMapOvr>
     <a:masterClrMapping/>
   </p:clrMapOvr>
+  <p:transition xmlns:p14="http://schemas.microsoft.com/office/powerpoint/2010/main" xmlns:p15="http://schemas.microsoft.com/office/powerpoint/2012/main" spd="slow" p14:dur="2000">
+    <p15:prstTrans prst="fracture"/>
+  </p:transition>
 </p:sld>
 </file>
 
@@ -3349,6 +3352,9 @@
   <p:clrMapOvr>
     <a:masterClrMapping/>
   </p:clrMapOvr>
+  <p:transition xmlns:p14="http://schemas.microsoft.com/office/powerpoint/2010/main" spd="slow" p14:dur="1500">
+    <p:split orient="vert"/>
+  </p:transition>
 </p:sld>
 </file>
 
@@ -4862,6 +4868,9 @@
   <p:clrMapOvr>
     <a:masterClrMapping/>
   </p:clrMapOvr>
+  <p:transition xmlns:p14="http://schemas.microsoft.com/office/powerpoint/2010/main" xmlns:p159="http://schemas.microsoft.com/office/powerpoint/2015/09/main" spd="slow" p14:dur="2000">
+    <p159:morph option="byObject"/>
+  </p:transition>
 </p:sld>
 </file>
 
@@ -5765,6 +5774,9 @@
   <p:clrMapOvr>
     <a:masterClrMapping/>
   </p:clrMapOvr>
+  <p:transition xmlns:p14="http://schemas.microsoft.com/office/powerpoint/2010/main" xmlns:p159="http://schemas.microsoft.com/office/powerpoint/2015/09/main" spd="slow" p14:dur="2000">
+    <p159:morph option="byObject"/>
+  </p:transition>
 </p:sld>
 </file>
 
@@ -7774,6 +7786,9 @@
   <p:clrMapOvr>
     <a:masterClrMapping/>
   </p:clrMapOvr>
+  <p:transition xmlns:p14="http://schemas.microsoft.com/office/powerpoint/2010/main" xmlns:p159="http://schemas.microsoft.com/office/powerpoint/2015/09/main" spd="slow" p14:dur="2000">
+    <p159:morph option="byObject"/>
+  </p:transition>
 </p:sld>
 </file>
 
@@ -8122,6 +8137,9 @@
   <p:clrMapOvr>
     <a:masterClrMapping/>
   </p:clrMapOvr>
+  <p:transition xmlns:p14="http://schemas.microsoft.com/office/powerpoint/2010/main" spd="slow" p14:dur="1500">
+    <p:split orient="vert"/>
+  </p:transition>
 </p:sld>
 </file>
 
@@ -11149,6 +11167,9 @@
   <p:clrMapOvr>
     <a:masterClrMapping/>
   </p:clrMapOvr>
+  <p:transition spd="slow">
+    <p:wipe/>
+  </p:transition>
 </p:sld>
 </file>
 
@@ -11911,6 +11932,9 @@
   <p:clrMapOvr>
     <a:masterClrMapping/>
   </p:clrMapOvr>
+  <p:transition xmlns:p14="http://schemas.microsoft.com/office/powerpoint/2010/main" spd="slow" p14:dur="1500">
+    <p:split orient="vert"/>
+  </p:transition>
 </p:sld>
 </file>
 
@@ -13711,6 +13735,9 @@
   <p:clrMapOvr>
     <a:masterClrMapping/>
   </p:clrMapOvr>
+  <p:transition xmlns:p14="http://schemas.microsoft.com/office/powerpoint/2010/main" spd="slow" p14:dur="1500">
+    <p:split orient="vert"/>
+  </p:transition>
 </p:sld>
 </file>
 
@@ -15646,6 +15673,9 @@
   <p:clrMapOvr>
     <a:masterClrMapping/>
   </p:clrMapOvr>
+  <p:transition xmlns:p14="http://schemas.microsoft.com/office/powerpoint/2010/main" spd="slow" p14:dur="1500">
+    <p:split orient="vert"/>
+  </p:transition>
 </p:sld>
 </file>
 
@@ -15970,6 +16000,9 @@
   <p:clrMapOvr>
     <a:masterClrMapping/>
   </p:clrMapOvr>
+  <p:transition xmlns:p14="http://schemas.microsoft.com/office/powerpoint/2010/main" spd="slow" p14:dur="1500">
+    <p:split orient="vert"/>
+  </p:transition>
 </p:sld>
 </file>
 
@@ -16743,6 +16776,9 @@
   <p:clrMapOvr>
     <a:masterClrMapping/>
   </p:clrMapOvr>
+  <p:transition spd="slow">
+    <p:cover/>
+  </p:transition>
 </p:sld>
 </file>
 
@@ -17678,6 +17714,9 @@
   <p:clrMapOvr>
     <a:masterClrMapping/>
   </p:clrMapOvr>
+  <p:transition spd="slow">
+    <p:wipe/>
+  </p:transition>
 </p:sld>
 </file>
 
@@ -18059,6 +18098,9 @@
   <p:clrMapOvr>
     <a:masterClrMapping/>
   </p:clrMapOvr>
+  <p:transition spd="slow">
+    <p:wipe/>
+  </p:transition>
 </p:sld>
 </file>
 
@@ -18383,6 +18425,9 @@
   <p:clrMapOvr>
     <a:masterClrMapping/>
   </p:clrMapOvr>
+  <p:transition xmlns:p14="http://schemas.microsoft.com/office/powerpoint/2010/main" xmlns:p15="http://schemas.microsoft.com/office/powerpoint/2012/main" spd="slow" p14:dur="1250">
+    <p15:prstTrans prst="pageCurlDouble"/>
+  </p:transition>
 </p:sld>
 </file>
 
@@ -20042,6 +20087,9 @@
   <p:clrMapOvr>
     <a:masterClrMapping/>
   </p:clrMapOvr>
+  <p:transition xmlns:p14="http://schemas.microsoft.com/office/powerpoint/2010/main" xmlns:p15="http://schemas.microsoft.com/office/powerpoint/2012/main" spd="slow" p14:dur="1250">
+    <p15:prstTrans prst="pageCurlDouble"/>
+  </p:transition>
 </p:sld>
 </file>
 
@@ -22029,6 +22077,9 @@
   <p:clrMapOvr>
     <a:masterClrMapping/>
   </p:clrMapOvr>
+  <p:transition xmlns:p14="http://schemas.microsoft.com/office/powerpoint/2010/main" xmlns:p15="http://schemas.microsoft.com/office/powerpoint/2012/main" spd="slow" p14:dur="1250">
+    <p15:prstTrans prst="pageCurlDouble"/>
+  </p:transition>
 </p:sld>
 </file>
 
@@ -22353,6 +22404,9 @@
   <p:clrMapOvr>
     <a:masterClrMapping/>
   </p:clrMapOvr>
+  <p:transition xmlns:p14="http://schemas.microsoft.com/office/powerpoint/2010/main" xmlns:p15="http://schemas.microsoft.com/office/powerpoint/2012/main" spd="slow" p14:dur="1250">
+    <p15:prstTrans prst="airplane"/>
+  </p:transition>
 </p:sld>
 </file>
 
@@ -23214,6 +23268,9 @@
   <p:clrMapOvr>
     <a:masterClrMapping/>
   </p:clrMapOvr>
+  <p:transition xmlns:p14="http://schemas.microsoft.com/office/powerpoint/2010/main" spd="slow" p14:dur="1500">
+    <p:split orient="vert"/>
+  </p:transition>
 </p:sld>
 </file>
 
@@ -25146,6 +25203,9 @@
   <p:clrMapOvr>
     <a:masterClrMapping/>
   </p:clrMapOvr>
+  <p:transition xmlns:p14="http://schemas.microsoft.com/office/powerpoint/2010/main" xmlns:p159="http://schemas.microsoft.com/office/powerpoint/2015/09/main" spd="slow" p14:dur="2000">
+    <p159:morph option="byObject"/>
+  </p:transition>
 </p:sld>
 </file>
 
@@ -26939,6 +26999,9 @@
   <p:clrMapOvr>
     <a:masterClrMapping/>
   </p:clrMapOvr>
+  <p:transition xmlns:p14="http://schemas.microsoft.com/office/powerpoint/2010/main" xmlns:p159="http://schemas.microsoft.com/office/powerpoint/2015/09/main" spd="slow" p14:dur="2000">
+    <p159:morph option="byObject"/>
+  </p:transition>
 </p:sld>
 </file>
 

</xml_diff>

<commit_message>
docs(slide): refine presentation script, update slide deck, and sync demo figure artifacts
</commit_message>
<xml_diff>
--- a/draft/fraud-detection/slide/[Nhom9]_Slide_FraudDetection_Academic_VN.pptx
+++ b/draft/fraud-detection/slide/[Nhom9]_Slide_FraudDetection_Academic_VN.pptx
@@ -2644,8 +2644,8 @@
         </p:nvSpPr>
         <p:spPr>
           <a:xfrm>
-            <a:off x="502920" y="3337560"/>
-            <a:ext cx="8138160" cy="502920"/>
+            <a:off x="502920" y="3172968"/>
+            <a:ext cx="8138160" cy="1581912"/>
           </a:xfrm>
           <a:prstGeom prst="rect">
             <a:avLst/>
@@ -2672,9 +2672,19 @@
                 <a:ea typeface="Segoe UI" pitchFamily="34" charset="-122"/>
                 <a:cs typeface="Segoe UI" pitchFamily="34" charset="-120"/>
               </a:rPr>
-              <a:t>Trần Hoàng Hôn (26410046)  •  Đặng Chí Thanh (25730067)  •  Nguyễn Duy Khang (26410055)</a:t>
-            </a:r>
-            <a:endParaRPr lang="en-US" sz="1000" dirty="0"/>
+              <a:t>Trần Hoàng Hôn (</a:t>
+            </a:r>
+            <a:r>
+              <a:rPr lang="en-US" sz="1000" dirty="0" smtClean="0">
+                <a:solidFill>
+                  <a:srgbClr val="CBD5E1"/>
+                </a:solidFill>
+                <a:latin typeface="Segoe UI" pitchFamily="34" charset="0"/>
+                <a:ea typeface="Segoe UI" pitchFamily="34" charset="-122"/>
+                <a:cs typeface="Segoe UI" pitchFamily="34" charset="-120"/>
+              </a:rPr>
+              <a:t>26410046)</a:t>
+            </a:r>
           </a:p>
           <a:p>
             <a:pPr marL="0" indent="0" algn="ctr">
@@ -2684,7 +2694,7 @@
               <a:buNone/>
             </a:pPr>
             <a:r>
-              <a:rPr lang="en-US" sz="1000" dirty="0">
+              <a:rPr lang="en-US" sz="1000" dirty="0" err="1" smtClean="0">
                 <a:solidFill>
                   <a:srgbClr val="CBD5E1"/>
                 </a:solidFill>
@@ -2692,10 +2702,260 @@
                 <a:ea typeface="Segoe UI" pitchFamily="34" charset="-122"/>
                 <a:cs typeface="Segoe UI" pitchFamily="34" charset="-120"/>
               </a:rPr>
-              <a:t>Hoàng Cao Sơn (25730061)  •  Vũ Văn Duy (26410031)  •  Bùi Thị Mỷ Cẩm (25730013)  •  Phạm Thanh Trung (26410141)</a:t>
+              <a:t>Đặng</a:t>
+            </a:r>
+            <a:r>
+              <a:rPr lang="en-US" sz="1000" dirty="0" smtClean="0">
+                <a:solidFill>
+                  <a:srgbClr val="CBD5E1"/>
+                </a:solidFill>
+                <a:latin typeface="Segoe UI" pitchFamily="34" charset="0"/>
+                <a:ea typeface="Segoe UI" pitchFamily="34" charset="-122"/>
+                <a:cs typeface="Segoe UI" pitchFamily="34" charset="-120"/>
+              </a:rPr>
+              <a:t> </a:t>
+            </a:r>
+            <a:r>
+              <a:rPr lang="en-US" sz="1000" dirty="0">
+                <a:solidFill>
+                  <a:srgbClr val="CBD5E1"/>
+                </a:solidFill>
+                <a:latin typeface="Segoe UI" pitchFamily="34" charset="0"/>
+                <a:ea typeface="Segoe UI" pitchFamily="34" charset="-122"/>
+                <a:cs typeface="Segoe UI" pitchFamily="34" charset="-120"/>
+              </a:rPr>
+              <a:t>Chí Thanh (25730067</a:t>
+            </a:r>
+            <a:r>
+              <a:rPr lang="en-US" sz="1000" dirty="0" smtClean="0">
+                <a:solidFill>
+                  <a:srgbClr val="CBD5E1"/>
+                </a:solidFill>
+                <a:latin typeface="Segoe UI" pitchFamily="34" charset="0"/>
+                <a:ea typeface="Segoe UI" pitchFamily="34" charset="-122"/>
+                <a:cs typeface="Segoe UI" pitchFamily="34" charset="-120"/>
+              </a:rPr>
+              <a:t>)</a:t>
+            </a:r>
+          </a:p>
+          <a:p>
+            <a:pPr marL="0" indent="0" algn="ctr">
+              <a:lnSpc>
+                <a:spcPct val="130000"/>
+              </a:lnSpc>
+              <a:buNone/>
+            </a:pPr>
+            <a:r>
+              <a:rPr lang="en-US" sz="1000" dirty="0" err="1" smtClean="0">
+                <a:solidFill>
+                  <a:srgbClr val="CBD5E1"/>
+                </a:solidFill>
+                <a:latin typeface="Segoe UI" pitchFamily="34" charset="0"/>
+                <a:ea typeface="Segoe UI" pitchFamily="34" charset="-122"/>
+                <a:cs typeface="Segoe UI" pitchFamily="34" charset="-120"/>
+              </a:rPr>
+              <a:t>Nguyễn</a:t>
+            </a:r>
+            <a:r>
+              <a:rPr lang="en-US" sz="1000" dirty="0" smtClean="0">
+                <a:solidFill>
+                  <a:srgbClr val="CBD5E1"/>
+                </a:solidFill>
+                <a:latin typeface="Segoe UI" pitchFamily="34" charset="0"/>
+                <a:ea typeface="Segoe UI" pitchFamily="34" charset="-122"/>
+                <a:cs typeface="Segoe UI" pitchFamily="34" charset="-120"/>
+              </a:rPr>
+              <a:t> </a:t>
+            </a:r>
+            <a:r>
+              <a:rPr lang="en-US" sz="1000" dirty="0">
+                <a:solidFill>
+                  <a:srgbClr val="CBD5E1"/>
+                </a:solidFill>
+                <a:latin typeface="Segoe UI" pitchFamily="34" charset="0"/>
+                <a:ea typeface="Segoe UI" pitchFamily="34" charset="-122"/>
+                <a:cs typeface="Segoe UI" pitchFamily="34" charset="-120"/>
+              </a:rPr>
+              <a:t>Duy Khang (26410055)</a:t>
             </a:r>
             <a:endParaRPr lang="en-US" sz="1000" dirty="0"/>
           </a:p>
+          <a:p>
+            <a:pPr marL="0" indent="0" algn="ctr">
+              <a:lnSpc>
+                <a:spcPct val="130000"/>
+              </a:lnSpc>
+              <a:buNone/>
+            </a:pPr>
+            <a:r>
+              <a:rPr lang="en-US" sz="1000" dirty="0">
+                <a:solidFill>
+                  <a:srgbClr val="CBD5E1"/>
+                </a:solidFill>
+                <a:latin typeface="Segoe UI" pitchFamily="34" charset="0"/>
+                <a:ea typeface="Segoe UI" pitchFamily="34" charset="-122"/>
+                <a:cs typeface="Segoe UI" pitchFamily="34" charset="-120"/>
+              </a:rPr>
+              <a:t>Hoàng Cao Sơn (</a:t>
+            </a:r>
+            <a:r>
+              <a:rPr lang="en-US" sz="1000" dirty="0" smtClean="0">
+                <a:solidFill>
+                  <a:srgbClr val="CBD5E1"/>
+                </a:solidFill>
+                <a:latin typeface="Segoe UI" pitchFamily="34" charset="0"/>
+                <a:ea typeface="Segoe UI" pitchFamily="34" charset="-122"/>
+                <a:cs typeface="Segoe UI" pitchFamily="34" charset="-120"/>
+              </a:rPr>
+              <a:t>25730061)</a:t>
+            </a:r>
+          </a:p>
+          <a:p>
+            <a:pPr marL="0" indent="0" algn="ctr">
+              <a:lnSpc>
+                <a:spcPct val="130000"/>
+              </a:lnSpc>
+              <a:buNone/>
+            </a:pPr>
+            <a:r>
+              <a:rPr lang="en-US" sz="1000" dirty="0" err="1" smtClean="0">
+                <a:solidFill>
+                  <a:srgbClr val="CBD5E1"/>
+                </a:solidFill>
+                <a:latin typeface="Segoe UI" pitchFamily="34" charset="0"/>
+                <a:ea typeface="Segoe UI" pitchFamily="34" charset="-122"/>
+                <a:cs typeface="Segoe UI" pitchFamily="34" charset="-120"/>
+              </a:rPr>
+              <a:t>Vũ</a:t>
+            </a:r>
+            <a:r>
+              <a:rPr lang="en-US" sz="1000" dirty="0" smtClean="0">
+                <a:solidFill>
+                  <a:srgbClr val="CBD5E1"/>
+                </a:solidFill>
+                <a:latin typeface="Segoe UI" pitchFamily="34" charset="0"/>
+                <a:ea typeface="Segoe UI" pitchFamily="34" charset="-122"/>
+                <a:cs typeface="Segoe UI" pitchFamily="34" charset="-120"/>
+              </a:rPr>
+              <a:t> </a:t>
+            </a:r>
+            <a:r>
+              <a:rPr lang="en-US" sz="1000" dirty="0">
+                <a:solidFill>
+                  <a:srgbClr val="CBD5E1"/>
+                </a:solidFill>
+                <a:latin typeface="Segoe UI" pitchFamily="34" charset="0"/>
+                <a:ea typeface="Segoe UI" pitchFamily="34" charset="-122"/>
+                <a:cs typeface="Segoe UI" pitchFamily="34" charset="-120"/>
+              </a:rPr>
+              <a:t>Văn Duy (</a:t>
+            </a:r>
+            <a:r>
+              <a:rPr lang="en-US" sz="1000" dirty="0" smtClean="0">
+                <a:solidFill>
+                  <a:srgbClr val="CBD5E1"/>
+                </a:solidFill>
+                <a:latin typeface="Segoe UI" pitchFamily="34" charset="0"/>
+                <a:ea typeface="Segoe UI" pitchFamily="34" charset="-122"/>
+                <a:cs typeface="Segoe UI" pitchFamily="34" charset="-120"/>
+              </a:rPr>
+              <a:t>26410031)</a:t>
+            </a:r>
+          </a:p>
+          <a:p>
+            <a:pPr marL="0" indent="0" algn="ctr">
+              <a:lnSpc>
+                <a:spcPct val="130000"/>
+              </a:lnSpc>
+              <a:buNone/>
+            </a:pPr>
+            <a:r>
+              <a:rPr lang="en-US" sz="1000" dirty="0" err="1" smtClean="0">
+                <a:solidFill>
+                  <a:srgbClr val="CBD5E1"/>
+                </a:solidFill>
+                <a:latin typeface="Segoe UI" pitchFamily="34" charset="0"/>
+                <a:ea typeface="Segoe UI" pitchFamily="34" charset="-122"/>
+                <a:cs typeface="Segoe UI" pitchFamily="34" charset="-120"/>
+              </a:rPr>
+              <a:t>Bùi</a:t>
+            </a:r>
+            <a:r>
+              <a:rPr lang="en-US" sz="1000" dirty="0" smtClean="0">
+                <a:solidFill>
+                  <a:srgbClr val="CBD5E1"/>
+                </a:solidFill>
+                <a:latin typeface="Segoe UI" pitchFamily="34" charset="0"/>
+                <a:ea typeface="Segoe UI" pitchFamily="34" charset="-122"/>
+                <a:cs typeface="Segoe UI" pitchFamily="34" charset="-120"/>
+              </a:rPr>
+              <a:t> </a:t>
+            </a:r>
+            <a:r>
+              <a:rPr lang="en-US" sz="1000" dirty="0">
+                <a:solidFill>
+                  <a:srgbClr val="CBD5E1"/>
+                </a:solidFill>
+                <a:latin typeface="Segoe UI" pitchFamily="34" charset="0"/>
+                <a:ea typeface="Segoe UI" pitchFamily="34" charset="-122"/>
+                <a:cs typeface="Segoe UI" pitchFamily="34" charset="-120"/>
+              </a:rPr>
+              <a:t>Thị Mỷ Cẩm (</a:t>
+            </a:r>
+            <a:r>
+              <a:rPr lang="en-US" sz="1000" dirty="0" smtClean="0">
+                <a:solidFill>
+                  <a:srgbClr val="CBD5E1"/>
+                </a:solidFill>
+                <a:latin typeface="Segoe UI" pitchFamily="34" charset="0"/>
+                <a:ea typeface="Segoe UI" pitchFamily="34" charset="-122"/>
+                <a:cs typeface="Segoe UI" pitchFamily="34" charset="-120"/>
+              </a:rPr>
+              <a:t>25730013)</a:t>
+            </a:r>
+          </a:p>
+          <a:p>
+            <a:pPr marL="0" indent="0" algn="ctr">
+              <a:lnSpc>
+                <a:spcPct val="130000"/>
+              </a:lnSpc>
+              <a:buNone/>
+            </a:pPr>
+            <a:r>
+              <a:rPr lang="en-US" sz="1000" dirty="0" err="1" smtClean="0">
+                <a:solidFill>
+                  <a:srgbClr val="CBD5E1"/>
+                </a:solidFill>
+                <a:latin typeface="Segoe UI" pitchFamily="34" charset="0"/>
+                <a:ea typeface="Segoe UI" pitchFamily="34" charset="-122"/>
+                <a:cs typeface="Segoe UI" pitchFamily="34" charset="-120"/>
+              </a:rPr>
+              <a:t>Phạm</a:t>
+            </a:r>
+            <a:r>
+              <a:rPr lang="en-US" sz="1000" dirty="0" smtClean="0">
+                <a:solidFill>
+                  <a:srgbClr val="CBD5E1"/>
+                </a:solidFill>
+                <a:latin typeface="Segoe UI" pitchFamily="34" charset="0"/>
+                <a:ea typeface="Segoe UI" pitchFamily="34" charset="-122"/>
+                <a:cs typeface="Segoe UI" pitchFamily="34" charset="-120"/>
+              </a:rPr>
+              <a:t> </a:t>
+            </a:r>
+            <a:r>
+              <a:rPr lang="en-US" sz="1000" dirty="0">
+                <a:solidFill>
+                  <a:srgbClr val="CBD5E1"/>
+                </a:solidFill>
+                <a:latin typeface="Segoe UI" pitchFamily="34" charset="0"/>
+                <a:ea typeface="Segoe UI" pitchFamily="34" charset="-122"/>
+                <a:cs typeface="Segoe UI" pitchFamily="34" charset="-120"/>
+              </a:rPr>
+              <a:t>Thanh Trung (26410141)</a:t>
+            </a:r>
+            <a:endParaRPr lang="en-US" sz="1000" dirty="0"/>
+          </a:p>
         </p:txBody>
       </p:sp>
       <p:sp>
@@ -2706,7 +2966,7 @@
         </p:nvSpPr>
         <p:spPr>
           <a:xfrm>
-            <a:off x="502920" y="4434840"/>
+            <a:off x="502920" y="4754880"/>
             <a:ext cx="8138160" cy="228600"/>
           </a:xfrm>
           <a:prstGeom prst="rect">
@@ -2742,13 +3002,13 @@
   <p:clrMapOvr>
     <a:masterClrMapping/>
   </p:clrMapOvr>
-  <mc:AlternateContent xmlns:mc="http://schemas.openxmlformats.org/markup-compatibility/2006">
-    <mc:Choice xmlns:p14="http://schemas.microsoft.com/office/powerpoint/2010/main" Requires="p14">
+  <mc:AlternateContent xmlns:mc="http://schemas.openxmlformats.org/markup-compatibility/2006" xmlns:p14="http://schemas.microsoft.com/office/powerpoint/2010/main">
+    <mc:Choice Requires="p14">
       <p:transition spd="slow" p14:dur="800">
         <p14:flythrough/>
       </p:transition>
     </mc:Choice>
-    <mc:Fallback>
+    <mc:Fallback xmlns="">
       <p:transition spd="slow">
         <p:fade/>
       </p:transition>
@@ -3100,13 +3360,13 @@
   <p:clrMapOvr>
     <a:masterClrMapping/>
   </p:clrMapOvr>
-  <mc:AlternateContent xmlns:mc="http://schemas.openxmlformats.org/markup-compatibility/2006">
-    <mc:Choice xmlns:p14="http://schemas.microsoft.com/office/powerpoint/2010/main" Requires="p14">
+  <mc:AlternateContent xmlns:mc="http://schemas.openxmlformats.org/markup-compatibility/2006" xmlns:p14="http://schemas.microsoft.com/office/powerpoint/2010/main">
+    <mc:Choice Requires="p14">
       <p:transition spd="slow" p14:dur="1200">
         <p14:prism/>
       </p:transition>
     </mc:Choice>
-    <mc:Fallback>
+    <mc:Fallback xmlns="">
       <p:transition spd="slow">
         <p:fade/>
       </p:transition>
@@ -3676,29 +3936,24 @@
               <a:buNone/>
             </a:pPr>
             <a:r>
-              <a:rPr lang="en-US" sz="880" dirty="0">
+              <a:rPr lang="en-US" sz="880" dirty="0" smtClean="0">
                 <a:solidFill>
                   <a:srgbClr val="1F2937"/>
                 </a:solidFill>
               </a:rPr>
               <a:t>engineered</a:t>
             </a:r>
-            <a:endParaRPr lang="en-US" sz="880" dirty="0"/>
-          </a:p>
-          <a:p>
-            <a:pPr marL="0" indent="0" algn="ctr">
-              <a:lnSpc>
-                <a:spcPct val="115000"/>
-              </a:lnSpc>
-              <a:buNone/>
-            </a:pPr>
-            <a:r>
-              <a:rPr lang="en-US" sz="880" dirty="0">
+            <a:r>
+              <a:rPr lang="en-US" sz="880" dirty="0"/>
+              <a:t> </a:t>
+            </a:r>
+            <a:r>
+              <a:rPr lang="en-US" sz="880" dirty="0" smtClean="0">
                 <a:solidFill>
                   <a:srgbClr val="1F2937"/>
                 </a:solidFill>
               </a:rPr>
-              <a:t>domain features</a:t>
+              <a:t>features</a:t>
             </a:r>
             <a:endParaRPr lang="en-US" sz="880" dirty="0"/>
           </a:p>
@@ -4585,7 +4840,7 @@
               <a:buNone/>
             </a:pPr>
             <a:r>
-              <a:rPr lang="en-US" sz="1010" b="1" dirty="0">
+              <a:rPr lang="en-US" sz="1010" b="1" dirty="0" err="1" smtClean="0">
                 <a:solidFill>
                   <a:srgbClr val="21295C"/>
                 </a:solidFill>
@@ -4593,7 +4848,117 @@
                 <a:ea typeface="Segoe UI" pitchFamily="34" charset="-122"/>
                 <a:cs typeface="Segoe UI" pitchFamily="34" charset="-120"/>
               </a:rPr>
-              <a:t>Quy chuẩn Khắt khe Chống Rò rỉ Dữ liệu (Strict Protocol Against Data Leakage)</a:t>
+              <a:t>Nguyên</a:t>
+            </a:r>
+            <a:r>
+              <a:rPr lang="en-US" sz="1010" b="1" dirty="0" smtClean="0">
+                <a:solidFill>
+                  <a:srgbClr val="21295C"/>
+                </a:solidFill>
+                <a:latin typeface="Segoe UI" pitchFamily="34" charset="0"/>
+                <a:ea typeface="Segoe UI" pitchFamily="34" charset="-122"/>
+                <a:cs typeface="Segoe UI" pitchFamily="34" charset="-120"/>
+              </a:rPr>
+              <a:t> </a:t>
+            </a:r>
+            <a:r>
+              <a:rPr lang="en-US" sz="1010" b="1" dirty="0" err="1" smtClean="0">
+                <a:solidFill>
+                  <a:srgbClr val="21295C"/>
+                </a:solidFill>
+                <a:latin typeface="Segoe UI" pitchFamily="34" charset="0"/>
+                <a:ea typeface="Segoe UI" pitchFamily="34" charset="-122"/>
+                <a:cs typeface="Segoe UI" pitchFamily="34" charset="-120"/>
+              </a:rPr>
+              <a:t>tắc</a:t>
+            </a:r>
+            <a:r>
+              <a:rPr lang="en-US" sz="1010" b="1" dirty="0" smtClean="0">
+                <a:solidFill>
+                  <a:srgbClr val="21295C"/>
+                </a:solidFill>
+                <a:latin typeface="Segoe UI" pitchFamily="34" charset="0"/>
+                <a:ea typeface="Segoe UI" pitchFamily="34" charset="-122"/>
+                <a:cs typeface="Segoe UI" pitchFamily="34" charset="-120"/>
+              </a:rPr>
+              <a:t> </a:t>
+            </a:r>
+            <a:r>
+              <a:rPr lang="en-US" sz="1010" b="1" dirty="0" err="1" smtClean="0">
+                <a:solidFill>
+                  <a:srgbClr val="21295C"/>
+                </a:solidFill>
+                <a:latin typeface="Segoe UI" pitchFamily="34" charset="0"/>
+                <a:ea typeface="Segoe UI" pitchFamily="34" charset="-122"/>
+                <a:cs typeface="Segoe UI" pitchFamily="34" charset="-120"/>
+              </a:rPr>
+              <a:t>Chống</a:t>
+            </a:r>
+            <a:r>
+              <a:rPr lang="en-US" sz="1010" b="1" dirty="0" smtClean="0">
+                <a:solidFill>
+                  <a:srgbClr val="21295C"/>
+                </a:solidFill>
+                <a:latin typeface="Segoe UI" pitchFamily="34" charset="0"/>
+                <a:ea typeface="Segoe UI" pitchFamily="34" charset="-122"/>
+                <a:cs typeface="Segoe UI" pitchFamily="34" charset="-120"/>
+              </a:rPr>
+              <a:t> </a:t>
+            </a:r>
+            <a:r>
+              <a:rPr lang="en-US" sz="1010" b="1" dirty="0">
+                <a:solidFill>
+                  <a:srgbClr val="21295C"/>
+                </a:solidFill>
+                <a:latin typeface="Segoe UI" pitchFamily="34" charset="0"/>
+                <a:ea typeface="Segoe UI" pitchFamily="34" charset="-122"/>
+                <a:cs typeface="Segoe UI" pitchFamily="34" charset="-120"/>
+              </a:rPr>
+              <a:t>Rò rỉ Dữ </a:t>
+            </a:r>
+            <a:r>
+              <a:rPr lang="en-US" sz="1010" b="1" dirty="0" err="1">
+                <a:solidFill>
+                  <a:srgbClr val="21295C"/>
+                </a:solidFill>
+                <a:latin typeface="Segoe UI" pitchFamily="34" charset="0"/>
+                <a:ea typeface="Segoe UI" pitchFamily="34" charset="-122"/>
+                <a:cs typeface="Segoe UI" pitchFamily="34" charset="-120"/>
+              </a:rPr>
+              <a:t>liệu</a:t>
+            </a:r>
+            <a:r>
+              <a:rPr lang="en-US" sz="1010" b="1" dirty="0">
+                <a:solidFill>
+                  <a:srgbClr val="21295C"/>
+                </a:solidFill>
+                <a:latin typeface="Segoe UI" pitchFamily="34" charset="0"/>
+                <a:ea typeface="Segoe UI" pitchFamily="34" charset="-122"/>
+                <a:cs typeface="Segoe UI" pitchFamily="34" charset="-120"/>
+              </a:rPr>
+              <a:t> </a:t>
+            </a:r>
+            <a:r>
+              <a:rPr lang="en-US" sz="1010" b="1" dirty="0" smtClean="0">
+                <a:solidFill>
+                  <a:srgbClr val="21295C"/>
+                </a:solidFill>
+                <a:latin typeface="Segoe UI" pitchFamily="34" charset="0"/>
+                <a:ea typeface="Segoe UI" pitchFamily="34" charset="-122"/>
+                <a:cs typeface="Segoe UI" pitchFamily="34" charset="-120"/>
+              </a:rPr>
+              <a:t>(Data </a:t>
+            </a:r>
+            <a:r>
+              <a:rPr lang="en-US" sz="1010" b="1" dirty="0">
+                <a:solidFill>
+                  <a:srgbClr val="21295C"/>
+                </a:solidFill>
+                <a:latin typeface="Segoe UI" pitchFamily="34" charset="0"/>
+                <a:ea typeface="Segoe UI" pitchFamily="34" charset="-122"/>
+                <a:cs typeface="Segoe UI" pitchFamily="34" charset="-120"/>
+              </a:rPr>
+              <a:t>Leakage)</a:t>
             </a:r>
             <a:endParaRPr lang="en-US" sz="1010" dirty="0"/>
           </a:p>
@@ -4724,13 +5089,13 @@
   <p:clrMapOvr>
     <a:masterClrMapping/>
   </p:clrMapOvr>
-  <mc:AlternateContent xmlns:mc="http://schemas.openxmlformats.org/markup-compatibility/2006">
-    <mc:Choice xmlns:p14="http://schemas.microsoft.com/office/powerpoint/2010/main" Requires="p14">
+  <mc:AlternateContent xmlns:mc="http://schemas.openxmlformats.org/markup-compatibility/2006" xmlns:p14="http://schemas.microsoft.com/office/powerpoint/2010/main">
+    <mc:Choice Requires="p14">
       <p:transition spd="slow" p14:dur="1300">
         <p14:pan dir="u"/>
       </p:transition>
     </mc:Choice>
-    <mc:Fallback>
+    <mc:Fallback xmlns="">
       <p:transition spd="slow">
         <p:fade/>
       </p:transition>
@@ -5103,17 +5468,6 @@
             <a:pPr marL="0" indent="0">
               <a:buNone/>
             </a:pPr>
-            <a:r>
-              <a:rPr lang="en-US" sz="950" b="1" dirty="0">
-                <a:solidFill>
-                  <a:srgbClr val="2563EB"/>
-                </a:solidFill>
-                <a:latin typeface="Consolas" pitchFamily="34" charset="0"/>
-                <a:ea typeface="Consolas" pitchFamily="34" charset="-122"/>
-                <a:cs typeface="Consolas" pitchFamily="34" charset="-120"/>
-              </a:rPr>
-              <a:t>Gini(D) = 1 - ∑ (p_i)²</a:t>
-            </a:r>
             <a:endParaRPr lang="en-US" sz="950" dirty="0"/>
           </a:p>
         </p:txBody>
@@ -5289,7 +5643,55 @@
                   <a:srgbClr val="1F2937"/>
                 </a:solidFill>
               </a:rPr>
-              <a:t>Thời gian huấn luyện lâu (~1187s), chi phí tính toán cao khi dữ liệu phình to.</a:t>
+              <a:t>Thời gian huấn luyện </a:t>
+            </a:r>
+            <a:r>
+              <a:rPr lang="en-US" sz="900" dirty="0" err="1">
+                <a:solidFill>
+                  <a:srgbClr val="1F2937"/>
+                </a:solidFill>
+              </a:rPr>
+              <a:t>lâu</a:t>
+            </a:r>
+            <a:r>
+              <a:rPr lang="en-US" sz="900" dirty="0">
+                <a:solidFill>
+                  <a:srgbClr val="1F2937"/>
+                </a:solidFill>
+              </a:rPr>
+              <a:t> </a:t>
+            </a:r>
+            <a:r>
+              <a:rPr lang="en-US" sz="900" dirty="0" smtClean="0">
+                <a:solidFill>
+                  <a:srgbClr val="1F2937"/>
+                </a:solidFill>
+              </a:rPr>
+              <a:t>(~20 </a:t>
+            </a:r>
+            <a:r>
+              <a:rPr lang="en-US" sz="900" dirty="0" err="1" smtClean="0">
+                <a:solidFill>
+                  <a:srgbClr val="1F2937"/>
+                </a:solidFill>
+              </a:rPr>
+              <a:t>phút</a:t>
+            </a:r>
+            <a:r>
+              <a:rPr lang="en-US" sz="900" dirty="0" smtClean="0">
+                <a:solidFill>
+                  <a:srgbClr val="1F2937"/>
+                </a:solidFill>
+              </a:rPr>
+              <a:t>), </a:t>
+            </a:r>
+            <a:r>
+              <a:rPr lang="en-US" sz="900" dirty="0">
+                <a:solidFill>
+                  <a:srgbClr val="1F2937"/>
+                </a:solidFill>
+              </a:rPr>
+              <a:t>chi phí tính toán cao khi dữ liệu phình to.</a:t>
             </a:r>
             <a:endParaRPr lang="en-US" sz="900" dirty="0"/>
           </a:p>
@@ -5446,17 +5848,6 @@
             <a:pPr marL="0" indent="0">
               <a:buNone/>
             </a:pPr>
-            <a:r>
-              <a:rPr lang="en-US" sz="900" b="1" dirty="0">
-                <a:solidFill>
-                  <a:srgbClr val="2563EB"/>
-                </a:solidFill>
-                <a:latin typeface="Consolas" pitchFamily="34" charset="0"/>
-                <a:ea typeface="Consolas" pitchFamily="34" charset="-122"/>
-                <a:cs typeface="Consolas" pitchFamily="34" charset="-120"/>
-              </a:rPr>
-              <a:t>Obj^(t) ≈ ∑ [ g_i · f_t + ½ h_i · f_t² ] + Ω(f_t)</a:t>
-            </a:r>
             <a:endParaRPr lang="en-US" sz="900" dirty="0"/>
           </a:p>
         </p:txBody>
@@ -5615,7 +6006,63 @@
                   <a:srgbClr val="1F2937"/>
                 </a:solidFill>
               </a:rPr>
-              <a:t>F1-Score đạt 99.63% tương đương RF, nhưng tốc độ huấn luyện nhanh gấp 28.5 lần (~41.7s).
+              <a:t>F1-Score đạt 99.63% tương đương RF, nhưng tốc độ huấn luyện nhanh </a:t>
+            </a:r>
+            <a:r>
+              <a:rPr lang="en-US" sz="900" dirty="0" err="1">
+                <a:solidFill>
+                  <a:srgbClr val="1F2937"/>
+                </a:solidFill>
+              </a:rPr>
+              <a:t>gấp</a:t>
+            </a:r>
+            <a:r>
+              <a:rPr lang="en-US" sz="900" dirty="0">
+                <a:solidFill>
+                  <a:srgbClr val="1F2937"/>
+                </a:solidFill>
+              </a:rPr>
+              <a:t> </a:t>
+            </a:r>
+            <a:r>
+              <a:rPr lang="en-US" sz="900" dirty="0" err="1" smtClean="0">
+                <a:solidFill>
+                  <a:srgbClr val="1F2937"/>
+                </a:solidFill>
+              </a:rPr>
+              <a:t>khoảng</a:t>
+            </a:r>
+            <a:r>
+              <a:rPr lang="en-US" sz="900" dirty="0" smtClean="0">
+                <a:solidFill>
+                  <a:srgbClr val="1F2937"/>
+                </a:solidFill>
+              </a:rPr>
+              <a:t> 28 </a:t>
+            </a:r>
+            <a:r>
+              <a:rPr lang="en-US" sz="900" dirty="0">
+                <a:solidFill>
+                  <a:srgbClr val="1F2937"/>
+                </a:solidFill>
+              </a:rPr>
+              <a:t>lần (~</a:t>
+            </a:r>
+            <a:r>
+              <a:rPr lang="en-US" sz="900" dirty="0" smtClean="0">
+                <a:solidFill>
+                  <a:srgbClr val="1F2937"/>
+                </a:solidFill>
+              </a:rPr>
+              <a:t>42s</a:t>
+            </a:r>
+            <a:r>
+              <a:rPr lang="en-US" sz="900" dirty="0">
+                <a:solidFill>
+                  <a:srgbClr val="1F2937"/>
+                </a:solidFill>
+              </a:rPr>
+              <a:t>).
 </a:t>
             </a:r>
             <a:r>
@@ -5638,6 +6085,54 @@
           </a:p>
         </p:txBody>
       </p:sp>
+      <p:pic>
+        <p:nvPicPr>
+          <p:cNvPr id="24" name="Picture 23"/>
+          <p:cNvPicPr>
+            <a:picLocks noChangeAspect="1"/>
+          </p:cNvPicPr>
+          <p:nvPr/>
+        </p:nvPicPr>
+        <p:blipFill>
+          <a:blip r:embed="rId3"/>
+          <a:stretch>
+            <a:fillRect/>
+          </a:stretch>
+        </p:blipFill>
+        <p:spPr>
+          <a:xfrm>
+            <a:off x="4850131" y="1463040"/>
+            <a:ext cx="3281934" cy="274320"/>
+          </a:xfrm>
+          <a:prstGeom prst="rect">
+            <a:avLst/>
+          </a:prstGeom>
+        </p:spPr>
+      </p:pic>
+      <p:pic>
+        <p:nvPicPr>
+          <p:cNvPr id="25" name="Picture 24"/>
+          <p:cNvPicPr>
+            <a:picLocks noChangeAspect="1"/>
+          </p:cNvPicPr>
+          <p:nvPr/>
+        </p:nvPicPr>
+        <p:blipFill>
+          <a:blip r:embed="rId4"/>
+          <a:stretch>
+            <a:fillRect/>
+          </a:stretch>
+        </p:blipFill>
+        <p:spPr>
+          <a:xfrm>
+            <a:off x="905115" y="1463040"/>
+            <a:ext cx="2770773" cy="301752"/>
+          </a:xfrm>
+          <a:prstGeom prst="rect">
+            <a:avLst/>
+          </a:prstGeom>
+        </p:spPr>
+      </p:pic>
     </p:spTree>
   </p:cSld>
   <p:clrMapOvr>
@@ -6018,8 +6513,8 @@
         </p:nvSpPr>
         <p:spPr>
           <a:xfrm>
-            <a:off x="640080" y="1763442"/>
-            <a:ext cx="4114800" cy="310896"/>
+            <a:off x="640080" y="1763441"/>
+            <a:ext cx="4114800" cy="461326"/>
           </a:xfrm>
           <a:prstGeom prst="rect">
             <a:avLst/>
@@ -6066,17 +6561,6 @@
             <a:pPr marL="0" indent="0">
               <a:buNone/>
             </a:pPr>
-            <a:r>
-              <a:rPr lang="en-US" sz="900" b="1" dirty="0">
-                <a:solidFill>
-                  <a:srgbClr val="DC2626"/>
-                </a:solidFill>
-                <a:latin typeface="Consolas" pitchFamily="34" charset="0"/>
-                <a:ea typeface="Consolas" pitchFamily="34" charset="-122"/>
-                <a:cs typeface="Consolas" pitchFamily="34" charset="-120"/>
-              </a:rPr>
-              <a:t>L_rec(x, x_recon) = (1 / d) · ∑ (x_j - x_recon_j)²</a:t>
-            </a:r>
             <a:endParaRPr lang="en-US" sz="900" dirty="0"/>
           </a:p>
         </p:txBody>
@@ -7720,6 +8204,30 @@
           </a:p>
         </p:txBody>
       </p:sp>
+      <p:pic>
+        <p:nvPicPr>
+          <p:cNvPr id="21" name="Picture 20"/>
+          <p:cNvPicPr>
+            <a:picLocks noChangeAspect="1"/>
+          </p:cNvPicPr>
+          <p:nvPr/>
+        </p:nvPicPr>
+        <p:blipFill>
+          <a:blip r:embed="rId3"/>
+          <a:stretch>
+            <a:fillRect/>
+          </a:stretch>
+        </p:blipFill>
+        <p:spPr>
+          <a:xfrm>
+            <a:off x="1028381" y="1778508"/>
+            <a:ext cx="2251267" cy="391668"/>
+          </a:xfrm>
+          <a:prstGeom prst="rect">
+            <a:avLst/>
+          </a:prstGeom>
+        </p:spPr>
+      </p:pic>
     </p:spTree>
   </p:cSld>
   <p:clrMapOvr>
@@ -8024,7 +8532,117 @@
                 <a:ea typeface="Segoe UI" pitchFamily="34" charset="-122"/>
                 <a:cs typeface="Segoe UI" pitchFamily="34" charset="-120"/>
               </a:rPr>
-              <a:t>Benchmark Hiệu năng Toàn diện &amp; Đối chuẩn Đa Chỉ số (Precision, Recall, F1, PR-AUC)</a:t>
+              <a:t>Benchmark Hiệu năng Toàn diện &amp; </a:t>
+            </a:r>
+            <a:r>
+              <a:rPr lang="en-US" sz="1100" dirty="0" err="1" smtClean="0">
+                <a:solidFill>
+                  <a:srgbClr val="E2E8F0"/>
+                </a:solidFill>
+                <a:latin typeface="Segoe UI" pitchFamily="34" charset="0"/>
+                <a:ea typeface="Segoe UI" pitchFamily="34" charset="-122"/>
+                <a:cs typeface="Segoe UI" pitchFamily="34" charset="-120"/>
+              </a:rPr>
+              <a:t>Bảng</a:t>
+            </a:r>
+            <a:r>
+              <a:rPr lang="en-US" sz="1100" dirty="0" smtClean="0">
+                <a:solidFill>
+                  <a:srgbClr val="E2E8F0"/>
+                </a:solidFill>
+                <a:latin typeface="Segoe UI" pitchFamily="34" charset="0"/>
+                <a:ea typeface="Segoe UI" pitchFamily="34" charset="-122"/>
+                <a:cs typeface="Segoe UI" pitchFamily="34" charset="-120"/>
+              </a:rPr>
+              <a:t> so </a:t>
+            </a:r>
+            <a:r>
+              <a:rPr lang="en-US" sz="1100" dirty="0" err="1" smtClean="0">
+                <a:solidFill>
+                  <a:srgbClr val="E2E8F0"/>
+                </a:solidFill>
+                <a:latin typeface="Segoe UI" pitchFamily="34" charset="0"/>
+                <a:ea typeface="Segoe UI" pitchFamily="34" charset="-122"/>
+                <a:cs typeface="Segoe UI" pitchFamily="34" charset="-120"/>
+              </a:rPr>
+              <a:t>sánh</a:t>
+            </a:r>
+            <a:r>
+              <a:rPr lang="en-US" sz="1100" dirty="0" smtClean="0">
+                <a:solidFill>
+                  <a:srgbClr val="E2E8F0"/>
+                </a:solidFill>
+                <a:latin typeface="Segoe UI" pitchFamily="34" charset="0"/>
+                <a:ea typeface="Segoe UI" pitchFamily="34" charset="-122"/>
+                <a:cs typeface="Segoe UI" pitchFamily="34" charset="-120"/>
+              </a:rPr>
+              <a:t> </a:t>
+            </a:r>
+            <a:r>
+              <a:rPr lang="en-US" sz="1100" dirty="0" err="1" smtClean="0">
+                <a:solidFill>
+                  <a:srgbClr val="E2E8F0"/>
+                </a:solidFill>
+                <a:latin typeface="Segoe UI" pitchFamily="34" charset="0"/>
+                <a:ea typeface="Segoe UI" pitchFamily="34" charset="-122"/>
+                <a:cs typeface="Segoe UI" pitchFamily="34" charset="-120"/>
+              </a:rPr>
+              <a:t>đa</a:t>
+            </a:r>
+            <a:r>
+              <a:rPr lang="en-US" sz="1100" dirty="0" smtClean="0">
+                <a:solidFill>
+                  <a:srgbClr val="E2E8F0"/>
+                </a:solidFill>
+                <a:latin typeface="Segoe UI" pitchFamily="34" charset="0"/>
+                <a:ea typeface="Segoe UI" pitchFamily="34" charset="-122"/>
+                <a:cs typeface="Segoe UI" pitchFamily="34" charset="-120"/>
+              </a:rPr>
+              <a:t> </a:t>
+            </a:r>
+            <a:r>
+              <a:rPr lang="en-US" sz="1100" dirty="0" err="1">
+                <a:solidFill>
+                  <a:srgbClr val="E2E8F0"/>
+                </a:solidFill>
+                <a:latin typeface="Segoe UI" pitchFamily="34" charset="0"/>
+                <a:ea typeface="Segoe UI" pitchFamily="34" charset="-122"/>
+                <a:cs typeface="Segoe UI" pitchFamily="34" charset="-120"/>
+              </a:rPr>
+              <a:t>c</a:t>
+            </a:r>
+            <a:r>
+              <a:rPr lang="en-US" sz="1100" dirty="0" err="1" smtClean="0">
+                <a:solidFill>
+                  <a:srgbClr val="E2E8F0"/>
+                </a:solidFill>
+                <a:latin typeface="Segoe UI" pitchFamily="34" charset="0"/>
+                <a:ea typeface="Segoe UI" pitchFamily="34" charset="-122"/>
+                <a:cs typeface="Segoe UI" pitchFamily="34" charset="-120"/>
+              </a:rPr>
+              <a:t>hỉ</a:t>
+            </a:r>
+            <a:r>
+              <a:rPr lang="en-US" sz="1100" dirty="0" smtClean="0">
+                <a:solidFill>
+                  <a:srgbClr val="E2E8F0"/>
+                </a:solidFill>
+                <a:latin typeface="Segoe UI" pitchFamily="34" charset="0"/>
+                <a:ea typeface="Segoe UI" pitchFamily="34" charset="-122"/>
+                <a:cs typeface="Segoe UI" pitchFamily="34" charset="-120"/>
+              </a:rPr>
+              <a:t> </a:t>
+            </a:r>
+            <a:r>
+              <a:rPr lang="en-US" sz="1100" dirty="0">
+                <a:solidFill>
+                  <a:srgbClr val="E2E8F0"/>
+                </a:solidFill>
+                <a:latin typeface="Segoe UI" pitchFamily="34" charset="0"/>
+                <a:ea typeface="Segoe UI" pitchFamily="34" charset="-122"/>
+                <a:cs typeface="Segoe UI" pitchFamily="34" charset="-120"/>
+              </a:rPr>
+              <a:t>số (Precision, Recall, F1, PR-AUC)</a:t>
             </a:r>
             <a:endParaRPr lang="en-US" sz="1100" dirty="0"/>
           </a:p>
@@ -8072,7 +8690,62 @@
                 <a:ea typeface="Segoe UI" pitchFamily="34" charset="-122"/>
                 <a:cs typeface="Segoe UI" pitchFamily="34" charset="-120"/>
               </a:rPr>
-              <a:t>Feature Importance Attribution &amp; Đóng góp Vượt bậc của Domain Engineering</a:t>
+              <a:t>Feature Importance Attribution &amp; Đóng góp Vượt </a:t>
+            </a:r>
+            <a:r>
+              <a:rPr lang="en-US" sz="1100" dirty="0" err="1">
+                <a:solidFill>
+                  <a:srgbClr val="E2E8F0"/>
+                </a:solidFill>
+                <a:latin typeface="Segoe UI" pitchFamily="34" charset="0"/>
+                <a:ea typeface="Segoe UI" pitchFamily="34" charset="-122"/>
+                <a:cs typeface="Segoe UI" pitchFamily="34" charset="-120"/>
+              </a:rPr>
+              <a:t>bậc</a:t>
+            </a:r>
+            <a:r>
+              <a:rPr lang="en-US" sz="1100" dirty="0">
+                <a:solidFill>
+                  <a:srgbClr val="E2E8F0"/>
+                </a:solidFill>
+                <a:latin typeface="Segoe UI" pitchFamily="34" charset="0"/>
+                <a:ea typeface="Segoe UI" pitchFamily="34" charset="-122"/>
+                <a:cs typeface="Segoe UI" pitchFamily="34" charset="-120"/>
+              </a:rPr>
+              <a:t> </a:t>
+            </a:r>
+            <a:r>
+              <a:rPr lang="en-US" sz="1100" dirty="0" err="1" smtClean="0">
+                <a:solidFill>
+                  <a:srgbClr val="E2E8F0"/>
+                </a:solidFill>
+                <a:latin typeface="Segoe UI" pitchFamily="34" charset="0"/>
+                <a:ea typeface="Segoe UI" pitchFamily="34" charset="-122"/>
+                <a:cs typeface="Segoe UI" pitchFamily="34" charset="-120"/>
+              </a:rPr>
+              <a:t>của</a:t>
+            </a:r>
+            <a:r>
+              <a:rPr lang="en-US" sz="1100" dirty="0" smtClean="0">
+                <a:solidFill>
+                  <a:srgbClr val="E2E8F0"/>
+                </a:solidFill>
+                <a:latin typeface="Segoe UI" pitchFamily="34" charset="0"/>
+                <a:ea typeface="Segoe UI" pitchFamily="34" charset="-122"/>
+                <a:cs typeface="Segoe UI" pitchFamily="34" charset="-120"/>
+              </a:rPr>
+              <a:t> </a:t>
+            </a:r>
+            <a:r>
+              <a:rPr lang="en-US" sz="1100" dirty="0">
+                <a:solidFill>
+                  <a:srgbClr val="E2E8F0"/>
+                </a:solidFill>
+                <a:latin typeface="Segoe UI" pitchFamily="34" charset="0"/>
+                <a:ea typeface="Segoe UI" pitchFamily="34" charset="-122"/>
+                <a:cs typeface="Segoe UI" pitchFamily="34" charset="-120"/>
+              </a:rPr>
+              <a:t>Engineering</a:t>
             </a:r>
             <a:endParaRPr lang="en-US" sz="1100" dirty="0"/>
           </a:p>
@@ -8107,13 +8780,13 @@
   <p:clrMapOvr>
     <a:masterClrMapping/>
   </p:clrMapOvr>
-  <mc:AlternateContent xmlns:mc="http://schemas.openxmlformats.org/markup-compatibility/2006">
-    <mc:Choice xmlns:p14="http://schemas.microsoft.com/office/powerpoint/2010/main" Requires="p14">
+  <mc:AlternateContent xmlns:mc="http://schemas.openxmlformats.org/markup-compatibility/2006" xmlns:p14="http://schemas.microsoft.com/office/powerpoint/2010/main">
+    <mc:Choice Requires="p14">
       <p:transition spd="slow" p14:dur="1200">
         <p14:prism/>
       </p:transition>
     </mc:Choice>
-    <mc:Fallback>
+    <mc:Fallback xmlns="">
       <p:transition spd="slow">
         <p:fade/>
       </p:transition>
@@ -8221,7 +8894,117 @@
                 <a:ea typeface="Segoe UI" pitchFamily="34" charset="-122"/>
                 <a:cs typeface="Segoe UI" pitchFamily="34" charset="-120"/>
               </a:rPr>
-              <a:t>Kết quả Thực nghiệm: Đối chuẩn Đa Chỉ số Toàn diện</a:t>
+              <a:t>Kết quả Thực nghiệm: </a:t>
+            </a:r>
+            <a:r>
+              <a:rPr lang="en-US" sz="1900" b="1" dirty="0" smtClean="0">
+                <a:solidFill>
+                  <a:srgbClr val="21295C"/>
+                </a:solidFill>
+                <a:latin typeface="Segoe UI" pitchFamily="34" charset="0"/>
+                <a:ea typeface="Segoe UI" pitchFamily="34" charset="-122"/>
+                <a:cs typeface="Segoe UI" pitchFamily="34" charset="-120"/>
+              </a:rPr>
+              <a:t>So </a:t>
+            </a:r>
+            <a:r>
+              <a:rPr lang="en-US" sz="1900" b="1" dirty="0" err="1" smtClean="0">
+                <a:solidFill>
+                  <a:srgbClr val="21295C"/>
+                </a:solidFill>
+                <a:latin typeface="Segoe UI" pitchFamily="34" charset="0"/>
+                <a:ea typeface="Segoe UI" pitchFamily="34" charset="-122"/>
+                <a:cs typeface="Segoe UI" pitchFamily="34" charset="-120"/>
+              </a:rPr>
+              <a:t>sánh</a:t>
+            </a:r>
+            <a:r>
+              <a:rPr lang="en-US" sz="1900" b="1" dirty="0" smtClean="0">
+                <a:solidFill>
+                  <a:srgbClr val="21295C"/>
+                </a:solidFill>
+                <a:latin typeface="Segoe UI" pitchFamily="34" charset="0"/>
+                <a:ea typeface="Segoe UI" pitchFamily="34" charset="-122"/>
+                <a:cs typeface="Segoe UI" pitchFamily="34" charset="-120"/>
+              </a:rPr>
+              <a:t> </a:t>
+            </a:r>
+            <a:r>
+              <a:rPr lang="en-US" sz="1900" b="1" dirty="0" err="1" smtClean="0">
+                <a:solidFill>
+                  <a:srgbClr val="21295C"/>
+                </a:solidFill>
+                <a:latin typeface="Segoe UI" pitchFamily="34" charset="0"/>
+                <a:ea typeface="Segoe UI" pitchFamily="34" charset="-122"/>
+                <a:cs typeface="Segoe UI" pitchFamily="34" charset="-120"/>
+              </a:rPr>
+              <a:t>đ</a:t>
+            </a:r>
+            <a:r>
+              <a:rPr lang="en-US" sz="1900" b="1" dirty="0" err="1" smtClean="0">
+                <a:solidFill>
+                  <a:srgbClr val="21295C"/>
+                </a:solidFill>
+                <a:latin typeface="Segoe UI" pitchFamily="34" charset="0"/>
+                <a:ea typeface="Segoe UI" pitchFamily="34" charset="-122"/>
+                <a:cs typeface="Segoe UI" pitchFamily="34" charset="-120"/>
+              </a:rPr>
+              <a:t>a</a:t>
+            </a:r>
+            <a:r>
+              <a:rPr lang="en-US" sz="1900" b="1" dirty="0" smtClean="0">
+                <a:solidFill>
+                  <a:srgbClr val="21295C"/>
+                </a:solidFill>
+                <a:latin typeface="Segoe UI" pitchFamily="34" charset="0"/>
+                <a:ea typeface="Segoe UI" pitchFamily="34" charset="-122"/>
+                <a:cs typeface="Segoe UI" pitchFamily="34" charset="-120"/>
+              </a:rPr>
+              <a:t> </a:t>
+            </a:r>
+            <a:r>
+              <a:rPr lang="en-US" sz="1900" b="1" dirty="0" err="1" smtClean="0">
+                <a:solidFill>
+                  <a:srgbClr val="21295C"/>
+                </a:solidFill>
+                <a:latin typeface="Segoe UI" pitchFamily="34" charset="0"/>
+                <a:ea typeface="Segoe UI" pitchFamily="34" charset="-122"/>
+                <a:cs typeface="Segoe UI" pitchFamily="34" charset="-120"/>
+              </a:rPr>
+              <a:t>c</a:t>
+            </a:r>
+            <a:r>
+              <a:rPr lang="en-US" sz="1900" b="1" dirty="0" err="1" smtClean="0">
+                <a:solidFill>
+                  <a:srgbClr val="21295C"/>
+                </a:solidFill>
+                <a:latin typeface="Segoe UI" pitchFamily="34" charset="0"/>
+                <a:ea typeface="Segoe UI" pitchFamily="34" charset="-122"/>
+                <a:cs typeface="Segoe UI" pitchFamily="34" charset="-120"/>
+              </a:rPr>
+              <a:t>hỉ</a:t>
+            </a:r>
+            <a:r>
+              <a:rPr lang="en-US" sz="1900" b="1" dirty="0" smtClean="0">
+                <a:solidFill>
+                  <a:srgbClr val="21295C"/>
+                </a:solidFill>
+                <a:latin typeface="Segoe UI" pitchFamily="34" charset="0"/>
+                <a:ea typeface="Segoe UI" pitchFamily="34" charset="-122"/>
+                <a:cs typeface="Segoe UI" pitchFamily="34" charset="-120"/>
+              </a:rPr>
+              <a:t> </a:t>
+            </a:r>
+            <a:r>
+              <a:rPr lang="en-US" sz="1900" b="1" dirty="0" err="1" smtClean="0">
+                <a:solidFill>
+                  <a:srgbClr val="21295C"/>
+                </a:solidFill>
+                <a:latin typeface="Segoe UI" pitchFamily="34" charset="0"/>
+                <a:ea typeface="Segoe UI" pitchFamily="34" charset="-122"/>
+                <a:cs typeface="Segoe UI" pitchFamily="34" charset="-120"/>
+              </a:rPr>
+              <a:t>số</a:t>
             </a:r>
             <a:endParaRPr lang="en-US" sz="1900" dirty="0"/>
           </a:p>
@@ -10960,7 +11743,62 @@
                 <a:ea typeface="Segoe UI" pitchFamily="34" charset="-122"/>
                 <a:cs typeface="Segoe UI" pitchFamily="34" charset="-120"/>
               </a:rPr>
-              <a:t>Đúc kết Thực nghiệm Định lượng</a:t>
+              <a:t>Đúc </a:t>
+            </a:r>
+            <a:r>
+              <a:rPr lang="en-US" sz="940" b="1" dirty="0" err="1">
+                <a:solidFill>
+                  <a:srgbClr val="21295C"/>
+                </a:solidFill>
+                <a:latin typeface="Segoe UI" pitchFamily="34" charset="0"/>
+                <a:ea typeface="Segoe UI" pitchFamily="34" charset="-122"/>
+                <a:cs typeface="Segoe UI" pitchFamily="34" charset="-120"/>
+              </a:rPr>
+              <a:t>kết</a:t>
+            </a:r>
+            <a:r>
+              <a:rPr lang="en-US" sz="940" b="1" dirty="0">
+                <a:solidFill>
+                  <a:srgbClr val="21295C"/>
+                </a:solidFill>
+                <a:latin typeface="Segoe UI" pitchFamily="34" charset="0"/>
+                <a:ea typeface="Segoe UI" pitchFamily="34" charset="-122"/>
+                <a:cs typeface="Segoe UI" pitchFamily="34" charset="-120"/>
+              </a:rPr>
+              <a:t> </a:t>
+            </a:r>
+            <a:r>
+              <a:rPr lang="en-US" sz="940" b="1" dirty="0" err="1" smtClean="0">
+                <a:solidFill>
+                  <a:srgbClr val="21295C"/>
+                </a:solidFill>
+                <a:latin typeface="Segoe UI" pitchFamily="34" charset="0"/>
+                <a:ea typeface="Segoe UI" pitchFamily="34" charset="-122"/>
+                <a:cs typeface="Segoe UI" pitchFamily="34" charset="-120"/>
+              </a:rPr>
+              <a:t>bảng</a:t>
+            </a:r>
+            <a:r>
+              <a:rPr lang="en-US" sz="940" b="1" dirty="0" smtClean="0">
+                <a:solidFill>
+                  <a:srgbClr val="21295C"/>
+                </a:solidFill>
+                <a:latin typeface="Segoe UI" pitchFamily="34" charset="0"/>
+                <a:ea typeface="Segoe UI" pitchFamily="34" charset="-122"/>
+                <a:cs typeface="Segoe UI" pitchFamily="34" charset="-120"/>
+              </a:rPr>
+              <a:t> so </a:t>
+            </a:r>
+            <a:r>
+              <a:rPr lang="en-US" sz="940" b="1" dirty="0" err="1" smtClean="0">
+                <a:solidFill>
+                  <a:srgbClr val="21295C"/>
+                </a:solidFill>
+                <a:latin typeface="Segoe UI" pitchFamily="34" charset="0"/>
+                <a:ea typeface="Segoe UI" pitchFamily="34" charset="-122"/>
+                <a:cs typeface="Segoe UI" pitchFamily="34" charset="-120"/>
+              </a:rPr>
+              <a:t>sánh</a:t>
             </a:r>
             <a:endParaRPr lang="en-US" sz="940" dirty="0"/>
           </a:p>
@@ -11151,7 +11989,40 @@
                 <a:ea typeface="Segoe UI" pitchFamily="34" charset="-122"/>
                 <a:cs typeface="Segoe UI" pitchFamily="34" charset="-120"/>
               </a:rPr>
-              <a:t>Phân tích Biểu đồ Đa Chỉ số</a:t>
+              <a:t>Phân tích </a:t>
+            </a:r>
+            <a:r>
+              <a:rPr lang="en-US" sz="920" b="1" dirty="0" err="1">
+                <a:solidFill>
+                  <a:srgbClr val="21295C"/>
+                </a:solidFill>
+                <a:latin typeface="Segoe UI" pitchFamily="34" charset="0"/>
+                <a:ea typeface="Segoe UI" pitchFamily="34" charset="-122"/>
+                <a:cs typeface="Segoe UI" pitchFamily="34" charset="-120"/>
+              </a:rPr>
+              <a:t>Biểu</a:t>
+            </a:r>
+            <a:r>
+              <a:rPr lang="en-US" sz="920" b="1" dirty="0">
+                <a:solidFill>
+                  <a:srgbClr val="21295C"/>
+                </a:solidFill>
+                <a:latin typeface="Segoe UI" pitchFamily="34" charset="0"/>
+                <a:ea typeface="Segoe UI" pitchFamily="34" charset="-122"/>
+                <a:cs typeface="Segoe UI" pitchFamily="34" charset="-120"/>
+              </a:rPr>
+              <a:t> </a:t>
+            </a:r>
+            <a:r>
+              <a:rPr lang="en-US" sz="920" b="1" dirty="0" err="1" smtClean="0">
+                <a:solidFill>
+                  <a:srgbClr val="21295C"/>
+                </a:solidFill>
+                <a:latin typeface="Segoe UI" pitchFamily="34" charset="0"/>
+                <a:ea typeface="Segoe UI" pitchFamily="34" charset="-122"/>
+                <a:cs typeface="Segoe UI" pitchFamily="34" charset="-120"/>
+              </a:rPr>
+              <a:t>đồ</a:t>
             </a:r>
             <a:endParaRPr lang="en-US" sz="920" dirty="0"/>
           </a:p>
@@ -11234,13 +12105,13 @@
   <p:clrMapOvr>
     <a:masterClrMapping/>
   </p:clrMapOvr>
-  <mc:AlternateContent xmlns:mc="http://schemas.openxmlformats.org/markup-compatibility/2006">
-    <mc:Choice xmlns:p14="http://schemas.microsoft.com/office/powerpoint/2010/main" Requires="p14">
+  <mc:AlternateContent xmlns:mc="http://schemas.openxmlformats.org/markup-compatibility/2006" xmlns:p14="http://schemas.microsoft.com/office/powerpoint/2010/main">
+    <mc:Choice Requires="p14">
       <p:transition spd="slow" p14:dur="1300">
         <p14:pan dir="u"/>
       </p:transition>
     </mc:Choice>
-    <mc:Fallback>
+    <mc:Fallback xmlns="">
       <p:transition spd="slow">
         <p:fade/>
       </p:transition>
@@ -12037,13 +12908,13 @@
   <p:clrMapOvr>
     <a:masterClrMapping/>
   </p:clrMapOvr>
-  <mc:AlternateContent xmlns:mc="http://schemas.openxmlformats.org/markup-compatibility/2006">
-    <mc:Choice xmlns:p159="http://schemas.microsoft.com/office/powerpoint/2015/09/main" Requires="p159">
+  <mc:AlternateContent xmlns:mc="http://schemas.openxmlformats.org/markup-compatibility/2006" xmlns:p159="http://schemas.microsoft.com/office/powerpoint/2015/09/main">
+    <mc:Choice Requires="p159">
       <p:transition xmlns:p14="http://schemas.microsoft.com/office/powerpoint/2010/main" spd="slow" p14:dur="2000">
         <p159:morph option="byObject"/>
       </p:transition>
     </mc:Choice>
-    <mc:Fallback>
+    <mc:Fallback xmlns="">
       <p:transition spd="slow">
         <p:fade/>
       </p:transition>
@@ -13908,7 +14779,62 @@
                 <a:ea typeface="Segoe UI" pitchFamily="34" charset="-122"/>
                 <a:cs typeface="Segoe UI" pitchFamily="34" charset="-120"/>
               </a:rPr>
-              <a:t>Triệt tiêu nhiễu: Kỹ thuật đặc trưng miền biến bài toán phân lớp phi tuyến phức tạp thành ranh giới quyết định tuyến tính rõ rệt.</a:t>
+              <a:t>Triệt tiêu nhiễu: Kỹ thuật đặc </a:t>
+            </a:r>
+            <a:r>
+              <a:rPr lang="en-US" sz="830" dirty="0" err="1">
+                <a:solidFill>
+                  <a:srgbClr val="1F2937"/>
+                </a:solidFill>
+                <a:latin typeface="Segoe UI" pitchFamily="34" charset="0"/>
+                <a:ea typeface="Segoe UI" pitchFamily="34" charset="-122"/>
+                <a:cs typeface="Segoe UI" pitchFamily="34" charset="-120"/>
+              </a:rPr>
+              <a:t>trưng</a:t>
+            </a:r>
+            <a:r>
+              <a:rPr lang="en-US" sz="830" dirty="0">
+                <a:solidFill>
+                  <a:srgbClr val="1F2937"/>
+                </a:solidFill>
+                <a:latin typeface="Segoe UI" pitchFamily="34" charset="0"/>
+                <a:ea typeface="Segoe UI" pitchFamily="34" charset="-122"/>
+                <a:cs typeface="Segoe UI" pitchFamily="34" charset="-120"/>
+              </a:rPr>
+              <a:t> </a:t>
+            </a:r>
+            <a:r>
+              <a:rPr lang="en-US" sz="830" dirty="0" err="1" smtClean="0">
+                <a:solidFill>
+                  <a:srgbClr val="1F2937"/>
+                </a:solidFill>
+                <a:latin typeface="Segoe UI" pitchFamily="34" charset="0"/>
+                <a:ea typeface="Segoe UI" pitchFamily="34" charset="-122"/>
+                <a:cs typeface="Segoe UI" pitchFamily="34" charset="-120"/>
+              </a:rPr>
+              <a:t>biến</a:t>
+            </a:r>
+            <a:r>
+              <a:rPr lang="en-US" sz="830" dirty="0" smtClean="0">
+                <a:solidFill>
+                  <a:srgbClr val="1F2937"/>
+                </a:solidFill>
+                <a:latin typeface="Segoe UI" pitchFamily="34" charset="0"/>
+                <a:ea typeface="Segoe UI" pitchFamily="34" charset="-122"/>
+                <a:cs typeface="Segoe UI" pitchFamily="34" charset="-120"/>
+              </a:rPr>
+              <a:t> </a:t>
+            </a:r>
+            <a:r>
+              <a:rPr lang="en-US" sz="830" dirty="0">
+                <a:solidFill>
+                  <a:srgbClr val="1F2937"/>
+                </a:solidFill>
+                <a:latin typeface="Segoe UI" pitchFamily="34" charset="0"/>
+                <a:ea typeface="Segoe UI" pitchFamily="34" charset="-122"/>
+                <a:cs typeface="Segoe UI" pitchFamily="34" charset="-120"/>
+              </a:rPr>
+              <a:t>bài toán phân lớp phi tuyến phức tạp thành ranh giới quyết định tuyến tính rõ rệt.</a:t>
             </a:r>
             <a:endParaRPr lang="en-US" sz="830" dirty="0"/>
           </a:p>
@@ -13919,13 +14845,13 @@
   <p:clrMapOvr>
     <a:masterClrMapping/>
   </p:clrMapOvr>
-  <mc:AlternateContent xmlns:mc="http://schemas.openxmlformats.org/markup-compatibility/2006">
-    <mc:Choice xmlns:p159="http://schemas.microsoft.com/office/powerpoint/2015/09/main" Requires="p159">
+  <mc:AlternateContent xmlns:mc="http://schemas.openxmlformats.org/markup-compatibility/2006" xmlns:p159="http://schemas.microsoft.com/office/powerpoint/2015/09/main">
+    <mc:Choice Requires="p159">
       <p:transition xmlns:p14="http://schemas.microsoft.com/office/powerpoint/2010/main" spd="slow" p14:dur="2000">
         <p159:morph option="byObject"/>
       </p:transition>
     </mc:Choice>
-    <mc:Fallback>
+    <mc:Fallback xmlns="">
       <p:transition spd="slow">
         <p:fade/>
       </p:transition>
@@ -15937,13 +16863,13 @@
   <p:clrMapOvr>
     <a:masterClrMapping/>
   </p:clrMapOvr>
-  <mc:AlternateContent xmlns:mc="http://schemas.openxmlformats.org/markup-compatibility/2006">
-    <mc:Choice xmlns:p159="http://schemas.microsoft.com/office/powerpoint/2015/09/main" Requires="p159">
+  <mc:AlternateContent xmlns:mc="http://schemas.openxmlformats.org/markup-compatibility/2006" xmlns:p159="http://schemas.microsoft.com/office/powerpoint/2015/09/main">
+    <mc:Choice Requires="p159">
       <p:transition xmlns:p14="http://schemas.microsoft.com/office/powerpoint/2010/main" spd="slow" p14:dur="2000">
         <p159:morph option="byObject"/>
       </p:transition>
     </mc:Choice>
-    <mc:Fallback>
+    <mc:Fallback xmlns="">
       <p:transition spd="slow">
         <p:fade/>
       </p:transition>
@@ -16295,13 +17221,13 @@
   <p:clrMapOvr>
     <a:masterClrMapping/>
   </p:clrMapOvr>
-  <mc:AlternateContent xmlns:mc="http://schemas.openxmlformats.org/markup-compatibility/2006">
-    <mc:Choice xmlns:p14="http://schemas.microsoft.com/office/powerpoint/2010/main" Requires="p14">
+  <mc:AlternateContent xmlns:mc="http://schemas.openxmlformats.org/markup-compatibility/2006" xmlns:p14="http://schemas.microsoft.com/office/powerpoint/2010/main">
+    <mc:Choice Requires="p14">
       <p:transition spd="slow" p14:dur="1200">
         <p14:prism/>
       </p:transition>
     </mc:Choice>
-    <mc:Fallback>
+    <mc:Fallback xmlns="">
       <p:transition spd="slow">
         <p:fade/>
       </p:transition>
@@ -16738,12 +17664,28 @@
 </a:t>
             </a:r>
             <a:r>
+              <a:rPr lang="en-US" sz="1000" dirty="0" err="1" smtClean="0">
+                <a:solidFill>
+                  <a:srgbClr val="4B5563"/>
+                </a:solidFill>
+              </a:rPr>
+              <a:t>Phân</a:t>
+            </a:r>
+            <a:r>
+              <a:rPr lang="en-US" sz="1000" dirty="0" smtClean="0">
+                <a:solidFill>
+                  <a:srgbClr val="4B5563"/>
+                </a:solidFill>
+              </a:rPr>
+              <a:t> </a:t>
+            </a:r>
+            <a:r>
               <a:rPr lang="en-US" sz="1000" dirty="0">
                 <a:solidFill>
                   <a:srgbClr val="4B5563"/>
                 </a:solidFill>
               </a:rPr>
-              <a:t>Khu biệt loại giao dịch, dấu vết rút cạn số dư và 14 engineered features.</a:t>
+              <a:t>biệt loại giao dịch, dấu vết rút cạn số dư và 14 engineered features.</a:t>
             </a:r>
             <a:endParaRPr lang="en-US" sz="1250" dirty="0"/>
           </a:p>
@@ -16856,7 +17798,23 @@
                   <a:srgbClr val="4B5563"/>
                 </a:solidFill>
               </a:rPr>
-              <a:t>Quy chuẩn Leak-Free, Random Forest vs. XGBoost và Deep Autoencoder.</a:t>
+              <a:t>Quy chuẩn Leak-Free, Random </a:t>
+            </a:r>
+            <a:r>
+              <a:rPr lang="en-US" sz="1000" dirty="0" smtClean="0">
+                <a:solidFill>
+                  <a:srgbClr val="4B5563"/>
+                </a:solidFill>
+              </a:rPr>
+              <a:t>Forest, </a:t>
+            </a:r>
+            <a:r>
+              <a:rPr lang="en-US" sz="1000" dirty="0">
+                <a:solidFill>
+                  <a:srgbClr val="4B5563"/>
+                </a:solidFill>
+              </a:rPr>
+              <a:t>XGBoost và Deep Autoencoder.</a:t>
             </a:r>
             <a:endParaRPr lang="en-US" sz="1250" dirty="0"/>
           </a:p>
@@ -17073,7 +18031,63 @@
                   <a:srgbClr val="21295C"/>
                 </a:solidFill>
               </a:rPr>
-              <a:t>Hệ thống Demo &amp; Định hướng Tương lai
+              <a:t>Hệ thống Demo &amp; Định </a:t>
+            </a:r>
+            <a:r>
+              <a:rPr lang="en-US" sz="1250" b="1" dirty="0" err="1">
+                <a:solidFill>
+                  <a:srgbClr val="21295C"/>
+                </a:solidFill>
+              </a:rPr>
+              <a:t>hướng</a:t>
+            </a:r>
+            <a:r>
+              <a:rPr lang="en-US" sz="1250" b="1" dirty="0">
+                <a:solidFill>
+                  <a:srgbClr val="21295C"/>
+                </a:solidFill>
+              </a:rPr>
+              <a:t> </a:t>
+            </a:r>
+            <a:r>
+              <a:rPr lang="en-US" sz="1250" b="1" dirty="0" err="1">
+                <a:solidFill>
+                  <a:srgbClr val="21295C"/>
+                </a:solidFill>
+              </a:rPr>
+              <a:t>p</a:t>
+            </a:r>
+            <a:r>
+              <a:rPr lang="en-US" sz="1250" b="1" dirty="0" err="1" smtClean="0">
+                <a:solidFill>
+                  <a:srgbClr val="21295C"/>
+                </a:solidFill>
+              </a:rPr>
+              <a:t>hát</a:t>
+            </a:r>
+            <a:r>
+              <a:rPr lang="en-US" sz="1250" b="1" dirty="0" smtClean="0">
+                <a:solidFill>
+                  <a:srgbClr val="21295C"/>
+                </a:solidFill>
+              </a:rPr>
+              <a:t> </a:t>
+            </a:r>
+            <a:r>
+              <a:rPr lang="en-US" sz="1250" b="1" dirty="0" err="1" smtClean="0">
+                <a:solidFill>
+                  <a:srgbClr val="21295C"/>
+                </a:solidFill>
+              </a:rPr>
+              <a:t>triển</a:t>
+            </a:r>
+            <a:r>
+              <a:rPr lang="en-US" sz="1250" b="1" dirty="0">
+                <a:solidFill>
+                  <a:srgbClr val="21295C"/>
+                </a:solidFill>
+              </a:rPr>
+              <a:t>
 </a:t>
             </a:r>
             <a:r>
@@ -17198,7 +18212,62 @@
                 <a:ea typeface="Segoe UI" pitchFamily="34" charset="-122"/>
                 <a:cs typeface="Segoe UI" pitchFamily="34" charset="-120"/>
               </a:rPr>
-              <a:t>Hệ thống Demo Streamlit &amp; Lộ trình Nghiên cứu Tương lai</a:t>
+              <a:t>Hệ thống Demo Streamlit &amp; </a:t>
+            </a:r>
+            <a:r>
+              <a:rPr lang="en-US" sz="1900" b="1" dirty="0" err="1" smtClean="0">
+                <a:solidFill>
+                  <a:srgbClr val="21295C"/>
+                </a:solidFill>
+                <a:latin typeface="Segoe UI" pitchFamily="34" charset="0"/>
+                <a:ea typeface="Segoe UI" pitchFamily="34" charset="-122"/>
+                <a:cs typeface="Segoe UI" pitchFamily="34" charset="-120"/>
+              </a:rPr>
+              <a:t>Hướng</a:t>
+            </a:r>
+            <a:r>
+              <a:rPr lang="en-US" sz="1900" b="1" dirty="0" smtClean="0">
+                <a:solidFill>
+                  <a:srgbClr val="21295C"/>
+                </a:solidFill>
+                <a:latin typeface="Segoe UI" pitchFamily="34" charset="0"/>
+                <a:ea typeface="Segoe UI" pitchFamily="34" charset="-122"/>
+                <a:cs typeface="Segoe UI" pitchFamily="34" charset="-120"/>
+              </a:rPr>
+              <a:t> </a:t>
+            </a:r>
+            <a:r>
+              <a:rPr lang="en-US" sz="1900" b="1" dirty="0" err="1" smtClean="0">
+                <a:solidFill>
+                  <a:srgbClr val="21295C"/>
+                </a:solidFill>
+                <a:latin typeface="Segoe UI" pitchFamily="34" charset="0"/>
+                <a:ea typeface="Segoe UI" pitchFamily="34" charset="-122"/>
+                <a:cs typeface="Segoe UI" pitchFamily="34" charset="-120"/>
+              </a:rPr>
+              <a:t>phát</a:t>
+            </a:r>
+            <a:r>
+              <a:rPr lang="en-US" sz="1900" b="1" dirty="0" smtClean="0">
+                <a:solidFill>
+                  <a:srgbClr val="21295C"/>
+                </a:solidFill>
+                <a:latin typeface="Segoe UI" pitchFamily="34" charset="0"/>
+                <a:ea typeface="Segoe UI" pitchFamily="34" charset="-122"/>
+                <a:cs typeface="Segoe UI" pitchFamily="34" charset="-120"/>
+              </a:rPr>
+              <a:t> </a:t>
+            </a:r>
+            <a:r>
+              <a:rPr lang="en-US" sz="1900" b="1" dirty="0" err="1" smtClean="0">
+                <a:solidFill>
+                  <a:srgbClr val="21295C"/>
+                </a:solidFill>
+                <a:latin typeface="Segoe UI" pitchFamily="34" charset="0"/>
+                <a:ea typeface="Segoe UI" pitchFamily="34" charset="-122"/>
+                <a:cs typeface="Segoe UI" pitchFamily="34" charset="-120"/>
+              </a:rPr>
+              <a:t>triển</a:t>
             </a:r>
             <a:endParaRPr lang="en-US" sz="1900" dirty="0"/>
           </a:p>
@@ -17815,7 +18884,7 @@
         </p:spPr>
         <p:txBody>
           <a:bodyPr wrap="square" lIns="25400" tIns="50800" rIns="50800" bIns="25400" rtlCol="0" anchor="ctr">
-            <a:normAutofit/>
+            <a:normAutofit lnSpcReduction="10000"/>
           </a:bodyPr>
           <a:lstStyle/>
           <a:p>
@@ -17973,15 +19042,54 @@
               <a:buNone/>
             </a:pPr>
             <a:r>
-              <a:rPr lang="en-US" sz="920" b="1" dirty="0">
+              <a:rPr lang="en-US" sz="920" b="1" dirty="0" err="1" smtClean="0">
                 <a:solidFill>
                   <a:srgbClr val="21295C"/>
                 </a:solidFill>
                 <a:latin typeface="Segoe UI" pitchFamily="34" charset="0"/>
-                <a:ea typeface="Segoe UI" pitchFamily="34" charset="-122"/>
                 <a:cs typeface="Segoe UI" pitchFamily="34" charset="-120"/>
               </a:rPr>
-              <a:t>Lộ trình Nghiên cứu Tương lai</a:t>
+              <a:t>Hướng</a:t>
+            </a:r>
+            <a:r>
+              <a:rPr lang="en-US" sz="920" b="1" dirty="0" smtClean="0">
+                <a:solidFill>
+                  <a:srgbClr val="21295C"/>
+                </a:solidFill>
+                <a:latin typeface="Segoe UI" pitchFamily="34" charset="0"/>
+                <a:cs typeface="Segoe UI" pitchFamily="34" charset="-120"/>
+              </a:rPr>
+              <a:t> </a:t>
+            </a:r>
+            <a:r>
+              <a:rPr lang="en-US" sz="920" b="1" dirty="0" err="1" smtClean="0">
+                <a:solidFill>
+                  <a:srgbClr val="21295C"/>
+                </a:solidFill>
+                <a:latin typeface="Segoe UI" pitchFamily="34" charset="0"/>
+                <a:cs typeface="Segoe UI" pitchFamily="34" charset="-120"/>
+              </a:rPr>
+              <a:t>phát</a:t>
+            </a:r>
+            <a:r>
+              <a:rPr lang="en-US" sz="920" b="1" dirty="0" smtClean="0">
+                <a:solidFill>
+                  <a:srgbClr val="21295C"/>
+                </a:solidFill>
+                <a:latin typeface="Segoe UI" pitchFamily="34" charset="0"/>
+                <a:cs typeface="Segoe UI" pitchFamily="34" charset="-120"/>
+              </a:rPr>
+              <a:t> </a:t>
+            </a:r>
+            <a:r>
+              <a:rPr lang="en-US" sz="920" b="1" dirty="0" err="1" smtClean="0">
+                <a:solidFill>
+                  <a:srgbClr val="21295C"/>
+                </a:solidFill>
+                <a:latin typeface="Segoe UI" pitchFamily="34" charset="0"/>
+                <a:cs typeface="Segoe UI" pitchFamily="34" charset="-120"/>
+              </a:rPr>
+              <a:t>triển</a:t>
             </a:r>
             <a:endParaRPr lang="en-US" sz="920" dirty="0"/>
           </a:p>
@@ -18088,13 +19196,13 @@
   <p:clrMapOvr>
     <a:masterClrMapping/>
   </p:clrMapOvr>
-  <mc:AlternateContent xmlns:mc="http://schemas.openxmlformats.org/markup-compatibility/2006">
-    <mc:Choice xmlns:p14="http://schemas.microsoft.com/office/powerpoint/2010/main" Requires="p14">
+  <mc:AlternateContent xmlns:mc="http://schemas.openxmlformats.org/markup-compatibility/2006" xmlns:p14="http://schemas.microsoft.com/office/powerpoint/2010/main">
+    <mc:Choice Requires="p14">
       <p:transition spd="slow" p14:dur="1300">
         <p14:pan dir="u"/>
       </p:transition>
     </mc:Choice>
-    <mc:Fallback>
+    <mc:Fallback xmlns="">
       <p:transition spd="slow">
         <p:fade/>
       </p:transition>
@@ -18482,7 +19590,139 @@
                 <a:ea typeface="Segoe UI" pitchFamily="34" charset="-122"/>
                 <a:cs typeface="Segoe UI" pitchFamily="34" charset="-120"/>
               </a:rPr>
-              <a:t> 09 rất mong nhận được những câu hỏi và góp ý quý báu từ Hội đồng!</a:t>
+              <a:t> 09 rất mong nhận được những câu hỏi và góp ý quý </a:t>
+            </a:r>
+            <a:r>
+              <a:rPr lang="en-US" sz="930" i="1" dirty="0" err="1">
+                <a:solidFill>
+                  <a:srgbClr val="FCD34D"/>
+                </a:solidFill>
+                <a:latin typeface="Segoe UI" pitchFamily="34" charset="0"/>
+                <a:ea typeface="Segoe UI" pitchFamily="34" charset="-122"/>
+                <a:cs typeface="Segoe UI" pitchFamily="34" charset="-120"/>
+              </a:rPr>
+              <a:t>báu</a:t>
+            </a:r>
+            <a:r>
+              <a:rPr lang="en-US" sz="930" i="1" dirty="0">
+                <a:solidFill>
+                  <a:srgbClr val="FCD34D"/>
+                </a:solidFill>
+                <a:latin typeface="Segoe UI" pitchFamily="34" charset="0"/>
+                <a:ea typeface="Segoe UI" pitchFamily="34" charset="-122"/>
+                <a:cs typeface="Segoe UI" pitchFamily="34" charset="-120"/>
+              </a:rPr>
+              <a:t> </a:t>
+            </a:r>
+            <a:r>
+              <a:rPr lang="en-US" sz="930" i="1" dirty="0" err="1" smtClean="0">
+                <a:solidFill>
+                  <a:srgbClr val="FCD34D"/>
+                </a:solidFill>
+                <a:latin typeface="Segoe UI" pitchFamily="34" charset="0"/>
+                <a:ea typeface="Segoe UI" pitchFamily="34" charset="-122"/>
+                <a:cs typeface="Segoe UI" pitchFamily="34" charset="-120"/>
+              </a:rPr>
+              <a:t>từ</a:t>
+            </a:r>
+            <a:r>
+              <a:rPr lang="en-US" sz="930" i="1" dirty="0">
+                <a:solidFill>
+                  <a:srgbClr val="FCD34D"/>
+                </a:solidFill>
+                <a:latin typeface="Segoe UI" pitchFamily="34" charset="0"/>
+                <a:ea typeface="Segoe UI" pitchFamily="34" charset="-122"/>
+                <a:cs typeface="Segoe UI" pitchFamily="34" charset="-120"/>
+              </a:rPr>
+              <a:t> </a:t>
+            </a:r>
+            <a:r>
+              <a:rPr lang="en-US" sz="930" i="1" dirty="0" err="1" smtClean="0">
+                <a:solidFill>
+                  <a:srgbClr val="FCD34D"/>
+                </a:solidFill>
+                <a:latin typeface="Segoe UI" pitchFamily="34" charset="0"/>
+                <a:ea typeface="Segoe UI" pitchFamily="34" charset="-122"/>
+                <a:cs typeface="Segoe UI" pitchFamily="34" charset="-120"/>
+              </a:rPr>
+              <a:t>Thầy</a:t>
+            </a:r>
+            <a:r>
+              <a:rPr lang="en-US" sz="930" i="1" dirty="0" smtClean="0">
+                <a:solidFill>
+                  <a:srgbClr val="FCD34D"/>
+                </a:solidFill>
+                <a:latin typeface="Segoe UI" pitchFamily="34" charset="0"/>
+                <a:ea typeface="Segoe UI" pitchFamily="34" charset="-122"/>
+                <a:cs typeface="Segoe UI" pitchFamily="34" charset="-120"/>
+              </a:rPr>
+              <a:t> </a:t>
+            </a:r>
+            <a:r>
+              <a:rPr lang="en-US" sz="930" i="1" dirty="0" err="1" smtClean="0">
+                <a:solidFill>
+                  <a:srgbClr val="FCD34D"/>
+                </a:solidFill>
+                <a:latin typeface="Segoe UI" pitchFamily="34" charset="0"/>
+                <a:ea typeface="Segoe UI" pitchFamily="34" charset="-122"/>
+                <a:cs typeface="Segoe UI" pitchFamily="34" charset="-120"/>
+              </a:rPr>
+              <a:t>và</a:t>
+            </a:r>
+            <a:r>
+              <a:rPr lang="en-US" sz="930" i="1" dirty="0" smtClean="0">
+                <a:solidFill>
+                  <a:srgbClr val="FCD34D"/>
+                </a:solidFill>
+                <a:latin typeface="Segoe UI" pitchFamily="34" charset="0"/>
+                <a:ea typeface="Segoe UI" pitchFamily="34" charset="-122"/>
+                <a:cs typeface="Segoe UI" pitchFamily="34" charset="-120"/>
+              </a:rPr>
+              <a:t> </a:t>
+            </a:r>
+            <a:r>
+              <a:rPr lang="en-US" sz="930" i="1" dirty="0" err="1" smtClean="0">
+                <a:solidFill>
+                  <a:srgbClr val="FCD34D"/>
+                </a:solidFill>
+                <a:latin typeface="Segoe UI" pitchFamily="34" charset="0"/>
+                <a:ea typeface="Segoe UI" pitchFamily="34" charset="-122"/>
+                <a:cs typeface="Segoe UI" pitchFamily="34" charset="-120"/>
+              </a:rPr>
+              <a:t>các</a:t>
+            </a:r>
+            <a:r>
+              <a:rPr lang="en-US" sz="930" i="1" dirty="0" smtClean="0">
+                <a:solidFill>
+                  <a:srgbClr val="FCD34D"/>
+                </a:solidFill>
+                <a:latin typeface="Segoe UI" pitchFamily="34" charset="0"/>
+                <a:ea typeface="Segoe UI" pitchFamily="34" charset="-122"/>
+                <a:cs typeface="Segoe UI" pitchFamily="34" charset="-120"/>
+              </a:rPr>
+              <a:t> </a:t>
+            </a:r>
+            <a:r>
+              <a:rPr lang="en-US" sz="930" i="1" smtClean="0">
+                <a:solidFill>
+                  <a:srgbClr val="FCD34D"/>
+                </a:solidFill>
+                <a:latin typeface="Segoe UI" pitchFamily="34" charset="0"/>
+                <a:ea typeface="Segoe UI" pitchFamily="34" charset="-122"/>
+                <a:cs typeface="Segoe UI" pitchFamily="34" charset="-120"/>
+              </a:rPr>
+              <a:t>bạn</a:t>
+            </a:r>
+            <a:r>
+              <a:rPr lang="en-US" sz="930" i="1" smtClean="0">
+                <a:solidFill>
+                  <a:srgbClr val="FCD34D"/>
+                </a:solidFill>
+                <a:latin typeface="Segoe UI" pitchFamily="34" charset="0"/>
+                <a:ea typeface="Segoe UI" pitchFamily="34" charset="-122"/>
+                <a:cs typeface="Segoe UI" pitchFamily="34" charset="-120"/>
+              </a:rPr>
+              <a:t>!</a:t>
             </a:r>
             <a:endParaRPr lang="en-US" sz="930" dirty="0"/>
           </a:p>
@@ -18493,13 +19733,13 @@
   <p:clrMapOvr>
     <a:masterClrMapping/>
   </p:clrMapOvr>
-  <mc:AlternateContent xmlns:mc="http://schemas.openxmlformats.org/markup-compatibility/2006">
-    <mc:Choice xmlns:p15="http://schemas.microsoft.com/office/powerpoint/2012/main" Requires="p15">
+  <mc:AlternateContent xmlns:mc="http://schemas.openxmlformats.org/markup-compatibility/2006" xmlns:p15="http://schemas.microsoft.com/office/powerpoint/2012/main">
+    <mc:Choice Requires="p15">
       <p:transition xmlns:p14="http://schemas.microsoft.com/office/powerpoint/2010/main" spd="slow" p14:dur="1250">
         <p15:prstTrans prst="airplane"/>
       </p:transition>
     </mc:Choice>
-    <mc:Fallback>
+    <mc:Fallback xmlns="">
       <p:transition spd="slow">
         <p:fade/>
       </p:transition>
@@ -18851,13 +20091,13 @@
   <p:clrMapOvr>
     <a:masterClrMapping/>
   </p:clrMapOvr>
-  <mc:AlternateContent xmlns:mc="http://schemas.openxmlformats.org/markup-compatibility/2006">
-    <mc:Choice xmlns:p14="http://schemas.microsoft.com/office/powerpoint/2010/main" Requires="p14">
+  <mc:AlternateContent xmlns:mc="http://schemas.openxmlformats.org/markup-compatibility/2006" xmlns:p14="http://schemas.microsoft.com/office/powerpoint/2010/main">
+    <mc:Choice Requires="p14">
       <p:transition spd="slow" p14:dur="1200">
         <p14:prism/>
       </p:transition>
     </mc:Choice>
-    <mc:Fallback>
+    <mc:Fallback xmlns="">
       <p:transition spd="slow">
         <p:fade/>
       </p:transition>
@@ -20429,7 +21669,7 @@
         </p:spPr>
         <p:txBody>
           <a:bodyPr wrap="square" lIns="25400" tIns="50800" rIns="50800" bIns="25400" rtlCol="0" anchor="ctr">
-            <a:normAutofit fontScale="92500" lnSpcReduction="20000"/>
+            <a:normAutofit fontScale="92500" lnSpcReduction="10000"/>
           </a:bodyPr>
           <a:lstStyle/>
           <a:p>
@@ -20476,7 +21716,95 @@
                 <a:ea typeface="Segoe UI" pitchFamily="34" charset="-122"/>
                 <a:cs typeface="Segoe UI" pitchFamily="34" charset="-120"/>
               </a:rPr>
-              <a:t>Thiết kế 14 domain features bắt trọn sai lệch số dư sổ cái.</a:t>
+              <a:t>Thiết kế 14 </a:t>
+            </a:r>
+            <a:r>
+              <a:rPr lang="en-US" sz="950" dirty="0" smtClean="0">
+                <a:solidFill>
+                  <a:srgbClr val="1F2937"/>
+                </a:solidFill>
+                <a:latin typeface="Segoe UI" pitchFamily="34" charset="0"/>
+                <a:ea typeface="Segoe UI" pitchFamily="34" charset="-122"/>
+                <a:cs typeface="Segoe UI" pitchFamily="34" charset="-120"/>
+              </a:rPr>
+              <a:t>features </a:t>
+            </a:r>
+            <a:r>
+              <a:rPr lang="en-US" sz="950" dirty="0">
+                <a:solidFill>
+                  <a:srgbClr val="1F2937"/>
+                </a:solidFill>
+                <a:latin typeface="Segoe UI" pitchFamily="34" charset="0"/>
+                <a:ea typeface="Segoe UI" pitchFamily="34" charset="-122"/>
+                <a:cs typeface="Segoe UI" pitchFamily="34" charset="-120"/>
+              </a:rPr>
+              <a:t>bắt trọn sai lệch số </a:t>
+            </a:r>
+            <a:r>
+              <a:rPr lang="en-US" sz="950" dirty="0" err="1">
+                <a:solidFill>
+                  <a:srgbClr val="1F2937"/>
+                </a:solidFill>
+                <a:latin typeface="Segoe UI" pitchFamily="34" charset="0"/>
+                <a:ea typeface="Segoe UI" pitchFamily="34" charset="-122"/>
+                <a:cs typeface="Segoe UI" pitchFamily="34" charset="-120"/>
+              </a:rPr>
+              <a:t>dư</a:t>
+            </a:r>
+            <a:r>
+              <a:rPr lang="en-US" sz="950" dirty="0">
+                <a:solidFill>
+                  <a:srgbClr val="1F2937"/>
+                </a:solidFill>
+                <a:latin typeface="Segoe UI" pitchFamily="34" charset="0"/>
+                <a:ea typeface="Segoe UI" pitchFamily="34" charset="-122"/>
+                <a:cs typeface="Segoe UI" pitchFamily="34" charset="-120"/>
+              </a:rPr>
+              <a:t> </a:t>
+            </a:r>
+            <a:r>
+              <a:rPr lang="en-US" sz="950" dirty="0" err="1" smtClean="0">
+                <a:solidFill>
+                  <a:srgbClr val="1F2937"/>
+                </a:solidFill>
+                <a:latin typeface="Segoe UI" pitchFamily="34" charset="0"/>
+                <a:ea typeface="Segoe UI" pitchFamily="34" charset="-122"/>
+                <a:cs typeface="Segoe UI" pitchFamily="34" charset="-120"/>
+              </a:rPr>
+              <a:t>tài</a:t>
+            </a:r>
+            <a:r>
+              <a:rPr lang="en-US" sz="950" dirty="0" smtClean="0">
+                <a:solidFill>
+                  <a:srgbClr val="1F2937"/>
+                </a:solidFill>
+                <a:latin typeface="Segoe UI" pitchFamily="34" charset="0"/>
+                <a:ea typeface="Segoe UI" pitchFamily="34" charset="-122"/>
+                <a:cs typeface="Segoe UI" pitchFamily="34" charset="-120"/>
+              </a:rPr>
+              <a:t> </a:t>
+            </a:r>
+            <a:r>
+              <a:rPr lang="en-US" sz="950" dirty="0" err="1" smtClean="0">
+                <a:solidFill>
+                  <a:srgbClr val="1F2937"/>
+                </a:solidFill>
+                <a:latin typeface="Segoe UI" pitchFamily="34" charset="0"/>
+                <a:ea typeface="Segoe UI" pitchFamily="34" charset="-122"/>
+                <a:cs typeface="Segoe UI" pitchFamily="34" charset="-120"/>
+              </a:rPr>
+              <a:t>khoản</a:t>
+            </a:r>
+            <a:r>
+              <a:rPr lang="en-US" sz="950" dirty="0" smtClean="0">
+                <a:solidFill>
+                  <a:srgbClr val="1F2937"/>
+                </a:solidFill>
+                <a:latin typeface="Segoe UI" pitchFamily="34" charset="0"/>
+                <a:ea typeface="Segoe UI" pitchFamily="34" charset="-122"/>
+                <a:cs typeface="Segoe UI" pitchFamily="34" charset="-120"/>
+              </a:rPr>
+              <a:t>.</a:t>
             </a:r>
             <a:endParaRPr lang="en-US" sz="950" dirty="0"/>
           </a:p>
@@ -20492,7 +21820,7 @@
               <a:buChar char="•"/>
             </a:pPr>
             <a:r>
-              <a:rPr lang="en-US" sz="950" dirty="0">
+              <a:rPr lang="en-US" sz="950" dirty="0" smtClean="0">
                 <a:solidFill>
                   <a:srgbClr val="1F2937"/>
                 </a:solidFill>
@@ -20500,7 +21828,40 @@
                 <a:ea typeface="Segoe UI" pitchFamily="34" charset="-122"/>
                 <a:cs typeface="Segoe UI" pitchFamily="34" charset="-120"/>
               </a:rPr>
-              <a:t>Đối chuẩn Ensemble Trees với Unsupervised Deep Autoencoder bắt Zero-Day.</a:t>
+              <a:t>So </a:t>
+            </a:r>
+            <a:r>
+              <a:rPr lang="en-US" sz="950" dirty="0" err="1" smtClean="0">
+                <a:solidFill>
+                  <a:srgbClr val="1F2937"/>
+                </a:solidFill>
+                <a:latin typeface="Segoe UI" pitchFamily="34" charset="0"/>
+                <a:ea typeface="Segoe UI" pitchFamily="34" charset="-122"/>
+                <a:cs typeface="Segoe UI" pitchFamily="34" charset="-120"/>
+              </a:rPr>
+              <a:t>sánh</a:t>
+            </a:r>
+            <a:r>
+              <a:rPr lang="en-US" sz="950" dirty="0" smtClean="0">
+                <a:solidFill>
+                  <a:srgbClr val="1F2937"/>
+                </a:solidFill>
+                <a:latin typeface="Segoe UI" pitchFamily="34" charset="0"/>
+                <a:ea typeface="Segoe UI" pitchFamily="34" charset="-122"/>
+                <a:cs typeface="Segoe UI" pitchFamily="34" charset="-120"/>
+              </a:rPr>
+              <a:t> </a:t>
+            </a:r>
+            <a:r>
+              <a:rPr lang="en-US" sz="950" dirty="0">
+                <a:solidFill>
+                  <a:srgbClr val="1F2937"/>
+                </a:solidFill>
+                <a:latin typeface="Segoe UI" pitchFamily="34" charset="0"/>
+                <a:ea typeface="Segoe UI" pitchFamily="34" charset="-122"/>
+                <a:cs typeface="Segoe UI" pitchFamily="34" charset="-120"/>
+              </a:rPr>
+              <a:t>Ensemble Trees với Unsupervised Deep Autoencoder bắt Zero-Day.</a:t>
             </a:r>
             <a:endParaRPr lang="en-US" sz="950" dirty="0"/>
           </a:p>
@@ -20535,13 +21896,13 @@
   <p:clrMapOvr>
     <a:masterClrMapping/>
   </p:clrMapOvr>
-  <mc:AlternateContent xmlns:mc="http://schemas.openxmlformats.org/markup-compatibility/2006">
-    <mc:Choice xmlns:p14="http://schemas.microsoft.com/office/powerpoint/2010/main" Requires="p14">
+  <mc:AlternateContent xmlns:mc="http://schemas.openxmlformats.org/markup-compatibility/2006" xmlns:p14="http://schemas.microsoft.com/office/powerpoint/2010/main">
+    <mc:Choice Requires="p14">
       <p:transition spd="slow" p14:dur="1300">
         <p14:pan dir="u"/>
       </p:transition>
     </mc:Choice>
-    <mc:Fallback>
+    <mc:Fallback xmlns="">
       <p:transition spd="slow">
         <p:fade/>
       </p:transition>
@@ -21141,7 +22502,31 @@
                   <a:srgbClr val="2563EB"/>
                 </a:solidFill>
               </a:rPr>
-              <a:t>11 → 14 Đặc trưng Miền</a:t>
+              <a:t>11 → 14 </a:t>
+            </a:r>
+            <a:r>
+              <a:rPr lang="en-US" sz="1350" b="1" dirty="0" err="1">
+                <a:solidFill>
+                  <a:srgbClr val="2563EB"/>
+                </a:solidFill>
+              </a:rPr>
+              <a:t>Đặc</a:t>
+            </a:r>
+            <a:r>
+              <a:rPr lang="en-US" sz="1350" b="1" dirty="0">
+                <a:solidFill>
+                  <a:srgbClr val="2563EB"/>
+                </a:solidFill>
+              </a:rPr>
+              <a:t> </a:t>
+            </a:r>
+            <a:r>
+              <a:rPr lang="en-US" sz="1350" b="1" dirty="0" err="1" smtClean="0">
+                <a:solidFill>
+                  <a:srgbClr val="2563EB"/>
+                </a:solidFill>
+              </a:rPr>
+              <a:t>trưng</a:t>
             </a:r>
             <a:endParaRPr lang="en-US" sz="1350" dirty="0"/>
           </a:p>
@@ -22618,13 +24003,13 @@
   <p:clrMapOvr>
     <a:masterClrMapping/>
   </p:clrMapOvr>
-  <mc:AlternateContent xmlns:mc="http://schemas.openxmlformats.org/markup-compatibility/2006">
-    <mc:Choice xmlns:p159="http://schemas.microsoft.com/office/powerpoint/2015/09/main" Requires="p159">
+  <mc:AlternateContent xmlns:mc="http://schemas.openxmlformats.org/markup-compatibility/2006" xmlns:p159="http://schemas.microsoft.com/office/powerpoint/2015/09/main">
+    <mc:Choice Requires="p159">
       <p:transition xmlns:p14="http://schemas.microsoft.com/office/powerpoint/2010/main" spd="slow" p14:dur="2000">
         <p159:morph option="byObject"/>
       </p:transition>
     </mc:Choice>
-    <mc:Fallback>
+    <mc:Fallback xmlns="">
       <p:transition spd="slow">
         <p:fade/>
       </p:transition>
@@ -22941,7 +24326,18 @@
                 <a:ea typeface="Segoe UI" pitchFamily="34" charset="-122"/>
                 <a:cs typeface="Segoe UI" pitchFamily="34" charset="-120"/>
               </a:rPr>
-              <a:t>Công thức Toán học của 14 Engineered Domain Features</a:t>
+              <a:t>Công thức Toán học của 14 Engineered </a:t>
+            </a:r>
+            <a:r>
+              <a:rPr lang="en-US" sz="1100" dirty="0" smtClean="0">
+                <a:solidFill>
+                  <a:srgbClr val="E2E8F0"/>
+                </a:solidFill>
+                <a:latin typeface="Segoe UI" pitchFamily="34" charset="0"/>
+                <a:ea typeface="Segoe UI" pitchFamily="34" charset="-122"/>
+                <a:cs typeface="Segoe UI" pitchFamily="34" charset="-120"/>
+              </a:rPr>
+              <a:t>Features</a:t>
             </a:r>
             <a:endParaRPr lang="en-US" sz="1100" dirty="0"/>
           </a:p>
@@ -22976,13 +24372,13 @@
   <p:clrMapOvr>
     <a:masterClrMapping/>
   </p:clrMapOvr>
-  <mc:AlternateContent xmlns:mc="http://schemas.openxmlformats.org/markup-compatibility/2006">
-    <mc:Choice xmlns:p14="http://schemas.microsoft.com/office/powerpoint/2010/main" Requires="p14">
+  <mc:AlternateContent xmlns:mc="http://schemas.openxmlformats.org/markup-compatibility/2006" xmlns:p14="http://schemas.microsoft.com/office/powerpoint/2010/main">
+    <mc:Choice Requires="p14">
       <p:transition spd="slow" p14:dur="1200">
         <p14:prism/>
       </p:transition>
     </mc:Choice>
-    <mc:Fallback>
+    <mc:Fallback xmlns="">
       <p:transition spd="slow">
         <p:fade/>
       </p:transition>
@@ -23329,7 +24725,63 @@
                   <a:srgbClr val="21295C"/>
                 </a:solidFill>
               </a:rPr>
-              <a:t>Phát hiện 1: Khu biệt Loại Giao dịch</a:t>
+              <a:t>Phát hiện 1: </a:t>
+            </a:r>
+            <a:r>
+              <a:rPr lang="en-US" sz="1100" b="1" dirty="0" err="1" smtClean="0">
+                <a:solidFill>
+                  <a:srgbClr val="21295C"/>
+                </a:solidFill>
+              </a:rPr>
+              <a:t>Khoanh</a:t>
+            </a:r>
+            <a:r>
+              <a:rPr lang="en-US" sz="1100" b="1" dirty="0" smtClean="0">
+                <a:solidFill>
+                  <a:srgbClr val="21295C"/>
+                </a:solidFill>
+              </a:rPr>
+              <a:t> </a:t>
+            </a:r>
+            <a:r>
+              <a:rPr lang="en-US" sz="1100" b="1" dirty="0" err="1" smtClean="0">
+                <a:solidFill>
+                  <a:srgbClr val="21295C"/>
+                </a:solidFill>
+              </a:rPr>
+              <a:t>vùng</a:t>
+            </a:r>
+            <a:r>
+              <a:rPr lang="en-US" sz="1100" b="1" dirty="0" smtClean="0">
+                <a:solidFill>
+                  <a:srgbClr val="21295C"/>
+                </a:solidFill>
+              </a:rPr>
+              <a:t> </a:t>
+            </a:r>
+            <a:r>
+              <a:rPr lang="en-US" sz="1100" b="1" dirty="0" err="1" smtClean="0">
+                <a:solidFill>
+                  <a:srgbClr val="21295C"/>
+                </a:solidFill>
+              </a:rPr>
+              <a:t>Loại</a:t>
+            </a:r>
+            <a:r>
+              <a:rPr lang="en-US" sz="1100" b="1" dirty="0" smtClean="0">
+                <a:solidFill>
+                  <a:srgbClr val="21295C"/>
+                </a:solidFill>
+              </a:rPr>
+              <a:t> </a:t>
+            </a:r>
+            <a:r>
+              <a:rPr lang="en-US" sz="1100" b="1" dirty="0">
+                <a:solidFill>
+                  <a:srgbClr val="21295C"/>
+                </a:solidFill>
+              </a:rPr>
+              <a:t>Giao dịch</a:t>
             </a:r>
             <a:endParaRPr lang="en-US" sz="1100" dirty="0"/>
           </a:p>
@@ -23741,7 +25193,63 @@
                   <a:srgbClr val="21295C"/>
                 </a:solidFill>
               </a:rPr>
-              <a:t>Phát hiện 3: Sai Lệch Sổ Cái Đích</a:t>
+              <a:t>Phát hiện 3: Sai </a:t>
+            </a:r>
+            <a:r>
+              <a:rPr lang="en-US" sz="1100" b="1" dirty="0" err="1">
+                <a:solidFill>
+                  <a:srgbClr val="21295C"/>
+                </a:solidFill>
+              </a:rPr>
+              <a:t>Lệch</a:t>
+            </a:r>
+            <a:r>
+              <a:rPr lang="en-US" sz="1100" b="1" dirty="0">
+                <a:solidFill>
+                  <a:srgbClr val="21295C"/>
+                </a:solidFill>
+              </a:rPr>
+              <a:t> </a:t>
+            </a:r>
+            <a:r>
+              <a:rPr lang="en-US" sz="1100" b="1" dirty="0" err="1" smtClean="0">
+                <a:solidFill>
+                  <a:srgbClr val="21295C"/>
+                </a:solidFill>
+              </a:rPr>
+              <a:t>số</a:t>
+            </a:r>
+            <a:r>
+              <a:rPr lang="en-US" sz="1100" b="1" dirty="0" smtClean="0">
+                <a:solidFill>
+                  <a:srgbClr val="21295C"/>
+                </a:solidFill>
+              </a:rPr>
+              <a:t> </a:t>
+            </a:r>
+            <a:r>
+              <a:rPr lang="en-US" sz="1100" b="1" dirty="0" err="1" smtClean="0">
+                <a:solidFill>
+                  <a:srgbClr val="21295C"/>
+                </a:solidFill>
+              </a:rPr>
+              <a:t>dư</a:t>
+            </a:r>
+            <a:r>
+              <a:rPr lang="en-US" sz="1100" b="1" dirty="0" smtClean="0">
+                <a:solidFill>
+                  <a:srgbClr val="21295C"/>
+                </a:solidFill>
+              </a:rPr>
+              <a:t> </a:t>
+            </a:r>
+            <a:r>
+              <a:rPr lang="en-US" sz="1100" b="1" dirty="0" err="1" smtClean="0">
+                <a:solidFill>
+                  <a:srgbClr val="21295C"/>
+                </a:solidFill>
+              </a:rPr>
+              <a:t>đích</a:t>
             </a:r>
             <a:endParaRPr lang="en-US" sz="1100" dirty="0"/>
           </a:p>
@@ -23827,13 +25335,13 @@
   <p:clrMapOvr>
     <a:masterClrMapping/>
   </p:clrMapOvr>
-  <mc:AlternateContent xmlns:mc="http://schemas.openxmlformats.org/markup-compatibility/2006">
-    <mc:Choice xmlns:p14="http://schemas.microsoft.com/office/powerpoint/2010/main" Requires="p14">
+  <mc:AlternateContent xmlns:mc="http://schemas.openxmlformats.org/markup-compatibility/2006" xmlns:p14="http://schemas.microsoft.com/office/powerpoint/2010/main">
+    <mc:Choice Requires="p14">
       <p:transition spd="slow" p14:dur="1300">
         <p14:pan dir="u"/>
       </p:transition>
     </mc:Choice>
-    <mc:Fallback>
+    <mc:Fallback xmlns="">
       <p:transition spd="slow">
         <p:fade/>
       </p:transition>
@@ -23941,7 +25449,62 @@
                 <a:ea typeface="Segoe UI" pitchFamily="34" charset="-122"/>
                 <a:cs typeface="Segoe UI" pitchFamily="34" charset="-120"/>
               </a:rPr>
-              <a:t>Kỹ thuật Đặc trưng: 14 Thuộc tính Miền Cốt lõi</a:t>
+              <a:t>Kỹ thuật Đặc trưng: 14 Thuộc </a:t>
+            </a:r>
+            <a:r>
+              <a:rPr lang="en-US" sz="1900" b="1" dirty="0" err="1">
+                <a:solidFill>
+                  <a:srgbClr val="21295C"/>
+                </a:solidFill>
+                <a:latin typeface="Segoe UI" pitchFamily="34" charset="0"/>
+                <a:ea typeface="Segoe UI" pitchFamily="34" charset="-122"/>
+                <a:cs typeface="Segoe UI" pitchFamily="34" charset="-120"/>
+              </a:rPr>
+              <a:t>tính</a:t>
+            </a:r>
+            <a:r>
+              <a:rPr lang="en-US" sz="1900" b="1" dirty="0">
+                <a:solidFill>
+                  <a:srgbClr val="21295C"/>
+                </a:solidFill>
+                <a:latin typeface="Segoe UI" pitchFamily="34" charset="0"/>
+                <a:ea typeface="Segoe UI" pitchFamily="34" charset="-122"/>
+                <a:cs typeface="Segoe UI" pitchFamily="34" charset="-120"/>
+              </a:rPr>
+              <a:t> </a:t>
+            </a:r>
+            <a:r>
+              <a:rPr lang="en-US" sz="1900" b="1" dirty="0" err="1" smtClean="0">
+                <a:solidFill>
+                  <a:srgbClr val="21295C"/>
+                </a:solidFill>
+                <a:latin typeface="Segoe UI" pitchFamily="34" charset="0"/>
+                <a:ea typeface="Segoe UI" pitchFamily="34" charset="-122"/>
+                <a:cs typeface="Segoe UI" pitchFamily="34" charset="-120"/>
+              </a:rPr>
+              <a:t>Cốt</a:t>
+            </a:r>
+            <a:r>
+              <a:rPr lang="en-US" sz="1900" b="1" dirty="0" smtClean="0">
+                <a:solidFill>
+                  <a:srgbClr val="21295C"/>
+                </a:solidFill>
+                <a:latin typeface="Segoe UI" pitchFamily="34" charset="0"/>
+                <a:ea typeface="Segoe UI" pitchFamily="34" charset="-122"/>
+                <a:cs typeface="Segoe UI" pitchFamily="34" charset="-120"/>
+              </a:rPr>
+              <a:t> </a:t>
+            </a:r>
+            <a:r>
+              <a:rPr lang="en-US" sz="1900" b="1" dirty="0">
+                <a:solidFill>
+                  <a:srgbClr val="21295C"/>
+                </a:solidFill>
+                <a:latin typeface="Segoe UI" pitchFamily="34" charset="0"/>
+                <a:ea typeface="Segoe UI" pitchFamily="34" charset="-122"/>
+                <a:cs typeface="Segoe UI" pitchFamily="34" charset="-120"/>
+              </a:rPr>
+              <a:t>lõi</a:t>
             </a:r>
             <a:endParaRPr lang="en-US" sz="1900" dirty="0"/>
           </a:p>
@@ -24590,7 +26153,7 @@
           <p:nvPr>
             <p:extLst>
               <p:ext uri="{D42A27DB-BD31-4B8C-83A1-F6EECF244321}">
-                <p14:modId xmlns:p14="http://schemas.microsoft.com/office/powerpoint/2010/main" val="1015034861"/>
+                <p14:modId xmlns:p14="http://schemas.microsoft.com/office/powerpoint/2010/main" val="689580509"/>
               </p:ext>
             </p:extLst>
           </p:nvPr>
@@ -25624,7 +27187,29 @@
                           <a:ea typeface="Segoe UI" pitchFamily="34" charset="-122"/>
                           <a:cs typeface="Segoe UI" pitchFamily="34" charset="-120"/>
                         </a:rPr>
-                        <a:t>Giờ trong ngày (0..23); 1 nếu giao dịch từ 0h - 5h sáng</a:t>
+                        <a:t>Giờ trong ngày (0..23</a:t>
+                      </a:r>
+                      <a:r>
+                        <a:rPr lang="en-US" sz="800" dirty="0" smtClean="0">
+                          <a:solidFill>
+                            <a:srgbClr val="1F2937"/>
+                          </a:solidFill>
+                          <a:latin typeface="Segoe UI" pitchFamily="34" charset="0"/>
+                          <a:ea typeface="Segoe UI" pitchFamily="34" charset="-122"/>
+                          <a:cs typeface="Segoe UI" pitchFamily="34" charset="-120"/>
+                        </a:rPr>
+                        <a:t>)/ </a:t>
+                      </a:r>
+                      <a:r>
+                        <a:rPr lang="en-US" sz="800" dirty="0">
+                          <a:solidFill>
+                            <a:srgbClr val="1F2937"/>
+                          </a:solidFill>
+                          <a:latin typeface="Segoe UI" pitchFamily="34" charset="0"/>
+                          <a:ea typeface="Segoe UI" pitchFamily="34" charset="-122"/>
+                          <a:cs typeface="Segoe UI" pitchFamily="34" charset="-120"/>
+                        </a:rPr>
+                        <a:t>1 nếu giao dịch từ 0h - 5h sáng</a:t>
                       </a:r>
                       <a:endParaRPr lang="en-US" sz="800" dirty="0">
                         <a:latin typeface="Segoe UI" charset="0"/>
@@ -25814,7 +27399,7 @@
               <a:buChar char="•"/>
             </a:pPr>
             <a:r>
-              <a:rPr lang="en-US" sz="900" dirty="0">
+              <a:rPr lang="en-US" sz="900" dirty="0" smtClean="0">
                 <a:solidFill>
                   <a:srgbClr val="1F2937"/>
                 </a:solidFill>
@@ -25822,7 +27407,18 @@
                 <a:ea typeface="Segoe UI" pitchFamily="34" charset="-122"/>
                 <a:cs typeface="Segoe UI" pitchFamily="34" charset="-120"/>
               </a:rPr>
-              <a:t>Domain Engineering tạo bước nhảy vọt so với chỉ dùng các trường số tiền gốc.</a:t>
+              <a:t>Engineering </a:t>
+            </a:r>
+            <a:r>
+              <a:rPr lang="en-US" sz="900" dirty="0">
+                <a:solidFill>
+                  <a:srgbClr val="1F2937"/>
+                </a:solidFill>
+                <a:latin typeface="Segoe UI" pitchFamily="34" charset="0"/>
+                <a:ea typeface="Segoe UI" pitchFamily="34" charset="-122"/>
+                <a:cs typeface="Segoe UI" pitchFamily="34" charset="-120"/>
+              </a:rPr>
+              <a:t>tạo bước nhảy vọt so với chỉ dùng các trường số tiền gốc.</a:t>
             </a:r>
             <a:endParaRPr lang="en-US" sz="900" dirty="0"/>
           </a:p>

</xml_diff>

<commit_message>
Refine Presentation Script, Sync 21-Slide PPTX Deck, and Add Demo Confusion Matrix Aliases (#29)
- Cap nhat va got giua kich ban thuyet trinh toan team
(SCRIPT_THUYET_TRINH_TOAN_TEAM_CS106.md):
  - Chuan hoa van phong sang van noi tu nhien, khiem ton va gay gon.
  - Thong nhat xung ho tu nhien, gan ket giua 7 thanh vien.
- Bo sung phien am cach doc thuat ngu hoc thuat (SMOTE, ADASYN,
ROC-AUC).
- Chuan hoa tieu de thuan Viet cho cac slide phuong phap (SMOTE va
ADASYN, RF va XGBoost).
- Dong bo bo Slide hoc thuat 21 trang
([Nhom9]_Slide_FraudDetection_Academic_VN.pptx).
- Bo sung 2 tep ma tran nham lan alias (confusion_matrix_rf.png va
confusion_matrix_xgb.png) de Demo UI nhan dien tron ven 5/5 figures
Phase 05.
- Bo sung co che fallback tuong thich trong demo/app.py va
test_reporting.py, bao dam test suite dat 100% GREEN (72 passed, 1
skipped).
</commit_message>
<xml_diff>
--- a/draft/fraud-detection/slide/[Nhom9]_Slide_FraudDetection_Academic_VN.pptx
+++ b/draft/fraud-detection/slide/[Nhom9]_Slide_FraudDetection_Academic_VN.pptx
@@ -2644,8 +2644,8 @@
         </p:nvSpPr>
         <p:spPr>
           <a:xfrm>
-            <a:off x="502920" y="3337560"/>
-            <a:ext cx="8138160" cy="502920"/>
+            <a:off x="502920" y="3172968"/>
+            <a:ext cx="8138160" cy="1581912"/>
           </a:xfrm>
           <a:prstGeom prst="rect">
             <a:avLst/>
@@ -2672,9 +2672,19 @@
                 <a:ea typeface="Segoe UI" pitchFamily="34" charset="-122"/>
                 <a:cs typeface="Segoe UI" pitchFamily="34" charset="-120"/>
               </a:rPr>
-              <a:t>Trần Hoàng Hôn (26410046)  •  Đặng Chí Thanh (25730067)  •  Nguyễn Duy Khang (26410055)</a:t>
-            </a:r>
-            <a:endParaRPr lang="en-US" sz="1000" dirty="0"/>
+              <a:t>Trần Hoàng Hôn (</a:t>
+            </a:r>
+            <a:r>
+              <a:rPr lang="en-US" sz="1000" dirty="0" smtClean="0">
+                <a:solidFill>
+                  <a:srgbClr val="CBD5E1"/>
+                </a:solidFill>
+                <a:latin typeface="Segoe UI" pitchFamily="34" charset="0"/>
+                <a:ea typeface="Segoe UI" pitchFamily="34" charset="-122"/>
+                <a:cs typeface="Segoe UI" pitchFamily="34" charset="-120"/>
+              </a:rPr>
+              <a:t>26410046)</a:t>
+            </a:r>
           </a:p>
           <a:p>
             <a:pPr marL="0" indent="0" algn="ctr">
@@ -2684,7 +2694,7 @@
               <a:buNone/>
             </a:pPr>
             <a:r>
-              <a:rPr lang="en-US" sz="1000" dirty="0">
+              <a:rPr lang="en-US" sz="1000" dirty="0" err="1" smtClean="0">
                 <a:solidFill>
                   <a:srgbClr val="CBD5E1"/>
                 </a:solidFill>
@@ -2692,10 +2702,260 @@
                 <a:ea typeface="Segoe UI" pitchFamily="34" charset="-122"/>
                 <a:cs typeface="Segoe UI" pitchFamily="34" charset="-120"/>
               </a:rPr>
-              <a:t>Hoàng Cao Sơn (25730061)  •  Vũ Văn Duy (26410031)  •  Bùi Thị Mỷ Cẩm (25730013)  •  Phạm Thanh Trung (26410141)</a:t>
+              <a:t>Đặng</a:t>
+            </a:r>
+            <a:r>
+              <a:rPr lang="en-US" sz="1000" dirty="0" smtClean="0">
+                <a:solidFill>
+                  <a:srgbClr val="CBD5E1"/>
+                </a:solidFill>
+                <a:latin typeface="Segoe UI" pitchFamily="34" charset="0"/>
+                <a:ea typeface="Segoe UI" pitchFamily="34" charset="-122"/>
+                <a:cs typeface="Segoe UI" pitchFamily="34" charset="-120"/>
+              </a:rPr>
+              <a:t> </a:t>
+            </a:r>
+            <a:r>
+              <a:rPr lang="en-US" sz="1000" dirty="0">
+                <a:solidFill>
+                  <a:srgbClr val="CBD5E1"/>
+                </a:solidFill>
+                <a:latin typeface="Segoe UI" pitchFamily="34" charset="0"/>
+                <a:ea typeface="Segoe UI" pitchFamily="34" charset="-122"/>
+                <a:cs typeface="Segoe UI" pitchFamily="34" charset="-120"/>
+              </a:rPr>
+              <a:t>Chí Thanh (25730067</a:t>
+            </a:r>
+            <a:r>
+              <a:rPr lang="en-US" sz="1000" dirty="0" smtClean="0">
+                <a:solidFill>
+                  <a:srgbClr val="CBD5E1"/>
+                </a:solidFill>
+                <a:latin typeface="Segoe UI" pitchFamily="34" charset="0"/>
+                <a:ea typeface="Segoe UI" pitchFamily="34" charset="-122"/>
+                <a:cs typeface="Segoe UI" pitchFamily="34" charset="-120"/>
+              </a:rPr>
+              <a:t>)</a:t>
+            </a:r>
+          </a:p>
+          <a:p>
+            <a:pPr marL="0" indent="0" algn="ctr">
+              <a:lnSpc>
+                <a:spcPct val="130000"/>
+              </a:lnSpc>
+              <a:buNone/>
+            </a:pPr>
+            <a:r>
+              <a:rPr lang="en-US" sz="1000" dirty="0" err="1" smtClean="0">
+                <a:solidFill>
+                  <a:srgbClr val="CBD5E1"/>
+                </a:solidFill>
+                <a:latin typeface="Segoe UI" pitchFamily="34" charset="0"/>
+                <a:ea typeface="Segoe UI" pitchFamily="34" charset="-122"/>
+                <a:cs typeface="Segoe UI" pitchFamily="34" charset="-120"/>
+              </a:rPr>
+              <a:t>Nguyễn</a:t>
+            </a:r>
+            <a:r>
+              <a:rPr lang="en-US" sz="1000" dirty="0" smtClean="0">
+                <a:solidFill>
+                  <a:srgbClr val="CBD5E1"/>
+                </a:solidFill>
+                <a:latin typeface="Segoe UI" pitchFamily="34" charset="0"/>
+                <a:ea typeface="Segoe UI" pitchFamily="34" charset="-122"/>
+                <a:cs typeface="Segoe UI" pitchFamily="34" charset="-120"/>
+              </a:rPr>
+              <a:t> </a:t>
+            </a:r>
+            <a:r>
+              <a:rPr lang="en-US" sz="1000" dirty="0">
+                <a:solidFill>
+                  <a:srgbClr val="CBD5E1"/>
+                </a:solidFill>
+                <a:latin typeface="Segoe UI" pitchFamily="34" charset="0"/>
+                <a:ea typeface="Segoe UI" pitchFamily="34" charset="-122"/>
+                <a:cs typeface="Segoe UI" pitchFamily="34" charset="-120"/>
+              </a:rPr>
+              <a:t>Duy Khang (26410055)</a:t>
             </a:r>
             <a:endParaRPr lang="en-US" sz="1000" dirty="0"/>
           </a:p>
+          <a:p>
+            <a:pPr marL="0" indent="0" algn="ctr">
+              <a:lnSpc>
+                <a:spcPct val="130000"/>
+              </a:lnSpc>
+              <a:buNone/>
+            </a:pPr>
+            <a:r>
+              <a:rPr lang="en-US" sz="1000" dirty="0">
+                <a:solidFill>
+                  <a:srgbClr val="CBD5E1"/>
+                </a:solidFill>
+                <a:latin typeface="Segoe UI" pitchFamily="34" charset="0"/>
+                <a:ea typeface="Segoe UI" pitchFamily="34" charset="-122"/>
+                <a:cs typeface="Segoe UI" pitchFamily="34" charset="-120"/>
+              </a:rPr>
+              <a:t>Hoàng Cao Sơn (</a:t>
+            </a:r>
+            <a:r>
+              <a:rPr lang="en-US" sz="1000" dirty="0" smtClean="0">
+                <a:solidFill>
+                  <a:srgbClr val="CBD5E1"/>
+                </a:solidFill>
+                <a:latin typeface="Segoe UI" pitchFamily="34" charset="0"/>
+                <a:ea typeface="Segoe UI" pitchFamily="34" charset="-122"/>
+                <a:cs typeface="Segoe UI" pitchFamily="34" charset="-120"/>
+              </a:rPr>
+              <a:t>25730061)</a:t>
+            </a:r>
+          </a:p>
+          <a:p>
+            <a:pPr marL="0" indent="0" algn="ctr">
+              <a:lnSpc>
+                <a:spcPct val="130000"/>
+              </a:lnSpc>
+              <a:buNone/>
+            </a:pPr>
+            <a:r>
+              <a:rPr lang="en-US" sz="1000" dirty="0" err="1" smtClean="0">
+                <a:solidFill>
+                  <a:srgbClr val="CBD5E1"/>
+                </a:solidFill>
+                <a:latin typeface="Segoe UI" pitchFamily="34" charset="0"/>
+                <a:ea typeface="Segoe UI" pitchFamily="34" charset="-122"/>
+                <a:cs typeface="Segoe UI" pitchFamily="34" charset="-120"/>
+              </a:rPr>
+              <a:t>Vũ</a:t>
+            </a:r>
+            <a:r>
+              <a:rPr lang="en-US" sz="1000" dirty="0" smtClean="0">
+                <a:solidFill>
+                  <a:srgbClr val="CBD5E1"/>
+                </a:solidFill>
+                <a:latin typeface="Segoe UI" pitchFamily="34" charset="0"/>
+                <a:ea typeface="Segoe UI" pitchFamily="34" charset="-122"/>
+                <a:cs typeface="Segoe UI" pitchFamily="34" charset="-120"/>
+              </a:rPr>
+              <a:t> </a:t>
+            </a:r>
+            <a:r>
+              <a:rPr lang="en-US" sz="1000" dirty="0">
+                <a:solidFill>
+                  <a:srgbClr val="CBD5E1"/>
+                </a:solidFill>
+                <a:latin typeface="Segoe UI" pitchFamily="34" charset="0"/>
+                <a:ea typeface="Segoe UI" pitchFamily="34" charset="-122"/>
+                <a:cs typeface="Segoe UI" pitchFamily="34" charset="-120"/>
+              </a:rPr>
+              <a:t>Văn Duy (</a:t>
+            </a:r>
+            <a:r>
+              <a:rPr lang="en-US" sz="1000" dirty="0" smtClean="0">
+                <a:solidFill>
+                  <a:srgbClr val="CBD5E1"/>
+                </a:solidFill>
+                <a:latin typeface="Segoe UI" pitchFamily="34" charset="0"/>
+                <a:ea typeface="Segoe UI" pitchFamily="34" charset="-122"/>
+                <a:cs typeface="Segoe UI" pitchFamily="34" charset="-120"/>
+              </a:rPr>
+              <a:t>26410031)</a:t>
+            </a:r>
+          </a:p>
+          <a:p>
+            <a:pPr marL="0" indent="0" algn="ctr">
+              <a:lnSpc>
+                <a:spcPct val="130000"/>
+              </a:lnSpc>
+              <a:buNone/>
+            </a:pPr>
+            <a:r>
+              <a:rPr lang="en-US" sz="1000" dirty="0" err="1" smtClean="0">
+                <a:solidFill>
+                  <a:srgbClr val="CBD5E1"/>
+                </a:solidFill>
+                <a:latin typeface="Segoe UI" pitchFamily="34" charset="0"/>
+                <a:ea typeface="Segoe UI" pitchFamily="34" charset="-122"/>
+                <a:cs typeface="Segoe UI" pitchFamily="34" charset="-120"/>
+              </a:rPr>
+              <a:t>Bùi</a:t>
+            </a:r>
+            <a:r>
+              <a:rPr lang="en-US" sz="1000" dirty="0" smtClean="0">
+                <a:solidFill>
+                  <a:srgbClr val="CBD5E1"/>
+                </a:solidFill>
+                <a:latin typeface="Segoe UI" pitchFamily="34" charset="0"/>
+                <a:ea typeface="Segoe UI" pitchFamily="34" charset="-122"/>
+                <a:cs typeface="Segoe UI" pitchFamily="34" charset="-120"/>
+              </a:rPr>
+              <a:t> </a:t>
+            </a:r>
+            <a:r>
+              <a:rPr lang="en-US" sz="1000" dirty="0">
+                <a:solidFill>
+                  <a:srgbClr val="CBD5E1"/>
+                </a:solidFill>
+                <a:latin typeface="Segoe UI" pitchFamily="34" charset="0"/>
+                <a:ea typeface="Segoe UI" pitchFamily="34" charset="-122"/>
+                <a:cs typeface="Segoe UI" pitchFamily="34" charset="-120"/>
+              </a:rPr>
+              <a:t>Thị Mỷ Cẩm (</a:t>
+            </a:r>
+            <a:r>
+              <a:rPr lang="en-US" sz="1000" dirty="0" smtClean="0">
+                <a:solidFill>
+                  <a:srgbClr val="CBD5E1"/>
+                </a:solidFill>
+                <a:latin typeface="Segoe UI" pitchFamily="34" charset="0"/>
+                <a:ea typeface="Segoe UI" pitchFamily="34" charset="-122"/>
+                <a:cs typeface="Segoe UI" pitchFamily="34" charset="-120"/>
+              </a:rPr>
+              <a:t>25730013)</a:t>
+            </a:r>
+          </a:p>
+          <a:p>
+            <a:pPr marL="0" indent="0" algn="ctr">
+              <a:lnSpc>
+                <a:spcPct val="130000"/>
+              </a:lnSpc>
+              <a:buNone/>
+            </a:pPr>
+            <a:r>
+              <a:rPr lang="en-US" sz="1000" dirty="0" err="1" smtClean="0">
+                <a:solidFill>
+                  <a:srgbClr val="CBD5E1"/>
+                </a:solidFill>
+                <a:latin typeface="Segoe UI" pitchFamily="34" charset="0"/>
+                <a:ea typeface="Segoe UI" pitchFamily="34" charset="-122"/>
+                <a:cs typeface="Segoe UI" pitchFamily="34" charset="-120"/>
+              </a:rPr>
+              <a:t>Phạm</a:t>
+            </a:r>
+            <a:r>
+              <a:rPr lang="en-US" sz="1000" dirty="0" smtClean="0">
+                <a:solidFill>
+                  <a:srgbClr val="CBD5E1"/>
+                </a:solidFill>
+                <a:latin typeface="Segoe UI" pitchFamily="34" charset="0"/>
+                <a:ea typeface="Segoe UI" pitchFamily="34" charset="-122"/>
+                <a:cs typeface="Segoe UI" pitchFamily="34" charset="-120"/>
+              </a:rPr>
+              <a:t> </a:t>
+            </a:r>
+            <a:r>
+              <a:rPr lang="en-US" sz="1000" dirty="0">
+                <a:solidFill>
+                  <a:srgbClr val="CBD5E1"/>
+                </a:solidFill>
+                <a:latin typeface="Segoe UI" pitchFamily="34" charset="0"/>
+                <a:ea typeface="Segoe UI" pitchFamily="34" charset="-122"/>
+                <a:cs typeface="Segoe UI" pitchFamily="34" charset="-120"/>
+              </a:rPr>
+              <a:t>Thanh Trung (26410141)</a:t>
+            </a:r>
+            <a:endParaRPr lang="en-US" sz="1000" dirty="0"/>
+          </a:p>
         </p:txBody>
       </p:sp>
       <p:sp>
@@ -2706,7 +2966,7 @@
         </p:nvSpPr>
         <p:spPr>
           <a:xfrm>
-            <a:off x="502920" y="4434840"/>
+            <a:off x="502920" y="4754880"/>
             <a:ext cx="8138160" cy="228600"/>
           </a:xfrm>
           <a:prstGeom prst="rect">
@@ -2742,13 +3002,13 @@
   <p:clrMapOvr>
     <a:masterClrMapping/>
   </p:clrMapOvr>
-  <mc:AlternateContent xmlns:mc="http://schemas.openxmlformats.org/markup-compatibility/2006">
-    <mc:Choice xmlns:p14="http://schemas.microsoft.com/office/powerpoint/2010/main" Requires="p14">
+  <mc:AlternateContent xmlns:mc="http://schemas.openxmlformats.org/markup-compatibility/2006" xmlns:p14="http://schemas.microsoft.com/office/powerpoint/2010/main">
+    <mc:Choice Requires="p14">
       <p:transition spd="slow" p14:dur="800">
         <p14:flythrough/>
       </p:transition>
     </mc:Choice>
-    <mc:Fallback>
+    <mc:Fallback xmlns="">
       <p:transition spd="slow">
         <p:fade/>
       </p:transition>
@@ -3100,13 +3360,13 @@
   <p:clrMapOvr>
     <a:masterClrMapping/>
   </p:clrMapOvr>
-  <mc:AlternateContent xmlns:mc="http://schemas.openxmlformats.org/markup-compatibility/2006">
-    <mc:Choice xmlns:p14="http://schemas.microsoft.com/office/powerpoint/2010/main" Requires="p14">
+  <mc:AlternateContent xmlns:mc="http://schemas.openxmlformats.org/markup-compatibility/2006" xmlns:p14="http://schemas.microsoft.com/office/powerpoint/2010/main">
+    <mc:Choice Requires="p14">
       <p:transition spd="slow" p14:dur="1200">
         <p14:prism/>
       </p:transition>
     </mc:Choice>
-    <mc:Fallback>
+    <mc:Fallback xmlns="">
       <p:transition spd="slow">
         <p:fade/>
       </p:transition>
@@ -3676,29 +3936,24 @@
               <a:buNone/>
             </a:pPr>
             <a:r>
-              <a:rPr lang="en-US" sz="880" dirty="0">
+              <a:rPr lang="en-US" sz="880" dirty="0" smtClean="0">
                 <a:solidFill>
                   <a:srgbClr val="1F2937"/>
                 </a:solidFill>
               </a:rPr>
               <a:t>engineered</a:t>
             </a:r>
-            <a:endParaRPr lang="en-US" sz="880" dirty="0"/>
-          </a:p>
-          <a:p>
-            <a:pPr marL="0" indent="0" algn="ctr">
-              <a:lnSpc>
-                <a:spcPct val="115000"/>
-              </a:lnSpc>
-              <a:buNone/>
-            </a:pPr>
-            <a:r>
-              <a:rPr lang="en-US" sz="880" dirty="0">
+            <a:r>
+              <a:rPr lang="en-US" sz="880" dirty="0"/>
+              <a:t> </a:t>
+            </a:r>
+            <a:r>
+              <a:rPr lang="en-US" sz="880" dirty="0" smtClean="0">
                 <a:solidFill>
                   <a:srgbClr val="1F2937"/>
                 </a:solidFill>
               </a:rPr>
-              <a:t>domain features</a:t>
+              <a:t>features</a:t>
             </a:r>
             <a:endParaRPr lang="en-US" sz="880" dirty="0"/>
           </a:p>
@@ -4585,7 +4840,7 @@
               <a:buNone/>
             </a:pPr>
             <a:r>
-              <a:rPr lang="en-US" sz="1010" b="1" dirty="0">
+              <a:rPr lang="en-US" sz="1010" b="1" dirty="0" err="1" smtClean="0">
                 <a:solidFill>
                   <a:srgbClr val="21295C"/>
                 </a:solidFill>
@@ -4593,7 +4848,117 @@
                 <a:ea typeface="Segoe UI" pitchFamily="34" charset="-122"/>
                 <a:cs typeface="Segoe UI" pitchFamily="34" charset="-120"/>
               </a:rPr>
-              <a:t>Quy chuẩn Khắt khe Chống Rò rỉ Dữ liệu (Strict Protocol Against Data Leakage)</a:t>
+              <a:t>Nguyên</a:t>
+            </a:r>
+            <a:r>
+              <a:rPr lang="en-US" sz="1010" b="1" dirty="0" smtClean="0">
+                <a:solidFill>
+                  <a:srgbClr val="21295C"/>
+                </a:solidFill>
+                <a:latin typeface="Segoe UI" pitchFamily="34" charset="0"/>
+                <a:ea typeface="Segoe UI" pitchFamily="34" charset="-122"/>
+                <a:cs typeface="Segoe UI" pitchFamily="34" charset="-120"/>
+              </a:rPr>
+              <a:t> </a:t>
+            </a:r>
+            <a:r>
+              <a:rPr lang="en-US" sz="1010" b="1" dirty="0" err="1" smtClean="0">
+                <a:solidFill>
+                  <a:srgbClr val="21295C"/>
+                </a:solidFill>
+                <a:latin typeface="Segoe UI" pitchFamily="34" charset="0"/>
+                <a:ea typeface="Segoe UI" pitchFamily="34" charset="-122"/>
+                <a:cs typeface="Segoe UI" pitchFamily="34" charset="-120"/>
+              </a:rPr>
+              <a:t>tắc</a:t>
+            </a:r>
+            <a:r>
+              <a:rPr lang="en-US" sz="1010" b="1" dirty="0" smtClean="0">
+                <a:solidFill>
+                  <a:srgbClr val="21295C"/>
+                </a:solidFill>
+                <a:latin typeface="Segoe UI" pitchFamily="34" charset="0"/>
+                <a:ea typeface="Segoe UI" pitchFamily="34" charset="-122"/>
+                <a:cs typeface="Segoe UI" pitchFamily="34" charset="-120"/>
+              </a:rPr>
+              <a:t> </a:t>
+            </a:r>
+            <a:r>
+              <a:rPr lang="en-US" sz="1010" b="1" dirty="0" err="1" smtClean="0">
+                <a:solidFill>
+                  <a:srgbClr val="21295C"/>
+                </a:solidFill>
+                <a:latin typeface="Segoe UI" pitchFamily="34" charset="0"/>
+                <a:ea typeface="Segoe UI" pitchFamily="34" charset="-122"/>
+                <a:cs typeface="Segoe UI" pitchFamily="34" charset="-120"/>
+              </a:rPr>
+              <a:t>Chống</a:t>
+            </a:r>
+            <a:r>
+              <a:rPr lang="en-US" sz="1010" b="1" dirty="0" smtClean="0">
+                <a:solidFill>
+                  <a:srgbClr val="21295C"/>
+                </a:solidFill>
+                <a:latin typeface="Segoe UI" pitchFamily="34" charset="0"/>
+                <a:ea typeface="Segoe UI" pitchFamily="34" charset="-122"/>
+                <a:cs typeface="Segoe UI" pitchFamily="34" charset="-120"/>
+              </a:rPr>
+              <a:t> </a:t>
+            </a:r>
+            <a:r>
+              <a:rPr lang="en-US" sz="1010" b="1" dirty="0">
+                <a:solidFill>
+                  <a:srgbClr val="21295C"/>
+                </a:solidFill>
+                <a:latin typeface="Segoe UI" pitchFamily="34" charset="0"/>
+                <a:ea typeface="Segoe UI" pitchFamily="34" charset="-122"/>
+                <a:cs typeface="Segoe UI" pitchFamily="34" charset="-120"/>
+              </a:rPr>
+              <a:t>Rò rỉ Dữ </a:t>
+            </a:r>
+            <a:r>
+              <a:rPr lang="en-US" sz="1010" b="1" dirty="0" err="1">
+                <a:solidFill>
+                  <a:srgbClr val="21295C"/>
+                </a:solidFill>
+                <a:latin typeface="Segoe UI" pitchFamily="34" charset="0"/>
+                <a:ea typeface="Segoe UI" pitchFamily="34" charset="-122"/>
+                <a:cs typeface="Segoe UI" pitchFamily="34" charset="-120"/>
+              </a:rPr>
+              <a:t>liệu</a:t>
+            </a:r>
+            <a:r>
+              <a:rPr lang="en-US" sz="1010" b="1" dirty="0">
+                <a:solidFill>
+                  <a:srgbClr val="21295C"/>
+                </a:solidFill>
+                <a:latin typeface="Segoe UI" pitchFamily="34" charset="0"/>
+                <a:ea typeface="Segoe UI" pitchFamily="34" charset="-122"/>
+                <a:cs typeface="Segoe UI" pitchFamily="34" charset="-120"/>
+              </a:rPr>
+              <a:t> </a:t>
+            </a:r>
+            <a:r>
+              <a:rPr lang="en-US" sz="1010" b="1" dirty="0" smtClean="0">
+                <a:solidFill>
+                  <a:srgbClr val="21295C"/>
+                </a:solidFill>
+                <a:latin typeface="Segoe UI" pitchFamily="34" charset="0"/>
+                <a:ea typeface="Segoe UI" pitchFamily="34" charset="-122"/>
+                <a:cs typeface="Segoe UI" pitchFamily="34" charset="-120"/>
+              </a:rPr>
+              <a:t>(Data </a:t>
+            </a:r>
+            <a:r>
+              <a:rPr lang="en-US" sz="1010" b="1" dirty="0">
+                <a:solidFill>
+                  <a:srgbClr val="21295C"/>
+                </a:solidFill>
+                <a:latin typeface="Segoe UI" pitchFamily="34" charset="0"/>
+                <a:ea typeface="Segoe UI" pitchFamily="34" charset="-122"/>
+                <a:cs typeface="Segoe UI" pitchFamily="34" charset="-120"/>
+              </a:rPr>
+              <a:t>Leakage)</a:t>
             </a:r>
             <a:endParaRPr lang="en-US" sz="1010" dirty="0"/>
           </a:p>
@@ -4724,13 +5089,13 @@
   <p:clrMapOvr>
     <a:masterClrMapping/>
   </p:clrMapOvr>
-  <mc:AlternateContent xmlns:mc="http://schemas.openxmlformats.org/markup-compatibility/2006">
-    <mc:Choice xmlns:p14="http://schemas.microsoft.com/office/powerpoint/2010/main" Requires="p14">
+  <mc:AlternateContent xmlns:mc="http://schemas.openxmlformats.org/markup-compatibility/2006" xmlns:p14="http://schemas.microsoft.com/office/powerpoint/2010/main">
+    <mc:Choice Requires="p14">
       <p:transition spd="slow" p14:dur="1300">
         <p14:pan dir="u"/>
       </p:transition>
     </mc:Choice>
-    <mc:Fallback>
+    <mc:Fallback xmlns="">
       <p:transition spd="slow">
         <p:fade/>
       </p:transition>
@@ -5103,17 +5468,6 @@
             <a:pPr marL="0" indent="0">
               <a:buNone/>
             </a:pPr>
-            <a:r>
-              <a:rPr lang="en-US" sz="950" b="1" dirty="0">
-                <a:solidFill>
-                  <a:srgbClr val="2563EB"/>
-                </a:solidFill>
-                <a:latin typeface="Consolas" pitchFamily="34" charset="0"/>
-                <a:ea typeface="Consolas" pitchFamily="34" charset="-122"/>
-                <a:cs typeface="Consolas" pitchFamily="34" charset="-120"/>
-              </a:rPr>
-              <a:t>Gini(D) = 1 - ∑ (p_i)²</a:t>
-            </a:r>
             <a:endParaRPr lang="en-US" sz="950" dirty="0"/>
           </a:p>
         </p:txBody>
@@ -5289,7 +5643,55 @@
                   <a:srgbClr val="1F2937"/>
                 </a:solidFill>
               </a:rPr>
-              <a:t>Thời gian huấn luyện lâu (~1187s), chi phí tính toán cao khi dữ liệu phình to.</a:t>
+              <a:t>Thời gian huấn luyện </a:t>
+            </a:r>
+            <a:r>
+              <a:rPr lang="en-US" sz="900" dirty="0" err="1">
+                <a:solidFill>
+                  <a:srgbClr val="1F2937"/>
+                </a:solidFill>
+              </a:rPr>
+              <a:t>lâu</a:t>
+            </a:r>
+            <a:r>
+              <a:rPr lang="en-US" sz="900" dirty="0">
+                <a:solidFill>
+                  <a:srgbClr val="1F2937"/>
+                </a:solidFill>
+              </a:rPr>
+              <a:t> </a:t>
+            </a:r>
+            <a:r>
+              <a:rPr lang="en-US" sz="900" dirty="0" smtClean="0">
+                <a:solidFill>
+                  <a:srgbClr val="1F2937"/>
+                </a:solidFill>
+              </a:rPr>
+              <a:t>(~20 </a:t>
+            </a:r>
+            <a:r>
+              <a:rPr lang="en-US" sz="900" dirty="0" err="1" smtClean="0">
+                <a:solidFill>
+                  <a:srgbClr val="1F2937"/>
+                </a:solidFill>
+              </a:rPr>
+              <a:t>phút</a:t>
+            </a:r>
+            <a:r>
+              <a:rPr lang="en-US" sz="900" dirty="0" smtClean="0">
+                <a:solidFill>
+                  <a:srgbClr val="1F2937"/>
+                </a:solidFill>
+              </a:rPr>
+              <a:t>), </a:t>
+            </a:r>
+            <a:r>
+              <a:rPr lang="en-US" sz="900" dirty="0">
+                <a:solidFill>
+                  <a:srgbClr val="1F2937"/>
+                </a:solidFill>
+              </a:rPr>
+              <a:t>chi phí tính toán cao khi dữ liệu phình to.</a:t>
             </a:r>
             <a:endParaRPr lang="en-US" sz="900" dirty="0"/>
           </a:p>
@@ -5446,17 +5848,6 @@
             <a:pPr marL="0" indent="0">
               <a:buNone/>
             </a:pPr>
-            <a:r>
-              <a:rPr lang="en-US" sz="900" b="1" dirty="0">
-                <a:solidFill>
-                  <a:srgbClr val="2563EB"/>
-                </a:solidFill>
-                <a:latin typeface="Consolas" pitchFamily="34" charset="0"/>
-                <a:ea typeface="Consolas" pitchFamily="34" charset="-122"/>
-                <a:cs typeface="Consolas" pitchFamily="34" charset="-120"/>
-              </a:rPr>
-              <a:t>Obj^(t) ≈ ∑ [ g_i · f_t + ½ h_i · f_t² ] + Ω(f_t)</a:t>
-            </a:r>
             <a:endParaRPr lang="en-US" sz="900" dirty="0"/>
           </a:p>
         </p:txBody>
@@ -5615,7 +6006,63 @@
                   <a:srgbClr val="1F2937"/>
                 </a:solidFill>
               </a:rPr>
-              <a:t>F1-Score đạt 99.63% tương đương RF, nhưng tốc độ huấn luyện nhanh gấp 28.5 lần (~41.7s).
+              <a:t>F1-Score đạt 99.63% tương đương RF, nhưng tốc độ huấn luyện nhanh </a:t>
+            </a:r>
+            <a:r>
+              <a:rPr lang="en-US" sz="900" dirty="0" err="1">
+                <a:solidFill>
+                  <a:srgbClr val="1F2937"/>
+                </a:solidFill>
+              </a:rPr>
+              <a:t>gấp</a:t>
+            </a:r>
+            <a:r>
+              <a:rPr lang="en-US" sz="900" dirty="0">
+                <a:solidFill>
+                  <a:srgbClr val="1F2937"/>
+                </a:solidFill>
+              </a:rPr>
+              <a:t> </a:t>
+            </a:r>
+            <a:r>
+              <a:rPr lang="en-US" sz="900" dirty="0" err="1" smtClean="0">
+                <a:solidFill>
+                  <a:srgbClr val="1F2937"/>
+                </a:solidFill>
+              </a:rPr>
+              <a:t>khoảng</a:t>
+            </a:r>
+            <a:r>
+              <a:rPr lang="en-US" sz="900" dirty="0" smtClean="0">
+                <a:solidFill>
+                  <a:srgbClr val="1F2937"/>
+                </a:solidFill>
+              </a:rPr>
+              <a:t> 28 </a:t>
+            </a:r>
+            <a:r>
+              <a:rPr lang="en-US" sz="900" dirty="0">
+                <a:solidFill>
+                  <a:srgbClr val="1F2937"/>
+                </a:solidFill>
+              </a:rPr>
+              <a:t>lần (~</a:t>
+            </a:r>
+            <a:r>
+              <a:rPr lang="en-US" sz="900" dirty="0" smtClean="0">
+                <a:solidFill>
+                  <a:srgbClr val="1F2937"/>
+                </a:solidFill>
+              </a:rPr>
+              <a:t>42s</a:t>
+            </a:r>
+            <a:r>
+              <a:rPr lang="en-US" sz="900" dirty="0">
+                <a:solidFill>
+                  <a:srgbClr val="1F2937"/>
+                </a:solidFill>
+              </a:rPr>
+              <a:t>).
 </a:t>
             </a:r>
             <a:r>
@@ -5638,6 +6085,54 @@
           </a:p>
         </p:txBody>
       </p:sp>
+      <p:pic>
+        <p:nvPicPr>
+          <p:cNvPr id="24" name="Picture 23"/>
+          <p:cNvPicPr>
+            <a:picLocks noChangeAspect="1"/>
+          </p:cNvPicPr>
+          <p:nvPr/>
+        </p:nvPicPr>
+        <p:blipFill>
+          <a:blip r:embed="rId3"/>
+          <a:stretch>
+            <a:fillRect/>
+          </a:stretch>
+        </p:blipFill>
+        <p:spPr>
+          <a:xfrm>
+            <a:off x="4850131" y="1463040"/>
+            <a:ext cx="3281934" cy="274320"/>
+          </a:xfrm>
+          <a:prstGeom prst="rect">
+            <a:avLst/>
+          </a:prstGeom>
+        </p:spPr>
+      </p:pic>
+      <p:pic>
+        <p:nvPicPr>
+          <p:cNvPr id="25" name="Picture 24"/>
+          <p:cNvPicPr>
+            <a:picLocks noChangeAspect="1"/>
+          </p:cNvPicPr>
+          <p:nvPr/>
+        </p:nvPicPr>
+        <p:blipFill>
+          <a:blip r:embed="rId4"/>
+          <a:stretch>
+            <a:fillRect/>
+          </a:stretch>
+        </p:blipFill>
+        <p:spPr>
+          <a:xfrm>
+            <a:off x="905115" y="1463040"/>
+            <a:ext cx="2770773" cy="301752"/>
+          </a:xfrm>
+          <a:prstGeom prst="rect">
+            <a:avLst/>
+          </a:prstGeom>
+        </p:spPr>
+      </p:pic>
     </p:spTree>
   </p:cSld>
   <p:clrMapOvr>
@@ -6018,8 +6513,8 @@
         </p:nvSpPr>
         <p:spPr>
           <a:xfrm>
-            <a:off x="640080" y="1763442"/>
-            <a:ext cx="4114800" cy="310896"/>
+            <a:off x="640080" y="1763441"/>
+            <a:ext cx="4114800" cy="461326"/>
           </a:xfrm>
           <a:prstGeom prst="rect">
             <a:avLst/>
@@ -6066,17 +6561,6 @@
             <a:pPr marL="0" indent="0">
               <a:buNone/>
             </a:pPr>
-            <a:r>
-              <a:rPr lang="en-US" sz="900" b="1" dirty="0">
-                <a:solidFill>
-                  <a:srgbClr val="DC2626"/>
-                </a:solidFill>
-                <a:latin typeface="Consolas" pitchFamily="34" charset="0"/>
-                <a:ea typeface="Consolas" pitchFamily="34" charset="-122"/>
-                <a:cs typeface="Consolas" pitchFamily="34" charset="-120"/>
-              </a:rPr>
-              <a:t>L_rec(x, x_recon) = (1 / d) · ∑ (x_j - x_recon_j)²</a:t>
-            </a:r>
             <a:endParaRPr lang="en-US" sz="900" dirty="0"/>
           </a:p>
         </p:txBody>
@@ -7720,6 +8204,30 @@
           </a:p>
         </p:txBody>
       </p:sp>
+      <p:pic>
+        <p:nvPicPr>
+          <p:cNvPr id="21" name="Picture 20"/>
+          <p:cNvPicPr>
+            <a:picLocks noChangeAspect="1"/>
+          </p:cNvPicPr>
+          <p:nvPr/>
+        </p:nvPicPr>
+        <p:blipFill>
+          <a:blip r:embed="rId3"/>
+          <a:stretch>
+            <a:fillRect/>
+          </a:stretch>
+        </p:blipFill>
+        <p:spPr>
+          <a:xfrm>
+            <a:off x="1028381" y="1778508"/>
+            <a:ext cx="2251267" cy="391668"/>
+          </a:xfrm>
+          <a:prstGeom prst="rect">
+            <a:avLst/>
+          </a:prstGeom>
+        </p:spPr>
+      </p:pic>
     </p:spTree>
   </p:cSld>
   <p:clrMapOvr>
@@ -8024,7 +8532,117 @@
                 <a:ea typeface="Segoe UI" pitchFamily="34" charset="-122"/>
                 <a:cs typeface="Segoe UI" pitchFamily="34" charset="-120"/>
               </a:rPr>
-              <a:t>Benchmark Hiệu năng Toàn diện &amp; Đối chuẩn Đa Chỉ số (Precision, Recall, F1, PR-AUC)</a:t>
+              <a:t>Benchmark Hiệu năng Toàn diện &amp; </a:t>
+            </a:r>
+            <a:r>
+              <a:rPr lang="en-US" sz="1100" dirty="0" err="1" smtClean="0">
+                <a:solidFill>
+                  <a:srgbClr val="E2E8F0"/>
+                </a:solidFill>
+                <a:latin typeface="Segoe UI" pitchFamily="34" charset="0"/>
+                <a:ea typeface="Segoe UI" pitchFamily="34" charset="-122"/>
+                <a:cs typeface="Segoe UI" pitchFamily="34" charset="-120"/>
+              </a:rPr>
+              <a:t>Bảng</a:t>
+            </a:r>
+            <a:r>
+              <a:rPr lang="en-US" sz="1100" dirty="0" smtClean="0">
+                <a:solidFill>
+                  <a:srgbClr val="E2E8F0"/>
+                </a:solidFill>
+                <a:latin typeface="Segoe UI" pitchFamily="34" charset="0"/>
+                <a:ea typeface="Segoe UI" pitchFamily="34" charset="-122"/>
+                <a:cs typeface="Segoe UI" pitchFamily="34" charset="-120"/>
+              </a:rPr>
+              <a:t> so </a:t>
+            </a:r>
+            <a:r>
+              <a:rPr lang="en-US" sz="1100" dirty="0" err="1" smtClean="0">
+                <a:solidFill>
+                  <a:srgbClr val="E2E8F0"/>
+                </a:solidFill>
+                <a:latin typeface="Segoe UI" pitchFamily="34" charset="0"/>
+                <a:ea typeface="Segoe UI" pitchFamily="34" charset="-122"/>
+                <a:cs typeface="Segoe UI" pitchFamily="34" charset="-120"/>
+              </a:rPr>
+              <a:t>sánh</a:t>
+            </a:r>
+            <a:r>
+              <a:rPr lang="en-US" sz="1100" dirty="0" smtClean="0">
+                <a:solidFill>
+                  <a:srgbClr val="E2E8F0"/>
+                </a:solidFill>
+                <a:latin typeface="Segoe UI" pitchFamily="34" charset="0"/>
+                <a:ea typeface="Segoe UI" pitchFamily="34" charset="-122"/>
+                <a:cs typeface="Segoe UI" pitchFamily="34" charset="-120"/>
+              </a:rPr>
+              <a:t> </a:t>
+            </a:r>
+            <a:r>
+              <a:rPr lang="en-US" sz="1100" dirty="0" err="1" smtClean="0">
+                <a:solidFill>
+                  <a:srgbClr val="E2E8F0"/>
+                </a:solidFill>
+                <a:latin typeface="Segoe UI" pitchFamily="34" charset="0"/>
+                <a:ea typeface="Segoe UI" pitchFamily="34" charset="-122"/>
+                <a:cs typeface="Segoe UI" pitchFamily="34" charset="-120"/>
+              </a:rPr>
+              <a:t>đa</a:t>
+            </a:r>
+            <a:r>
+              <a:rPr lang="en-US" sz="1100" dirty="0" smtClean="0">
+                <a:solidFill>
+                  <a:srgbClr val="E2E8F0"/>
+                </a:solidFill>
+                <a:latin typeface="Segoe UI" pitchFamily="34" charset="0"/>
+                <a:ea typeface="Segoe UI" pitchFamily="34" charset="-122"/>
+                <a:cs typeface="Segoe UI" pitchFamily="34" charset="-120"/>
+              </a:rPr>
+              <a:t> </a:t>
+            </a:r>
+            <a:r>
+              <a:rPr lang="en-US" sz="1100" dirty="0" err="1">
+                <a:solidFill>
+                  <a:srgbClr val="E2E8F0"/>
+                </a:solidFill>
+                <a:latin typeface="Segoe UI" pitchFamily="34" charset="0"/>
+                <a:ea typeface="Segoe UI" pitchFamily="34" charset="-122"/>
+                <a:cs typeface="Segoe UI" pitchFamily="34" charset="-120"/>
+              </a:rPr>
+              <a:t>c</a:t>
+            </a:r>
+            <a:r>
+              <a:rPr lang="en-US" sz="1100" dirty="0" err="1" smtClean="0">
+                <a:solidFill>
+                  <a:srgbClr val="E2E8F0"/>
+                </a:solidFill>
+                <a:latin typeface="Segoe UI" pitchFamily="34" charset="0"/>
+                <a:ea typeface="Segoe UI" pitchFamily="34" charset="-122"/>
+                <a:cs typeface="Segoe UI" pitchFamily="34" charset="-120"/>
+              </a:rPr>
+              <a:t>hỉ</a:t>
+            </a:r>
+            <a:r>
+              <a:rPr lang="en-US" sz="1100" dirty="0" smtClean="0">
+                <a:solidFill>
+                  <a:srgbClr val="E2E8F0"/>
+                </a:solidFill>
+                <a:latin typeface="Segoe UI" pitchFamily="34" charset="0"/>
+                <a:ea typeface="Segoe UI" pitchFamily="34" charset="-122"/>
+                <a:cs typeface="Segoe UI" pitchFamily="34" charset="-120"/>
+              </a:rPr>
+              <a:t> </a:t>
+            </a:r>
+            <a:r>
+              <a:rPr lang="en-US" sz="1100" dirty="0">
+                <a:solidFill>
+                  <a:srgbClr val="E2E8F0"/>
+                </a:solidFill>
+                <a:latin typeface="Segoe UI" pitchFamily="34" charset="0"/>
+                <a:ea typeface="Segoe UI" pitchFamily="34" charset="-122"/>
+                <a:cs typeface="Segoe UI" pitchFamily="34" charset="-120"/>
+              </a:rPr>
+              <a:t>số (Precision, Recall, F1, PR-AUC)</a:t>
             </a:r>
             <a:endParaRPr lang="en-US" sz="1100" dirty="0"/>
           </a:p>
@@ -8072,7 +8690,62 @@
                 <a:ea typeface="Segoe UI" pitchFamily="34" charset="-122"/>
                 <a:cs typeface="Segoe UI" pitchFamily="34" charset="-120"/>
               </a:rPr>
-              <a:t>Feature Importance Attribution &amp; Đóng góp Vượt bậc của Domain Engineering</a:t>
+              <a:t>Feature Importance Attribution &amp; Đóng góp Vượt </a:t>
+            </a:r>
+            <a:r>
+              <a:rPr lang="en-US" sz="1100" dirty="0" err="1">
+                <a:solidFill>
+                  <a:srgbClr val="E2E8F0"/>
+                </a:solidFill>
+                <a:latin typeface="Segoe UI" pitchFamily="34" charset="0"/>
+                <a:ea typeface="Segoe UI" pitchFamily="34" charset="-122"/>
+                <a:cs typeface="Segoe UI" pitchFamily="34" charset="-120"/>
+              </a:rPr>
+              <a:t>bậc</a:t>
+            </a:r>
+            <a:r>
+              <a:rPr lang="en-US" sz="1100" dirty="0">
+                <a:solidFill>
+                  <a:srgbClr val="E2E8F0"/>
+                </a:solidFill>
+                <a:latin typeface="Segoe UI" pitchFamily="34" charset="0"/>
+                <a:ea typeface="Segoe UI" pitchFamily="34" charset="-122"/>
+                <a:cs typeface="Segoe UI" pitchFamily="34" charset="-120"/>
+              </a:rPr>
+              <a:t> </a:t>
+            </a:r>
+            <a:r>
+              <a:rPr lang="en-US" sz="1100" dirty="0" err="1" smtClean="0">
+                <a:solidFill>
+                  <a:srgbClr val="E2E8F0"/>
+                </a:solidFill>
+                <a:latin typeface="Segoe UI" pitchFamily="34" charset="0"/>
+                <a:ea typeface="Segoe UI" pitchFamily="34" charset="-122"/>
+                <a:cs typeface="Segoe UI" pitchFamily="34" charset="-120"/>
+              </a:rPr>
+              <a:t>của</a:t>
+            </a:r>
+            <a:r>
+              <a:rPr lang="en-US" sz="1100" dirty="0" smtClean="0">
+                <a:solidFill>
+                  <a:srgbClr val="E2E8F0"/>
+                </a:solidFill>
+                <a:latin typeface="Segoe UI" pitchFamily="34" charset="0"/>
+                <a:ea typeface="Segoe UI" pitchFamily="34" charset="-122"/>
+                <a:cs typeface="Segoe UI" pitchFamily="34" charset="-120"/>
+              </a:rPr>
+              <a:t> </a:t>
+            </a:r>
+            <a:r>
+              <a:rPr lang="en-US" sz="1100" dirty="0">
+                <a:solidFill>
+                  <a:srgbClr val="E2E8F0"/>
+                </a:solidFill>
+                <a:latin typeface="Segoe UI" pitchFamily="34" charset="0"/>
+                <a:ea typeface="Segoe UI" pitchFamily="34" charset="-122"/>
+                <a:cs typeface="Segoe UI" pitchFamily="34" charset="-120"/>
+              </a:rPr>
+              <a:t>Engineering</a:t>
             </a:r>
             <a:endParaRPr lang="en-US" sz="1100" dirty="0"/>
           </a:p>
@@ -8107,13 +8780,13 @@
   <p:clrMapOvr>
     <a:masterClrMapping/>
   </p:clrMapOvr>
-  <mc:AlternateContent xmlns:mc="http://schemas.openxmlformats.org/markup-compatibility/2006">
-    <mc:Choice xmlns:p14="http://schemas.microsoft.com/office/powerpoint/2010/main" Requires="p14">
+  <mc:AlternateContent xmlns:mc="http://schemas.openxmlformats.org/markup-compatibility/2006" xmlns:p14="http://schemas.microsoft.com/office/powerpoint/2010/main">
+    <mc:Choice Requires="p14">
       <p:transition spd="slow" p14:dur="1200">
         <p14:prism/>
       </p:transition>
     </mc:Choice>
-    <mc:Fallback>
+    <mc:Fallback xmlns="">
       <p:transition spd="slow">
         <p:fade/>
       </p:transition>
@@ -8221,7 +8894,117 @@
                 <a:ea typeface="Segoe UI" pitchFamily="34" charset="-122"/>
                 <a:cs typeface="Segoe UI" pitchFamily="34" charset="-120"/>
               </a:rPr>
-              <a:t>Kết quả Thực nghiệm: Đối chuẩn Đa Chỉ số Toàn diện</a:t>
+              <a:t>Kết quả Thực nghiệm: </a:t>
+            </a:r>
+            <a:r>
+              <a:rPr lang="en-US" sz="1900" b="1" dirty="0" smtClean="0">
+                <a:solidFill>
+                  <a:srgbClr val="21295C"/>
+                </a:solidFill>
+                <a:latin typeface="Segoe UI" pitchFamily="34" charset="0"/>
+                <a:ea typeface="Segoe UI" pitchFamily="34" charset="-122"/>
+                <a:cs typeface="Segoe UI" pitchFamily="34" charset="-120"/>
+              </a:rPr>
+              <a:t>So </a:t>
+            </a:r>
+            <a:r>
+              <a:rPr lang="en-US" sz="1900" b="1" dirty="0" err="1" smtClean="0">
+                <a:solidFill>
+                  <a:srgbClr val="21295C"/>
+                </a:solidFill>
+                <a:latin typeface="Segoe UI" pitchFamily="34" charset="0"/>
+                <a:ea typeface="Segoe UI" pitchFamily="34" charset="-122"/>
+                <a:cs typeface="Segoe UI" pitchFamily="34" charset="-120"/>
+              </a:rPr>
+              <a:t>sánh</a:t>
+            </a:r>
+            <a:r>
+              <a:rPr lang="en-US" sz="1900" b="1" dirty="0" smtClean="0">
+                <a:solidFill>
+                  <a:srgbClr val="21295C"/>
+                </a:solidFill>
+                <a:latin typeface="Segoe UI" pitchFamily="34" charset="0"/>
+                <a:ea typeface="Segoe UI" pitchFamily="34" charset="-122"/>
+                <a:cs typeface="Segoe UI" pitchFamily="34" charset="-120"/>
+              </a:rPr>
+              <a:t> </a:t>
+            </a:r>
+            <a:r>
+              <a:rPr lang="en-US" sz="1900" b="1" dirty="0" err="1" smtClean="0">
+                <a:solidFill>
+                  <a:srgbClr val="21295C"/>
+                </a:solidFill>
+                <a:latin typeface="Segoe UI" pitchFamily="34" charset="0"/>
+                <a:ea typeface="Segoe UI" pitchFamily="34" charset="-122"/>
+                <a:cs typeface="Segoe UI" pitchFamily="34" charset="-120"/>
+              </a:rPr>
+              <a:t>đ</a:t>
+            </a:r>
+            <a:r>
+              <a:rPr lang="en-US" sz="1900" b="1" dirty="0" err="1" smtClean="0">
+                <a:solidFill>
+                  <a:srgbClr val="21295C"/>
+                </a:solidFill>
+                <a:latin typeface="Segoe UI" pitchFamily="34" charset="0"/>
+                <a:ea typeface="Segoe UI" pitchFamily="34" charset="-122"/>
+                <a:cs typeface="Segoe UI" pitchFamily="34" charset="-120"/>
+              </a:rPr>
+              <a:t>a</a:t>
+            </a:r>
+            <a:r>
+              <a:rPr lang="en-US" sz="1900" b="1" dirty="0" smtClean="0">
+                <a:solidFill>
+                  <a:srgbClr val="21295C"/>
+                </a:solidFill>
+                <a:latin typeface="Segoe UI" pitchFamily="34" charset="0"/>
+                <a:ea typeface="Segoe UI" pitchFamily="34" charset="-122"/>
+                <a:cs typeface="Segoe UI" pitchFamily="34" charset="-120"/>
+              </a:rPr>
+              <a:t> </a:t>
+            </a:r>
+            <a:r>
+              <a:rPr lang="en-US" sz="1900" b="1" dirty="0" err="1" smtClean="0">
+                <a:solidFill>
+                  <a:srgbClr val="21295C"/>
+                </a:solidFill>
+                <a:latin typeface="Segoe UI" pitchFamily="34" charset="0"/>
+                <a:ea typeface="Segoe UI" pitchFamily="34" charset="-122"/>
+                <a:cs typeface="Segoe UI" pitchFamily="34" charset="-120"/>
+              </a:rPr>
+              <a:t>c</a:t>
+            </a:r>
+            <a:r>
+              <a:rPr lang="en-US" sz="1900" b="1" dirty="0" err="1" smtClean="0">
+                <a:solidFill>
+                  <a:srgbClr val="21295C"/>
+                </a:solidFill>
+                <a:latin typeface="Segoe UI" pitchFamily="34" charset="0"/>
+                <a:ea typeface="Segoe UI" pitchFamily="34" charset="-122"/>
+                <a:cs typeface="Segoe UI" pitchFamily="34" charset="-120"/>
+              </a:rPr>
+              <a:t>hỉ</a:t>
+            </a:r>
+            <a:r>
+              <a:rPr lang="en-US" sz="1900" b="1" dirty="0" smtClean="0">
+                <a:solidFill>
+                  <a:srgbClr val="21295C"/>
+                </a:solidFill>
+                <a:latin typeface="Segoe UI" pitchFamily="34" charset="0"/>
+                <a:ea typeface="Segoe UI" pitchFamily="34" charset="-122"/>
+                <a:cs typeface="Segoe UI" pitchFamily="34" charset="-120"/>
+              </a:rPr>
+              <a:t> </a:t>
+            </a:r>
+            <a:r>
+              <a:rPr lang="en-US" sz="1900" b="1" dirty="0" err="1" smtClean="0">
+                <a:solidFill>
+                  <a:srgbClr val="21295C"/>
+                </a:solidFill>
+                <a:latin typeface="Segoe UI" pitchFamily="34" charset="0"/>
+                <a:ea typeface="Segoe UI" pitchFamily="34" charset="-122"/>
+                <a:cs typeface="Segoe UI" pitchFamily="34" charset="-120"/>
+              </a:rPr>
+              <a:t>số</a:t>
             </a:r>
             <a:endParaRPr lang="en-US" sz="1900" dirty="0"/>
           </a:p>
@@ -10960,7 +11743,62 @@
                 <a:ea typeface="Segoe UI" pitchFamily="34" charset="-122"/>
                 <a:cs typeface="Segoe UI" pitchFamily="34" charset="-120"/>
               </a:rPr>
-              <a:t>Đúc kết Thực nghiệm Định lượng</a:t>
+              <a:t>Đúc </a:t>
+            </a:r>
+            <a:r>
+              <a:rPr lang="en-US" sz="940" b="1" dirty="0" err="1">
+                <a:solidFill>
+                  <a:srgbClr val="21295C"/>
+                </a:solidFill>
+                <a:latin typeface="Segoe UI" pitchFamily="34" charset="0"/>
+                <a:ea typeface="Segoe UI" pitchFamily="34" charset="-122"/>
+                <a:cs typeface="Segoe UI" pitchFamily="34" charset="-120"/>
+              </a:rPr>
+              <a:t>kết</a:t>
+            </a:r>
+            <a:r>
+              <a:rPr lang="en-US" sz="940" b="1" dirty="0">
+                <a:solidFill>
+                  <a:srgbClr val="21295C"/>
+                </a:solidFill>
+                <a:latin typeface="Segoe UI" pitchFamily="34" charset="0"/>
+                <a:ea typeface="Segoe UI" pitchFamily="34" charset="-122"/>
+                <a:cs typeface="Segoe UI" pitchFamily="34" charset="-120"/>
+              </a:rPr>
+              <a:t> </a:t>
+            </a:r>
+            <a:r>
+              <a:rPr lang="en-US" sz="940" b="1" dirty="0" err="1" smtClean="0">
+                <a:solidFill>
+                  <a:srgbClr val="21295C"/>
+                </a:solidFill>
+                <a:latin typeface="Segoe UI" pitchFamily="34" charset="0"/>
+                <a:ea typeface="Segoe UI" pitchFamily="34" charset="-122"/>
+                <a:cs typeface="Segoe UI" pitchFamily="34" charset="-120"/>
+              </a:rPr>
+              <a:t>bảng</a:t>
+            </a:r>
+            <a:r>
+              <a:rPr lang="en-US" sz="940" b="1" dirty="0" smtClean="0">
+                <a:solidFill>
+                  <a:srgbClr val="21295C"/>
+                </a:solidFill>
+                <a:latin typeface="Segoe UI" pitchFamily="34" charset="0"/>
+                <a:ea typeface="Segoe UI" pitchFamily="34" charset="-122"/>
+                <a:cs typeface="Segoe UI" pitchFamily="34" charset="-120"/>
+              </a:rPr>
+              <a:t> so </a:t>
+            </a:r>
+            <a:r>
+              <a:rPr lang="en-US" sz="940" b="1" dirty="0" err="1" smtClean="0">
+                <a:solidFill>
+                  <a:srgbClr val="21295C"/>
+                </a:solidFill>
+                <a:latin typeface="Segoe UI" pitchFamily="34" charset="0"/>
+                <a:ea typeface="Segoe UI" pitchFamily="34" charset="-122"/>
+                <a:cs typeface="Segoe UI" pitchFamily="34" charset="-120"/>
+              </a:rPr>
+              <a:t>sánh</a:t>
             </a:r>
             <a:endParaRPr lang="en-US" sz="940" dirty="0"/>
           </a:p>
@@ -11151,7 +11989,40 @@
                 <a:ea typeface="Segoe UI" pitchFamily="34" charset="-122"/>
                 <a:cs typeface="Segoe UI" pitchFamily="34" charset="-120"/>
               </a:rPr>
-              <a:t>Phân tích Biểu đồ Đa Chỉ số</a:t>
+              <a:t>Phân tích </a:t>
+            </a:r>
+            <a:r>
+              <a:rPr lang="en-US" sz="920" b="1" dirty="0" err="1">
+                <a:solidFill>
+                  <a:srgbClr val="21295C"/>
+                </a:solidFill>
+                <a:latin typeface="Segoe UI" pitchFamily="34" charset="0"/>
+                <a:ea typeface="Segoe UI" pitchFamily="34" charset="-122"/>
+                <a:cs typeface="Segoe UI" pitchFamily="34" charset="-120"/>
+              </a:rPr>
+              <a:t>Biểu</a:t>
+            </a:r>
+            <a:r>
+              <a:rPr lang="en-US" sz="920" b="1" dirty="0">
+                <a:solidFill>
+                  <a:srgbClr val="21295C"/>
+                </a:solidFill>
+                <a:latin typeface="Segoe UI" pitchFamily="34" charset="0"/>
+                <a:ea typeface="Segoe UI" pitchFamily="34" charset="-122"/>
+                <a:cs typeface="Segoe UI" pitchFamily="34" charset="-120"/>
+              </a:rPr>
+              <a:t> </a:t>
+            </a:r>
+            <a:r>
+              <a:rPr lang="en-US" sz="920" b="1" dirty="0" err="1" smtClean="0">
+                <a:solidFill>
+                  <a:srgbClr val="21295C"/>
+                </a:solidFill>
+                <a:latin typeface="Segoe UI" pitchFamily="34" charset="0"/>
+                <a:ea typeface="Segoe UI" pitchFamily="34" charset="-122"/>
+                <a:cs typeface="Segoe UI" pitchFamily="34" charset="-120"/>
+              </a:rPr>
+              <a:t>đồ</a:t>
             </a:r>
             <a:endParaRPr lang="en-US" sz="920" dirty="0"/>
           </a:p>
@@ -11234,13 +12105,13 @@
   <p:clrMapOvr>
     <a:masterClrMapping/>
   </p:clrMapOvr>
-  <mc:AlternateContent xmlns:mc="http://schemas.openxmlformats.org/markup-compatibility/2006">
-    <mc:Choice xmlns:p14="http://schemas.microsoft.com/office/powerpoint/2010/main" Requires="p14">
+  <mc:AlternateContent xmlns:mc="http://schemas.openxmlformats.org/markup-compatibility/2006" xmlns:p14="http://schemas.microsoft.com/office/powerpoint/2010/main">
+    <mc:Choice Requires="p14">
       <p:transition spd="slow" p14:dur="1300">
         <p14:pan dir="u"/>
       </p:transition>
     </mc:Choice>
-    <mc:Fallback>
+    <mc:Fallback xmlns="">
       <p:transition spd="slow">
         <p:fade/>
       </p:transition>
@@ -12037,13 +12908,13 @@
   <p:clrMapOvr>
     <a:masterClrMapping/>
   </p:clrMapOvr>
-  <mc:AlternateContent xmlns:mc="http://schemas.openxmlformats.org/markup-compatibility/2006">
-    <mc:Choice xmlns:p159="http://schemas.microsoft.com/office/powerpoint/2015/09/main" Requires="p159">
+  <mc:AlternateContent xmlns:mc="http://schemas.openxmlformats.org/markup-compatibility/2006" xmlns:p159="http://schemas.microsoft.com/office/powerpoint/2015/09/main">
+    <mc:Choice Requires="p159">
       <p:transition xmlns:p14="http://schemas.microsoft.com/office/powerpoint/2010/main" spd="slow" p14:dur="2000">
         <p159:morph option="byObject"/>
       </p:transition>
     </mc:Choice>
-    <mc:Fallback>
+    <mc:Fallback xmlns="">
       <p:transition spd="slow">
         <p:fade/>
       </p:transition>
@@ -13908,7 +14779,62 @@
                 <a:ea typeface="Segoe UI" pitchFamily="34" charset="-122"/>
                 <a:cs typeface="Segoe UI" pitchFamily="34" charset="-120"/>
               </a:rPr>
-              <a:t>Triệt tiêu nhiễu: Kỹ thuật đặc trưng miền biến bài toán phân lớp phi tuyến phức tạp thành ranh giới quyết định tuyến tính rõ rệt.</a:t>
+              <a:t>Triệt tiêu nhiễu: Kỹ thuật đặc </a:t>
+            </a:r>
+            <a:r>
+              <a:rPr lang="en-US" sz="830" dirty="0" err="1">
+                <a:solidFill>
+                  <a:srgbClr val="1F2937"/>
+                </a:solidFill>
+                <a:latin typeface="Segoe UI" pitchFamily="34" charset="0"/>
+                <a:ea typeface="Segoe UI" pitchFamily="34" charset="-122"/>
+                <a:cs typeface="Segoe UI" pitchFamily="34" charset="-120"/>
+              </a:rPr>
+              <a:t>trưng</a:t>
+            </a:r>
+            <a:r>
+              <a:rPr lang="en-US" sz="830" dirty="0">
+                <a:solidFill>
+                  <a:srgbClr val="1F2937"/>
+                </a:solidFill>
+                <a:latin typeface="Segoe UI" pitchFamily="34" charset="0"/>
+                <a:ea typeface="Segoe UI" pitchFamily="34" charset="-122"/>
+                <a:cs typeface="Segoe UI" pitchFamily="34" charset="-120"/>
+              </a:rPr>
+              <a:t> </a:t>
+            </a:r>
+            <a:r>
+              <a:rPr lang="en-US" sz="830" dirty="0" err="1" smtClean="0">
+                <a:solidFill>
+                  <a:srgbClr val="1F2937"/>
+                </a:solidFill>
+                <a:latin typeface="Segoe UI" pitchFamily="34" charset="0"/>
+                <a:ea typeface="Segoe UI" pitchFamily="34" charset="-122"/>
+                <a:cs typeface="Segoe UI" pitchFamily="34" charset="-120"/>
+              </a:rPr>
+              <a:t>biến</a:t>
+            </a:r>
+            <a:r>
+              <a:rPr lang="en-US" sz="830" dirty="0" smtClean="0">
+                <a:solidFill>
+                  <a:srgbClr val="1F2937"/>
+                </a:solidFill>
+                <a:latin typeface="Segoe UI" pitchFamily="34" charset="0"/>
+                <a:ea typeface="Segoe UI" pitchFamily="34" charset="-122"/>
+                <a:cs typeface="Segoe UI" pitchFamily="34" charset="-120"/>
+              </a:rPr>
+              <a:t> </a:t>
+            </a:r>
+            <a:r>
+              <a:rPr lang="en-US" sz="830" dirty="0">
+                <a:solidFill>
+                  <a:srgbClr val="1F2937"/>
+                </a:solidFill>
+                <a:latin typeface="Segoe UI" pitchFamily="34" charset="0"/>
+                <a:ea typeface="Segoe UI" pitchFamily="34" charset="-122"/>
+                <a:cs typeface="Segoe UI" pitchFamily="34" charset="-120"/>
+              </a:rPr>
+              <a:t>bài toán phân lớp phi tuyến phức tạp thành ranh giới quyết định tuyến tính rõ rệt.</a:t>
             </a:r>
             <a:endParaRPr lang="en-US" sz="830" dirty="0"/>
           </a:p>
@@ -13919,13 +14845,13 @@
   <p:clrMapOvr>
     <a:masterClrMapping/>
   </p:clrMapOvr>
-  <mc:AlternateContent xmlns:mc="http://schemas.openxmlformats.org/markup-compatibility/2006">
-    <mc:Choice xmlns:p159="http://schemas.microsoft.com/office/powerpoint/2015/09/main" Requires="p159">
+  <mc:AlternateContent xmlns:mc="http://schemas.openxmlformats.org/markup-compatibility/2006" xmlns:p159="http://schemas.microsoft.com/office/powerpoint/2015/09/main">
+    <mc:Choice Requires="p159">
       <p:transition xmlns:p14="http://schemas.microsoft.com/office/powerpoint/2010/main" spd="slow" p14:dur="2000">
         <p159:morph option="byObject"/>
       </p:transition>
     </mc:Choice>
-    <mc:Fallback>
+    <mc:Fallback xmlns="">
       <p:transition spd="slow">
         <p:fade/>
       </p:transition>
@@ -15937,13 +16863,13 @@
   <p:clrMapOvr>
     <a:masterClrMapping/>
   </p:clrMapOvr>
-  <mc:AlternateContent xmlns:mc="http://schemas.openxmlformats.org/markup-compatibility/2006">
-    <mc:Choice xmlns:p159="http://schemas.microsoft.com/office/powerpoint/2015/09/main" Requires="p159">
+  <mc:AlternateContent xmlns:mc="http://schemas.openxmlformats.org/markup-compatibility/2006" xmlns:p159="http://schemas.microsoft.com/office/powerpoint/2015/09/main">
+    <mc:Choice Requires="p159">
       <p:transition xmlns:p14="http://schemas.microsoft.com/office/powerpoint/2010/main" spd="slow" p14:dur="2000">
         <p159:morph option="byObject"/>
       </p:transition>
     </mc:Choice>
-    <mc:Fallback>
+    <mc:Fallback xmlns="">
       <p:transition spd="slow">
         <p:fade/>
       </p:transition>
@@ -16295,13 +17221,13 @@
   <p:clrMapOvr>
     <a:masterClrMapping/>
   </p:clrMapOvr>
-  <mc:AlternateContent xmlns:mc="http://schemas.openxmlformats.org/markup-compatibility/2006">
-    <mc:Choice xmlns:p14="http://schemas.microsoft.com/office/powerpoint/2010/main" Requires="p14">
+  <mc:AlternateContent xmlns:mc="http://schemas.openxmlformats.org/markup-compatibility/2006" xmlns:p14="http://schemas.microsoft.com/office/powerpoint/2010/main">
+    <mc:Choice Requires="p14">
       <p:transition spd="slow" p14:dur="1200">
         <p14:prism/>
       </p:transition>
     </mc:Choice>
-    <mc:Fallback>
+    <mc:Fallback xmlns="">
       <p:transition spd="slow">
         <p:fade/>
       </p:transition>
@@ -16738,12 +17664,28 @@
 </a:t>
             </a:r>
             <a:r>
+              <a:rPr lang="en-US" sz="1000" dirty="0" err="1" smtClean="0">
+                <a:solidFill>
+                  <a:srgbClr val="4B5563"/>
+                </a:solidFill>
+              </a:rPr>
+              <a:t>Phân</a:t>
+            </a:r>
+            <a:r>
+              <a:rPr lang="en-US" sz="1000" dirty="0" smtClean="0">
+                <a:solidFill>
+                  <a:srgbClr val="4B5563"/>
+                </a:solidFill>
+              </a:rPr>
+              <a:t> </a:t>
+            </a:r>
+            <a:r>
               <a:rPr lang="en-US" sz="1000" dirty="0">
                 <a:solidFill>
                   <a:srgbClr val="4B5563"/>
                 </a:solidFill>
               </a:rPr>
-              <a:t>Khu biệt loại giao dịch, dấu vết rút cạn số dư và 14 engineered features.</a:t>
+              <a:t>biệt loại giao dịch, dấu vết rút cạn số dư và 14 engineered features.</a:t>
             </a:r>
             <a:endParaRPr lang="en-US" sz="1250" dirty="0"/>
           </a:p>
@@ -16856,7 +17798,23 @@
                   <a:srgbClr val="4B5563"/>
                 </a:solidFill>
               </a:rPr>
-              <a:t>Quy chuẩn Leak-Free, Random Forest vs. XGBoost và Deep Autoencoder.</a:t>
+              <a:t>Quy chuẩn Leak-Free, Random </a:t>
+            </a:r>
+            <a:r>
+              <a:rPr lang="en-US" sz="1000" dirty="0" smtClean="0">
+                <a:solidFill>
+                  <a:srgbClr val="4B5563"/>
+                </a:solidFill>
+              </a:rPr>
+              <a:t>Forest, </a:t>
+            </a:r>
+            <a:r>
+              <a:rPr lang="en-US" sz="1000" dirty="0">
+                <a:solidFill>
+                  <a:srgbClr val="4B5563"/>
+                </a:solidFill>
+              </a:rPr>
+              <a:t>XGBoost và Deep Autoencoder.</a:t>
             </a:r>
             <a:endParaRPr lang="en-US" sz="1250" dirty="0"/>
           </a:p>
@@ -17073,7 +18031,63 @@
                   <a:srgbClr val="21295C"/>
                 </a:solidFill>
               </a:rPr>
-              <a:t>Hệ thống Demo &amp; Định hướng Tương lai
+              <a:t>Hệ thống Demo &amp; Định </a:t>
+            </a:r>
+            <a:r>
+              <a:rPr lang="en-US" sz="1250" b="1" dirty="0" err="1">
+                <a:solidFill>
+                  <a:srgbClr val="21295C"/>
+                </a:solidFill>
+              </a:rPr>
+              <a:t>hướng</a:t>
+            </a:r>
+            <a:r>
+              <a:rPr lang="en-US" sz="1250" b="1" dirty="0">
+                <a:solidFill>
+                  <a:srgbClr val="21295C"/>
+                </a:solidFill>
+              </a:rPr>
+              <a:t> </a:t>
+            </a:r>
+            <a:r>
+              <a:rPr lang="en-US" sz="1250" b="1" dirty="0" err="1">
+                <a:solidFill>
+                  <a:srgbClr val="21295C"/>
+                </a:solidFill>
+              </a:rPr>
+              <a:t>p</a:t>
+            </a:r>
+            <a:r>
+              <a:rPr lang="en-US" sz="1250" b="1" dirty="0" err="1" smtClean="0">
+                <a:solidFill>
+                  <a:srgbClr val="21295C"/>
+                </a:solidFill>
+              </a:rPr>
+              <a:t>hát</a:t>
+            </a:r>
+            <a:r>
+              <a:rPr lang="en-US" sz="1250" b="1" dirty="0" smtClean="0">
+                <a:solidFill>
+                  <a:srgbClr val="21295C"/>
+                </a:solidFill>
+              </a:rPr>
+              <a:t> </a:t>
+            </a:r>
+            <a:r>
+              <a:rPr lang="en-US" sz="1250" b="1" dirty="0" err="1" smtClean="0">
+                <a:solidFill>
+                  <a:srgbClr val="21295C"/>
+                </a:solidFill>
+              </a:rPr>
+              <a:t>triển</a:t>
+            </a:r>
+            <a:r>
+              <a:rPr lang="en-US" sz="1250" b="1" dirty="0">
+                <a:solidFill>
+                  <a:srgbClr val="21295C"/>
+                </a:solidFill>
+              </a:rPr>
+              <a:t>
 </a:t>
             </a:r>
             <a:r>
@@ -17198,7 +18212,62 @@
                 <a:ea typeface="Segoe UI" pitchFamily="34" charset="-122"/>
                 <a:cs typeface="Segoe UI" pitchFamily="34" charset="-120"/>
               </a:rPr>
-              <a:t>Hệ thống Demo Streamlit &amp; Lộ trình Nghiên cứu Tương lai</a:t>
+              <a:t>Hệ thống Demo Streamlit &amp; </a:t>
+            </a:r>
+            <a:r>
+              <a:rPr lang="en-US" sz="1900" b="1" dirty="0" err="1" smtClean="0">
+                <a:solidFill>
+                  <a:srgbClr val="21295C"/>
+                </a:solidFill>
+                <a:latin typeface="Segoe UI" pitchFamily="34" charset="0"/>
+                <a:ea typeface="Segoe UI" pitchFamily="34" charset="-122"/>
+                <a:cs typeface="Segoe UI" pitchFamily="34" charset="-120"/>
+              </a:rPr>
+              <a:t>Hướng</a:t>
+            </a:r>
+            <a:r>
+              <a:rPr lang="en-US" sz="1900" b="1" dirty="0" smtClean="0">
+                <a:solidFill>
+                  <a:srgbClr val="21295C"/>
+                </a:solidFill>
+                <a:latin typeface="Segoe UI" pitchFamily="34" charset="0"/>
+                <a:ea typeface="Segoe UI" pitchFamily="34" charset="-122"/>
+                <a:cs typeface="Segoe UI" pitchFamily="34" charset="-120"/>
+              </a:rPr>
+              <a:t> </a:t>
+            </a:r>
+            <a:r>
+              <a:rPr lang="en-US" sz="1900" b="1" dirty="0" err="1" smtClean="0">
+                <a:solidFill>
+                  <a:srgbClr val="21295C"/>
+                </a:solidFill>
+                <a:latin typeface="Segoe UI" pitchFamily="34" charset="0"/>
+                <a:ea typeface="Segoe UI" pitchFamily="34" charset="-122"/>
+                <a:cs typeface="Segoe UI" pitchFamily="34" charset="-120"/>
+              </a:rPr>
+              <a:t>phát</a:t>
+            </a:r>
+            <a:r>
+              <a:rPr lang="en-US" sz="1900" b="1" dirty="0" smtClean="0">
+                <a:solidFill>
+                  <a:srgbClr val="21295C"/>
+                </a:solidFill>
+                <a:latin typeface="Segoe UI" pitchFamily="34" charset="0"/>
+                <a:ea typeface="Segoe UI" pitchFamily="34" charset="-122"/>
+                <a:cs typeface="Segoe UI" pitchFamily="34" charset="-120"/>
+              </a:rPr>
+              <a:t> </a:t>
+            </a:r>
+            <a:r>
+              <a:rPr lang="en-US" sz="1900" b="1" dirty="0" err="1" smtClean="0">
+                <a:solidFill>
+                  <a:srgbClr val="21295C"/>
+                </a:solidFill>
+                <a:latin typeface="Segoe UI" pitchFamily="34" charset="0"/>
+                <a:ea typeface="Segoe UI" pitchFamily="34" charset="-122"/>
+                <a:cs typeface="Segoe UI" pitchFamily="34" charset="-120"/>
+              </a:rPr>
+              <a:t>triển</a:t>
             </a:r>
             <a:endParaRPr lang="en-US" sz="1900" dirty="0"/>
           </a:p>
@@ -17815,7 +18884,7 @@
         </p:spPr>
         <p:txBody>
           <a:bodyPr wrap="square" lIns="25400" tIns="50800" rIns="50800" bIns="25400" rtlCol="0" anchor="ctr">
-            <a:normAutofit/>
+            <a:normAutofit lnSpcReduction="10000"/>
           </a:bodyPr>
           <a:lstStyle/>
           <a:p>
@@ -17973,15 +19042,54 @@
               <a:buNone/>
             </a:pPr>
             <a:r>
-              <a:rPr lang="en-US" sz="920" b="1" dirty="0">
+              <a:rPr lang="en-US" sz="920" b="1" dirty="0" err="1" smtClean="0">
                 <a:solidFill>
                   <a:srgbClr val="21295C"/>
                 </a:solidFill>
                 <a:latin typeface="Segoe UI" pitchFamily="34" charset="0"/>
-                <a:ea typeface="Segoe UI" pitchFamily="34" charset="-122"/>
                 <a:cs typeface="Segoe UI" pitchFamily="34" charset="-120"/>
               </a:rPr>
-              <a:t>Lộ trình Nghiên cứu Tương lai</a:t>
+              <a:t>Hướng</a:t>
+            </a:r>
+            <a:r>
+              <a:rPr lang="en-US" sz="920" b="1" dirty="0" smtClean="0">
+                <a:solidFill>
+                  <a:srgbClr val="21295C"/>
+                </a:solidFill>
+                <a:latin typeface="Segoe UI" pitchFamily="34" charset="0"/>
+                <a:cs typeface="Segoe UI" pitchFamily="34" charset="-120"/>
+              </a:rPr>
+              <a:t> </a:t>
+            </a:r>
+            <a:r>
+              <a:rPr lang="en-US" sz="920" b="1" dirty="0" err="1" smtClean="0">
+                <a:solidFill>
+                  <a:srgbClr val="21295C"/>
+                </a:solidFill>
+                <a:latin typeface="Segoe UI" pitchFamily="34" charset="0"/>
+                <a:cs typeface="Segoe UI" pitchFamily="34" charset="-120"/>
+              </a:rPr>
+              <a:t>phát</a:t>
+            </a:r>
+            <a:r>
+              <a:rPr lang="en-US" sz="920" b="1" dirty="0" smtClean="0">
+                <a:solidFill>
+                  <a:srgbClr val="21295C"/>
+                </a:solidFill>
+                <a:latin typeface="Segoe UI" pitchFamily="34" charset="0"/>
+                <a:cs typeface="Segoe UI" pitchFamily="34" charset="-120"/>
+              </a:rPr>
+              <a:t> </a:t>
+            </a:r>
+            <a:r>
+              <a:rPr lang="en-US" sz="920" b="1" dirty="0" err="1" smtClean="0">
+                <a:solidFill>
+                  <a:srgbClr val="21295C"/>
+                </a:solidFill>
+                <a:latin typeface="Segoe UI" pitchFamily="34" charset="0"/>
+                <a:cs typeface="Segoe UI" pitchFamily="34" charset="-120"/>
+              </a:rPr>
+              <a:t>triển</a:t>
             </a:r>
             <a:endParaRPr lang="en-US" sz="920" dirty="0"/>
           </a:p>
@@ -18088,13 +19196,13 @@
   <p:clrMapOvr>
     <a:masterClrMapping/>
   </p:clrMapOvr>
-  <mc:AlternateContent xmlns:mc="http://schemas.openxmlformats.org/markup-compatibility/2006">
-    <mc:Choice xmlns:p14="http://schemas.microsoft.com/office/powerpoint/2010/main" Requires="p14">
+  <mc:AlternateContent xmlns:mc="http://schemas.openxmlformats.org/markup-compatibility/2006" xmlns:p14="http://schemas.microsoft.com/office/powerpoint/2010/main">
+    <mc:Choice Requires="p14">
       <p:transition spd="slow" p14:dur="1300">
         <p14:pan dir="u"/>
       </p:transition>
     </mc:Choice>
-    <mc:Fallback>
+    <mc:Fallback xmlns="">
       <p:transition spd="slow">
         <p:fade/>
       </p:transition>
@@ -18482,7 +19590,139 @@
                 <a:ea typeface="Segoe UI" pitchFamily="34" charset="-122"/>
                 <a:cs typeface="Segoe UI" pitchFamily="34" charset="-120"/>
               </a:rPr>
-              <a:t> 09 rất mong nhận được những câu hỏi và góp ý quý báu từ Hội đồng!</a:t>
+              <a:t> 09 rất mong nhận được những câu hỏi và góp ý quý </a:t>
+            </a:r>
+            <a:r>
+              <a:rPr lang="en-US" sz="930" i="1" dirty="0" err="1">
+                <a:solidFill>
+                  <a:srgbClr val="FCD34D"/>
+                </a:solidFill>
+                <a:latin typeface="Segoe UI" pitchFamily="34" charset="0"/>
+                <a:ea typeface="Segoe UI" pitchFamily="34" charset="-122"/>
+                <a:cs typeface="Segoe UI" pitchFamily="34" charset="-120"/>
+              </a:rPr>
+              <a:t>báu</a:t>
+            </a:r>
+            <a:r>
+              <a:rPr lang="en-US" sz="930" i="1" dirty="0">
+                <a:solidFill>
+                  <a:srgbClr val="FCD34D"/>
+                </a:solidFill>
+                <a:latin typeface="Segoe UI" pitchFamily="34" charset="0"/>
+                <a:ea typeface="Segoe UI" pitchFamily="34" charset="-122"/>
+                <a:cs typeface="Segoe UI" pitchFamily="34" charset="-120"/>
+              </a:rPr>
+              <a:t> </a:t>
+            </a:r>
+            <a:r>
+              <a:rPr lang="en-US" sz="930" i="1" dirty="0" err="1" smtClean="0">
+                <a:solidFill>
+                  <a:srgbClr val="FCD34D"/>
+                </a:solidFill>
+                <a:latin typeface="Segoe UI" pitchFamily="34" charset="0"/>
+                <a:ea typeface="Segoe UI" pitchFamily="34" charset="-122"/>
+                <a:cs typeface="Segoe UI" pitchFamily="34" charset="-120"/>
+              </a:rPr>
+              <a:t>từ</a:t>
+            </a:r>
+            <a:r>
+              <a:rPr lang="en-US" sz="930" i="1" dirty="0">
+                <a:solidFill>
+                  <a:srgbClr val="FCD34D"/>
+                </a:solidFill>
+                <a:latin typeface="Segoe UI" pitchFamily="34" charset="0"/>
+                <a:ea typeface="Segoe UI" pitchFamily="34" charset="-122"/>
+                <a:cs typeface="Segoe UI" pitchFamily="34" charset="-120"/>
+              </a:rPr>
+              <a:t> </a:t>
+            </a:r>
+            <a:r>
+              <a:rPr lang="en-US" sz="930" i="1" dirty="0" err="1" smtClean="0">
+                <a:solidFill>
+                  <a:srgbClr val="FCD34D"/>
+                </a:solidFill>
+                <a:latin typeface="Segoe UI" pitchFamily="34" charset="0"/>
+                <a:ea typeface="Segoe UI" pitchFamily="34" charset="-122"/>
+                <a:cs typeface="Segoe UI" pitchFamily="34" charset="-120"/>
+              </a:rPr>
+              <a:t>Thầy</a:t>
+            </a:r>
+            <a:r>
+              <a:rPr lang="en-US" sz="930" i="1" dirty="0" smtClean="0">
+                <a:solidFill>
+                  <a:srgbClr val="FCD34D"/>
+                </a:solidFill>
+                <a:latin typeface="Segoe UI" pitchFamily="34" charset="0"/>
+                <a:ea typeface="Segoe UI" pitchFamily="34" charset="-122"/>
+                <a:cs typeface="Segoe UI" pitchFamily="34" charset="-120"/>
+              </a:rPr>
+              <a:t> </a:t>
+            </a:r>
+            <a:r>
+              <a:rPr lang="en-US" sz="930" i="1" dirty="0" err="1" smtClean="0">
+                <a:solidFill>
+                  <a:srgbClr val="FCD34D"/>
+                </a:solidFill>
+                <a:latin typeface="Segoe UI" pitchFamily="34" charset="0"/>
+                <a:ea typeface="Segoe UI" pitchFamily="34" charset="-122"/>
+                <a:cs typeface="Segoe UI" pitchFamily="34" charset="-120"/>
+              </a:rPr>
+              <a:t>và</a:t>
+            </a:r>
+            <a:r>
+              <a:rPr lang="en-US" sz="930" i="1" dirty="0" smtClean="0">
+                <a:solidFill>
+                  <a:srgbClr val="FCD34D"/>
+                </a:solidFill>
+                <a:latin typeface="Segoe UI" pitchFamily="34" charset="0"/>
+                <a:ea typeface="Segoe UI" pitchFamily="34" charset="-122"/>
+                <a:cs typeface="Segoe UI" pitchFamily="34" charset="-120"/>
+              </a:rPr>
+              <a:t> </a:t>
+            </a:r>
+            <a:r>
+              <a:rPr lang="en-US" sz="930" i="1" dirty="0" err="1" smtClean="0">
+                <a:solidFill>
+                  <a:srgbClr val="FCD34D"/>
+                </a:solidFill>
+                <a:latin typeface="Segoe UI" pitchFamily="34" charset="0"/>
+                <a:ea typeface="Segoe UI" pitchFamily="34" charset="-122"/>
+                <a:cs typeface="Segoe UI" pitchFamily="34" charset="-120"/>
+              </a:rPr>
+              <a:t>các</a:t>
+            </a:r>
+            <a:r>
+              <a:rPr lang="en-US" sz="930" i="1" dirty="0" smtClean="0">
+                <a:solidFill>
+                  <a:srgbClr val="FCD34D"/>
+                </a:solidFill>
+                <a:latin typeface="Segoe UI" pitchFamily="34" charset="0"/>
+                <a:ea typeface="Segoe UI" pitchFamily="34" charset="-122"/>
+                <a:cs typeface="Segoe UI" pitchFamily="34" charset="-120"/>
+              </a:rPr>
+              <a:t> </a:t>
+            </a:r>
+            <a:r>
+              <a:rPr lang="en-US" sz="930" i="1" smtClean="0">
+                <a:solidFill>
+                  <a:srgbClr val="FCD34D"/>
+                </a:solidFill>
+                <a:latin typeface="Segoe UI" pitchFamily="34" charset="0"/>
+                <a:ea typeface="Segoe UI" pitchFamily="34" charset="-122"/>
+                <a:cs typeface="Segoe UI" pitchFamily="34" charset="-120"/>
+              </a:rPr>
+              <a:t>bạn</a:t>
+            </a:r>
+            <a:r>
+              <a:rPr lang="en-US" sz="930" i="1" smtClean="0">
+                <a:solidFill>
+                  <a:srgbClr val="FCD34D"/>
+                </a:solidFill>
+                <a:latin typeface="Segoe UI" pitchFamily="34" charset="0"/>
+                <a:ea typeface="Segoe UI" pitchFamily="34" charset="-122"/>
+                <a:cs typeface="Segoe UI" pitchFamily="34" charset="-120"/>
+              </a:rPr>
+              <a:t>!</a:t>
             </a:r>
             <a:endParaRPr lang="en-US" sz="930" dirty="0"/>
           </a:p>
@@ -18493,13 +19733,13 @@
   <p:clrMapOvr>
     <a:masterClrMapping/>
   </p:clrMapOvr>
-  <mc:AlternateContent xmlns:mc="http://schemas.openxmlformats.org/markup-compatibility/2006">
-    <mc:Choice xmlns:p15="http://schemas.microsoft.com/office/powerpoint/2012/main" Requires="p15">
+  <mc:AlternateContent xmlns:mc="http://schemas.openxmlformats.org/markup-compatibility/2006" xmlns:p15="http://schemas.microsoft.com/office/powerpoint/2012/main">
+    <mc:Choice Requires="p15">
       <p:transition xmlns:p14="http://schemas.microsoft.com/office/powerpoint/2010/main" spd="slow" p14:dur="1250">
         <p15:prstTrans prst="airplane"/>
       </p:transition>
     </mc:Choice>
-    <mc:Fallback>
+    <mc:Fallback xmlns="">
       <p:transition spd="slow">
         <p:fade/>
       </p:transition>
@@ -18851,13 +20091,13 @@
   <p:clrMapOvr>
     <a:masterClrMapping/>
   </p:clrMapOvr>
-  <mc:AlternateContent xmlns:mc="http://schemas.openxmlformats.org/markup-compatibility/2006">
-    <mc:Choice xmlns:p14="http://schemas.microsoft.com/office/powerpoint/2010/main" Requires="p14">
+  <mc:AlternateContent xmlns:mc="http://schemas.openxmlformats.org/markup-compatibility/2006" xmlns:p14="http://schemas.microsoft.com/office/powerpoint/2010/main">
+    <mc:Choice Requires="p14">
       <p:transition spd="slow" p14:dur="1200">
         <p14:prism/>
       </p:transition>
     </mc:Choice>
-    <mc:Fallback>
+    <mc:Fallback xmlns="">
       <p:transition spd="slow">
         <p:fade/>
       </p:transition>
@@ -20429,7 +21669,7 @@
         </p:spPr>
         <p:txBody>
           <a:bodyPr wrap="square" lIns="25400" tIns="50800" rIns="50800" bIns="25400" rtlCol="0" anchor="ctr">
-            <a:normAutofit fontScale="92500" lnSpcReduction="20000"/>
+            <a:normAutofit fontScale="92500" lnSpcReduction="10000"/>
           </a:bodyPr>
           <a:lstStyle/>
           <a:p>
@@ -20476,7 +21716,95 @@
                 <a:ea typeface="Segoe UI" pitchFamily="34" charset="-122"/>
                 <a:cs typeface="Segoe UI" pitchFamily="34" charset="-120"/>
               </a:rPr>
-              <a:t>Thiết kế 14 domain features bắt trọn sai lệch số dư sổ cái.</a:t>
+              <a:t>Thiết kế 14 </a:t>
+            </a:r>
+            <a:r>
+              <a:rPr lang="en-US" sz="950" dirty="0" smtClean="0">
+                <a:solidFill>
+                  <a:srgbClr val="1F2937"/>
+                </a:solidFill>
+                <a:latin typeface="Segoe UI" pitchFamily="34" charset="0"/>
+                <a:ea typeface="Segoe UI" pitchFamily="34" charset="-122"/>
+                <a:cs typeface="Segoe UI" pitchFamily="34" charset="-120"/>
+              </a:rPr>
+              <a:t>features </a:t>
+            </a:r>
+            <a:r>
+              <a:rPr lang="en-US" sz="950" dirty="0">
+                <a:solidFill>
+                  <a:srgbClr val="1F2937"/>
+                </a:solidFill>
+                <a:latin typeface="Segoe UI" pitchFamily="34" charset="0"/>
+                <a:ea typeface="Segoe UI" pitchFamily="34" charset="-122"/>
+                <a:cs typeface="Segoe UI" pitchFamily="34" charset="-120"/>
+              </a:rPr>
+              <a:t>bắt trọn sai lệch số </a:t>
+            </a:r>
+            <a:r>
+              <a:rPr lang="en-US" sz="950" dirty="0" err="1">
+                <a:solidFill>
+                  <a:srgbClr val="1F2937"/>
+                </a:solidFill>
+                <a:latin typeface="Segoe UI" pitchFamily="34" charset="0"/>
+                <a:ea typeface="Segoe UI" pitchFamily="34" charset="-122"/>
+                <a:cs typeface="Segoe UI" pitchFamily="34" charset="-120"/>
+              </a:rPr>
+              <a:t>dư</a:t>
+            </a:r>
+            <a:r>
+              <a:rPr lang="en-US" sz="950" dirty="0">
+                <a:solidFill>
+                  <a:srgbClr val="1F2937"/>
+                </a:solidFill>
+                <a:latin typeface="Segoe UI" pitchFamily="34" charset="0"/>
+                <a:ea typeface="Segoe UI" pitchFamily="34" charset="-122"/>
+                <a:cs typeface="Segoe UI" pitchFamily="34" charset="-120"/>
+              </a:rPr>
+              <a:t> </a:t>
+            </a:r>
+            <a:r>
+              <a:rPr lang="en-US" sz="950" dirty="0" err="1" smtClean="0">
+                <a:solidFill>
+                  <a:srgbClr val="1F2937"/>
+                </a:solidFill>
+                <a:latin typeface="Segoe UI" pitchFamily="34" charset="0"/>
+                <a:ea typeface="Segoe UI" pitchFamily="34" charset="-122"/>
+                <a:cs typeface="Segoe UI" pitchFamily="34" charset="-120"/>
+              </a:rPr>
+              <a:t>tài</a:t>
+            </a:r>
+            <a:r>
+              <a:rPr lang="en-US" sz="950" dirty="0" smtClean="0">
+                <a:solidFill>
+                  <a:srgbClr val="1F2937"/>
+                </a:solidFill>
+                <a:latin typeface="Segoe UI" pitchFamily="34" charset="0"/>
+                <a:ea typeface="Segoe UI" pitchFamily="34" charset="-122"/>
+                <a:cs typeface="Segoe UI" pitchFamily="34" charset="-120"/>
+              </a:rPr>
+              <a:t> </a:t>
+            </a:r>
+            <a:r>
+              <a:rPr lang="en-US" sz="950" dirty="0" err="1" smtClean="0">
+                <a:solidFill>
+                  <a:srgbClr val="1F2937"/>
+                </a:solidFill>
+                <a:latin typeface="Segoe UI" pitchFamily="34" charset="0"/>
+                <a:ea typeface="Segoe UI" pitchFamily="34" charset="-122"/>
+                <a:cs typeface="Segoe UI" pitchFamily="34" charset="-120"/>
+              </a:rPr>
+              <a:t>khoản</a:t>
+            </a:r>
+            <a:r>
+              <a:rPr lang="en-US" sz="950" dirty="0" smtClean="0">
+                <a:solidFill>
+                  <a:srgbClr val="1F2937"/>
+                </a:solidFill>
+                <a:latin typeface="Segoe UI" pitchFamily="34" charset="0"/>
+                <a:ea typeface="Segoe UI" pitchFamily="34" charset="-122"/>
+                <a:cs typeface="Segoe UI" pitchFamily="34" charset="-120"/>
+              </a:rPr>
+              <a:t>.</a:t>
             </a:r>
             <a:endParaRPr lang="en-US" sz="950" dirty="0"/>
           </a:p>
@@ -20492,7 +21820,7 @@
               <a:buChar char="•"/>
             </a:pPr>
             <a:r>
-              <a:rPr lang="en-US" sz="950" dirty="0">
+              <a:rPr lang="en-US" sz="950" dirty="0" smtClean="0">
                 <a:solidFill>
                   <a:srgbClr val="1F2937"/>
                 </a:solidFill>
@@ -20500,7 +21828,40 @@
                 <a:ea typeface="Segoe UI" pitchFamily="34" charset="-122"/>
                 <a:cs typeface="Segoe UI" pitchFamily="34" charset="-120"/>
               </a:rPr>
-              <a:t>Đối chuẩn Ensemble Trees với Unsupervised Deep Autoencoder bắt Zero-Day.</a:t>
+              <a:t>So </a:t>
+            </a:r>
+            <a:r>
+              <a:rPr lang="en-US" sz="950" dirty="0" err="1" smtClean="0">
+                <a:solidFill>
+                  <a:srgbClr val="1F2937"/>
+                </a:solidFill>
+                <a:latin typeface="Segoe UI" pitchFamily="34" charset="0"/>
+                <a:ea typeface="Segoe UI" pitchFamily="34" charset="-122"/>
+                <a:cs typeface="Segoe UI" pitchFamily="34" charset="-120"/>
+              </a:rPr>
+              <a:t>sánh</a:t>
+            </a:r>
+            <a:r>
+              <a:rPr lang="en-US" sz="950" dirty="0" smtClean="0">
+                <a:solidFill>
+                  <a:srgbClr val="1F2937"/>
+                </a:solidFill>
+                <a:latin typeface="Segoe UI" pitchFamily="34" charset="0"/>
+                <a:ea typeface="Segoe UI" pitchFamily="34" charset="-122"/>
+                <a:cs typeface="Segoe UI" pitchFamily="34" charset="-120"/>
+              </a:rPr>
+              <a:t> </a:t>
+            </a:r>
+            <a:r>
+              <a:rPr lang="en-US" sz="950" dirty="0">
+                <a:solidFill>
+                  <a:srgbClr val="1F2937"/>
+                </a:solidFill>
+                <a:latin typeface="Segoe UI" pitchFamily="34" charset="0"/>
+                <a:ea typeface="Segoe UI" pitchFamily="34" charset="-122"/>
+                <a:cs typeface="Segoe UI" pitchFamily="34" charset="-120"/>
+              </a:rPr>
+              <a:t>Ensemble Trees với Unsupervised Deep Autoencoder bắt Zero-Day.</a:t>
             </a:r>
             <a:endParaRPr lang="en-US" sz="950" dirty="0"/>
           </a:p>
@@ -20535,13 +21896,13 @@
   <p:clrMapOvr>
     <a:masterClrMapping/>
   </p:clrMapOvr>
-  <mc:AlternateContent xmlns:mc="http://schemas.openxmlformats.org/markup-compatibility/2006">
-    <mc:Choice xmlns:p14="http://schemas.microsoft.com/office/powerpoint/2010/main" Requires="p14">
+  <mc:AlternateContent xmlns:mc="http://schemas.openxmlformats.org/markup-compatibility/2006" xmlns:p14="http://schemas.microsoft.com/office/powerpoint/2010/main">
+    <mc:Choice Requires="p14">
       <p:transition spd="slow" p14:dur="1300">
         <p14:pan dir="u"/>
       </p:transition>
     </mc:Choice>
-    <mc:Fallback>
+    <mc:Fallback xmlns="">
       <p:transition spd="slow">
         <p:fade/>
       </p:transition>
@@ -21141,7 +22502,31 @@
                   <a:srgbClr val="2563EB"/>
                 </a:solidFill>
               </a:rPr>
-              <a:t>11 → 14 Đặc trưng Miền</a:t>
+              <a:t>11 → 14 </a:t>
+            </a:r>
+            <a:r>
+              <a:rPr lang="en-US" sz="1350" b="1" dirty="0" err="1">
+                <a:solidFill>
+                  <a:srgbClr val="2563EB"/>
+                </a:solidFill>
+              </a:rPr>
+              <a:t>Đặc</a:t>
+            </a:r>
+            <a:r>
+              <a:rPr lang="en-US" sz="1350" b="1" dirty="0">
+                <a:solidFill>
+                  <a:srgbClr val="2563EB"/>
+                </a:solidFill>
+              </a:rPr>
+              <a:t> </a:t>
+            </a:r>
+            <a:r>
+              <a:rPr lang="en-US" sz="1350" b="1" dirty="0" err="1" smtClean="0">
+                <a:solidFill>
+                  <a:srgbClr val="2563EB"/>
+                </a:solidFill>
+              </a:rPr>
+              <a:t>trưng</a:t>
             </a:r>
             <a:endParaRPr lang="en-US" sz="1350" dirty="0"/>
           </a:p>
@@ -22618,13 +24003,13 @@
   <p:clrMapOvr>
     <a:masterClrMapping/>
   </p:clrMapOvr>
-  <mc:AlternateContent xmlns:mc="http://schemas.openxmlformats.org/markup-compatibility/2006">
-    <mc:Choice xmlns:p159="http://schemas.microsoft.com/office/powerpoint/2015/09/main" Requires="p159">
+  <mc:AlternateContent xmlns:mc="http://schemas.openxmlformats.org/markup-compatibility/2006" xmlns:p159="http://schemas.microsoft.com/office/powerpoint/2015/09/main">
+    <mc:Choice Requires="p159">
       <p:transition xmlns:p14="http://schemas.microsoft.com/office/powerpoint/2010/main" spd="slow" p14:dur="2000">
         <p159:morph option="byObject"/>
       </p:transition>
     </mc:Choice>
-    <mc:Fallback>
+    <mc:Fallback xmlns="">
       <p:transition spd="slow">
         <p:fade/>
       </p:transition>
@@ -22941,7 +24326,18 @@
                 <a:ea typeface="Segoe UI" pitchFamily="34" charset="-122"/>
                 <a:cs typeface="Segoe UI" pitchFamily="34" charset="-120"/>
               </a:rPr>
-              <a:t>Công thức Toán học của 14 Engineered Domain Features</a:t>
+              <a:t>Công thức Toán học của 14 Engineered </a:t>
+            </a:r>
+            <a:r>
+              <a:rPr lang="en-US" sz="1100" dirty="0" smtClean="0">
+                <a:solidFill>
+                  <a:srgbClr val="E2E8F0"/>
+                </a:solidFill>
+                <a:latin typeface="Segoe UI" pitchFamily="34" charset="0"/>
+                <a:ea typeface="Segoe UI" pitchFamily="34" charset="-122"/>
+                <a:cs typeface="Segoe UI" pitchFamily="34" charset="-120"/>
+              </a:rPr>
+              <a:t>Features</a:t>
             </a:r>
             <a:endParaRPr lang="en-US" sz="1100" dirty="0"/>
           </a:p>
@@ -22976,13 +24372,13 @@
   <p:clrMapOvr>
     <a:masterClrMapping/>
   </p:clrMapOvr>
-  <mc:AlternateContent xmlns:mc="http://schemas.openxmlformats.org/markup-compatibility/2006">
-    <mc:Choice xmlns:p14="http://schemas.microsoft.com/office/powerpoint/2010/main" Requires="p14">
+  <mc:AlternateContent xmlns:mc="http://schemas.openxmlformats.org/markup-compatibility/2006" xmlns:p14="http://schemas.microsoft.com/office/powerpoint/2010/main">
+    <mc:Choice Requires="p14">
       <p:transition spd="slow" p14:dur="1200">
         <p14:prism/>
       </p:transition>
     </mc:Choice>
-    <mc:Fallback>
+    <mc:Fallback xmlns="">
       <p:transition spd="slow">
         <p:fade/>
       </p:transition>
@@ -23329,7 +24725,63 @@
                   <a:srgbClr val="21295C"/>
                 </a:solidFill>
               </a:rPr>
-              <a:t>Phát hiện 1: Khu biệt Loại Giao dịch</a:t>
+              <a:t>Phát hiện 1: </a:t>
+            </a:r>
+            <a:r>
+              <a:rPr lang="en-US" sz="1100" b="1" dirty="0" err="1" smtClean="0">
+                <a:solidFill>
+                  <a:srgbClr val="21295C"/>
+                </a:solidFill>
+              </a:rPr>
+              <a:t>Khoanh</a:t>
+            </a:r>
+            <a:r>
+              <a:rPr lang="en-US" sz="1100" b="1" dirty="0" smtClean="0">
+                <a:solidFill>
+                  <a:srgbClr val="21295C"/>
+                </a:solidFill>
+              </a:rPr>
+              <a:t> </a:t>
+            </a:r>
+            <a:r>
+              <a:rPr lang="en-US" sz="1100" b="1" dirty="0" err="1" smtClean="0">
+                <a:solidFill>
+                  <a:srgbClr val="21295C"/>
+                </a:solidFill>
+              </a:rPr>
+              <a:t>vùng</a:t>
+            </a:r>
+            <a:r>
+              <a:rPr lang="en-US" sz="1100" b="1" dirty="0" smtClean="0">
+                <a:solidFill>
+                  <a:srgbClr val="21295C"/>
+                </a:solidFill>
+              </a:rPr>
+              <a:t> </a:t>
+            </a:r>
+            <a:r>
+              <a:rPr lang="en-US" sz="1100" b="1" dirty="0" err="1" smtClean="0">
+                <a:solidFill>
+                  <a:srgbClr val="21295C"/>
+                </a:solidFill>
+              </a:rPr>
+              <a:t>Loại</a:t>
+            </a:r>
+            <a:r>
+              <a:rPr lang="en-US" sz="1100" b="1" dirty="0" smtClean="0">
+                <a:solidFill>
+                  <a:srgbClr val="21295C"/>
+                </a:solidFill>
+              </a:rPr>
+              <a:t> </a:t>
+            </a:r>
+            <a:r>
+              <a:rPr lang="en-US" sz="1100" b="1" dirty="0">
+                <a:solidFill>
+                  <a:srgbClr val="21295C"/>
+                </a:solidFill>
+              </a:rPr>
+              <a:t>Giao dịch</a:t>
             </a:r>
             <a:endParaRPr lang="en-US" sz="1100" dirty="0"/>
           </a:p>
@@ -23741,7 +25193,63 @@
                   <a:srgbClr val="21295C"/>
                 </a:solidFill>
               </a:rPr>
-              <a:t>Phát hiện 3: Sai Lệch Sổ Cái Đích</a:t>
+              <a:t>Phát hiện 3: Sai </a:t>
+            </a:r>
+            <a:r>
+              <a:rPr lang="en-US" sz="1100" b="1" dirty="0" err="1">
+                <a:solidFill>
+                  <a:srgbClr val="21295C"/>
+                </a:solidFill>
+              </a:rPr>
+              <a:t>Lệch</a:t>
+            </a:r>
+            <a:r>
+              <a:rPr lang="en-US" sz="1100" b="1" dirty="0">
+                <a:solidFill>
+                  <a:srgbClr val="21295C"/>
+                </a:solidFill>
+              </a:rPr>
+              <a:t> </a:t>
+            </a:r>
+            <a:r>
+              <a:rPr lang="en-US" sz="1100" b="1" dirty="0" err="1" smtClean="0">
+                <a:solidFill>
+                  <a:srgbClr val="21295C"/>
+                </a:solidFill>
+              </a:rPr>
+              <a:t>số</a:t>
+            </a:r>
+            <a:r>
+              <a:rPr lang="en-US" sz="1100" b="1" dirty="0" smtClean="0">
+                <a:solidFill>
+                  <a:srgbClr val="21295C"/>
+                </a:solidFill>
+              </a:rPr>
+              <a:t> </a:t>
+            </a:r>
+            <a:r>
+              <a:rPr lang="en-US" sz="1100" b="1" dirty="0" err="1" smtClean="0">
+                <a:solidFill>
+                  <a:srgbClr val="21295C"/>
+                </a:solidFill>
+              </a:rPr>
+              <a:t>dư</a:t>
+            </a:r>
+            <a:r>
+              <a:rPr lang="en-US" sz="1100" b="1" dirty="0" smtClean="0">
+                <a:solidFill>
+                  <a:srgbClr val="21295C"/>
+                </a:solidFill>
+              </a:rPr>
+              <a:t> </a:t>
+            </a:r>
+            <a:r>
+              <a:rPr lang="en-US" sz="1100" b="1" dirty="0" err="1" smtClean="0">
+                <a:solidFill>
+                  <a:srgbClr val="21295C"/>
+                </a:solidFill>
+              </a:rPr>
+              <a:t>đích</a:t>
             </a:r>
             <a:endParaRPr lang="en-US" sz="1100" dirty="0"/>
           </a:p>
@@ -23827,13 +25335,13 @@
   <p:clrMapOvr>
     <a:masterClrMapping/>
   </p:clrMapOvr>
-  <mc:AlternateContent xmlns:mc="http://schemas.openxmlformats.org/markup-compatibility/2006">
-    <mc:Choice xmlns:p14="http://schemas.microsoft.com/office/powerpoint/2010/main" Requires="p14">
+  <mc:AlternateContent xmlns:mc="http://schemas.openxmlformats.org/markup-compatibility/2006" xmlns:p14="http://schemas.microsoft.com/office/powerpoint/2010/main">
+    <mc:Choice Requires="p14">
       <p:transition spd="slow" p14:dur="1300">
         <p14:pan dir="u"/>
       </p:transition>
     </mc:Choice>
-    <mc:Fallback>
+    <mc:Fallback xmlns="">
       <p:transition spd="slow">
         <p:fade/>
       </p:transition>
@@ -23941,7 +25449,62 @@
                 <a:ea typeface="Segoe UI" pitchFamily="34" charset="-122"/>
                 <a:cs typeface="Segoe UI" pitchFamily="34" charset="-120"/>
               </a:rPr>
-              <a:t>Kỹ thuật Đặc trưng: 14 Thuộc tính Miền Cốt lõi</a:t>
+              <a:t>Kỹ thuật Đặc trưng: 14 Thuộc </a:t>
+            </a:r>
+            <a:r>
+              <a:rPr lang="en-US" sz="1900" b="1" dirty="0" err="1">
+                <a:solidFill>
+                  <a:srgbClr val="21295C"/>
+                </a:solidFill>
+                <a:latin typeface="Segoe UI" pitchFamily="34" charset="0"/>
+                <a:ea typeface="Segoe UI" pitchFamily="34" charset="-122"/>
+                <a:cs typeface="Segoe UI" pitchFamily="34" charset="-120"/>
+              </a:rPr>
+              <a:t>tính</a:t>
+            </a:r>
+            <a:r>
+              <a:rPr lang="en-US" sz="1900" b="1" dirty="0">
+                <a:solidFill>
+                  <a:srgbClr val="21295C"/>
+                </a:solidFill>
+                <a:latin typeface="Segoe UI" pitchFamily="34" charset="0"/>
+                <a:ea typeface="Segoe UI" pitchFamily="34" charset="-122"/>
+                <a:cs typeface="Segoe UI" pitchFamily="34" charset="-120"/>
+              </a:rPr>
+              <a:t> </a:t>
+            </a:r>
+            <a:r>
+              <a:rPr lang="en-US" sz="1900" b="1" dirty="0" err="1" smtClean="0">
+                <a:solidFill>
+                  <a:srgbClr val="21295C"/>
+                </a:solidFill>
+                <a:latin typeface="Segoe UI" pitchFamily="34" charset="0"/>
+                <a:ea typeface="Segoe UI" pitchFamily="34" charset="-122"/>
+                <a:cs typeface="Segoe UI" pitchFamily="34" charset="-120"/>
+              </a:rPr>
+              <a:t>Cốt</a:t>
+            </a:r>
+            <a:r>
+              <a:rPr lang="en-US" sz="1900" b="1" dirty="0" smtClean="0">
+                <a:solidFill>
+                  <a:srgbClr val="21295C"/>
+                </a:solidFill>
+                <a:latin typeface="Segoe UI" pitchFamily="34" charset="0"/>
+                <a:ea typeface="Segoe UI" pitchFamily="34" charset="-122"/>
+                <a:cs typeface="Segoe UI" pitchFamily="34" charset="-120"/>
+              </a:rPr>
+              <a:t> </a:t>
+            </a:r>
+            <a:r>
+              <a:rPr lang="en-US" sz="1900" b="1" dirty="0">
+                <a:solidFill>
+                  <a:srgbClr val="21295C"/>
+                </a:solidFill>
+                <a:latin typeface="Segoe UI" pitchFamily="34" charset="0"/>
+                <a:ea typeface="Segoe UI" pitchFamily="34" charset="-122"/>
+                <a:cs typeface="Segoe UI" pitchFamily="34" charset="-120"/>
+              </a:rPr>
+              <a:t>lõi</a:t>
             </a:r>
             <a:endParaRPr lang="en-US" sz="1900" dirty="0"/>
           </a:p>
@@ -24590,7 +26153,7 @@
           <p:nvPr>
             <p:extLst>
               <p:ext uri="{D42A27DB-BD31-4B8C-83A1-F6EECF244321}">
-                <p14:modId xmlns:p14="http://schemas.microsoft.com/office/powerpoint/2010/main" val="1015034861"/>
+                <p14:modId xmlns:p14="http://schemas.microsoft.com/office/powerpoint/2010/main" val="689580509"/>
               </p:ext>
             </p:extLst>
           </p:nvPr>
@@ -25624,7 +27187,29 @@
                           <a:ea typeface="Segoe UI" pitchFamily="34" charset="-122"/>
                           <a:cs typeface="Segoe UI" pitchFamily="34" charset="-120"/>
                         </a:rPr>
-                        <a:t>Giờ trong ngày (0..23); 1 nếu giao dịch từ 0h - 5h sáng</a:t>
+                        <a:t>Giờ trong ngày (0..23</a:t>
+                      </a:r>
+                      <a:r>
+                        <a:rPr lang="en-US" sz="800" dirty="0" smtClean="0">
+                          <a:solidFill>
+                            <a:srgbClr val="1F2937"/>
+                          </a:solidFill>
+                          <a:latin typeface="Segoe UI" pitchFamily="34" charset="0"/>
+                          <a:ea typeface="Segoe UI" pitchFamily="34" charset="-122"/>
+                          <a:cs typeface="Segoe UI" pitchFamily="34" charset="-120"/>
+                        </a:rPr>
+                        <a:t>)/ </a:t>
+                      </a:r>
+                      <a:r>
+                        <a:rPr lang="en-US" sz="800" dirty="0">
+                          <a:solidFill>
+                            <a:srgbClr val="1F2937"/>
+                          </a:solidFill>
+                          <a:latin typeface="Segoe UI" pitchFamily="34" charset="0"/>
+                          <a:ea typeface="Segoe UI" pitchFamily="34" charset="-122"/>
+                          <a:cs typeface="Segoe UI" pitchFamily="34" charset="-120"/>
+                        </a:rPr>
+                        <a:t>1 nếu giao dịch từ 0h - 5h sáng</a:t>
                       </a:r>
                       <a:endParaRPr lang="en-US" sz="800" dirty="0">
                         <a:latin typeface="Segoe UI" charset="0"/>
@@ -25814,7 +27399,7 @@
               <a:buChar char="•"/>
             </a:pPr>
             <a:r>
-              <a:rPr lang="en-US" sz="900" dirty="0">
+              <a:rPr lang="en-US" sz="900" dirty="0" smtClean="0">
                 <a:solidFill>
                   <a:srgbClr val="1F2937"/>
                 </a:solidFill>
@@ -25822,7 +27407,18 @@
                 <a:ea typeface="Segoe UI" pitchFamily="34" charset="-122"/>
                 <a:cs typeface="Segoe UI" pitchFamily="34" charset="-120"/>
               </a:rPr>
-              <a:t>Domain Engineering tạo bước nhảy vọt so với chỉ dùng các trường số tiền gốc.</a:t>
+              <a:t>Engineering </a:t>
+            </a:r>
+            <a:r>
+              <a:rPr lang="en-US" sz="900" dirty="0">
+                <a:solidFill>
+                  <a:srgbClr val="1F2937"/>
+                </a:solidFill>
+                <a:latin typeface="Segoe UI" pitchFamily="34" charset="0"/>
+                <a:ea typeface="Segoe UI" pitchFamily="34" charset="-122"/>
+                <a:cs typeface="Segoe UI" pitchFamily="34" charset="-120"/>
+              </a:rPr>
+              <a:t>tạo bước nhảy vọt so với chỉ dùng các trường số tiền gốc.</a:t>
             </a:r>
             <a:endParaRPr lang="en-US" sz="900" dirty="0"/>
           </a:p>

</xml_diff>

<commit_message>
docs(slide): update academic presentation slides deck
</commit_message>
<xml_diff>
--- a/draft/fraud-detection/slide/[Nhom9]_Slide_FraudDetection_Academic_VN.pptx
+++ b/draft/fraud-detection/slide/[Nhom9]_Slide_FraudDetection_Academic_VN.pptx
@@ -8938,10 +8938,10 @@
                 <a:ea typeface="Segoe UI" pitchFamily="34" charset="-122"/>
                 <a:cs typeface="Segoe UI" pitchFamily="34" charset="-120"/>
               </a:rPr>
-              <a:t>đ</a:t>
-            </a:r>
-            <a:r>
-              <a:rPr lang="en-US" sz="1900" b="1" dirty="0" err="1" smtClean="0">
+              <a:t>đa</a:t>
+            </a:r>
+            <a:r>
+              <a:rPr lang="en-US" sz="1900" b="1" dirty="0" smtClean="0">
                 <a:solidFill>
                   <a:srgbClr val="21295C"/>
                 </a:solidFill>
@@ -8949,10 +8949,10 @@
                 <a:ea typeface="Segoe UI" pitchFamily="34" charset="-122"/>
                 <a:cs typeface="Segoe UI" pitchFamily="34" charset="-120"/>
               </a:rPr>
-              <a:t>a</a:t>
-            </a:r>
-            <a:r>
-              <a:rPr lang="en-US" sz="1900" b="1" dirty="0" smtClean="0">
+              <a:t> </a:t>
+            </a:r>
+            <a:r>
+              <a:rPr lang="en-US" sz="1900" b="1" dirty="0" err="1" smtClean="0">
                 <a:solidFill>
                   <a:srgbClr val="21295C"/>
                 </a:solidFill>
@@ -8960,29 +8960,7 @@
                 <a:ea typeface="Segoe UI" pitchFamily="34" charset="-122"/>
                 <a:cs typeface="Segoe UI" pitchFamily="34" charset="-120"/>
               </a:rPr>
-              <a:t> </a:t>
-            </a:r>
-            <a:r>
-              <a:rPr lang="en-US" sz="1900" b="1" dirty="0" err="1" smtClean="0">
-                <a:solidFill>
-                  <a:srgbClr val="21295C"/>
-                </a:solidFill>
-                <a:latin typeface="Segoe UI" pitchFamily="34" charset="0"/>
-                <a:ea typeface="Segoe UI" pitchFamily="34" charset="-122"/>
-                <a:cs typeface="Segoe UI" pitchFamily="34" charset="-120"/>
-              </a:rPr>
-              <a:t>c</a:t>
-            </a:r>
-            <a:r>
-              <a:rPr lang="en-US" sz="1900" b="1" dirty="0" err="1" smtClean="0">
-                <a:solidFill>
-                  <a:srgbClr val="21295C"/>
-                </a:solidFill>
-                <a:latin typeface="Segoe UI" pitchFamily="34" charset="0"/>
-                <a:ea typeface="Segoe UI" pitchFamily="34" charset="-122"/>
-                <a:cs typeface="Segoe UI" pitchFamily="34" charset="-120"/>
-              </a:rPr>
-              <a:t>hỉ</a:t>
+              <a:t>chỉ</a:t>
             </a:r>
             <a:r>
               <a:rPr lang="en-US" sz="1900" b="1" dirty="0" smtClean="0">
@@ -18383,419 +18361,6 @@
       </p:sp>
       <p:sp>
         <p:nvSpPr>
-          <p:cNvPr id="7" name="Shape 5"/>
-          <p:cNvSpPr/>
-          <p:nvPr/>
-        </p:nvSpPr>
-        <p:spPr>
-          <a:xfrm>
-            <a:off x="502920" y="987552"/>
-            <a:ext cx="5029200" cy="3584448"/>
-          </a:xfrm>
-          <a:prstGeom prst="roundRect">
-            <a:avLst>
-              <a:gd name="adj" fmla="val 3061"/>
-            </a:avLst>
-          </a:prstGeom>
-          <a:solidFill>
-            <a:srgbClr val="0F172A"/>
-          </a:solidFill>
-          <a:ln w="19050">
-            <a:solidFill>
-              <a:srgbClr val="3B82F6"/>
-            </a:solidFill>
-            <a:prstDash val="solid"/>
-          </a:ln>
-        </p:spPr>
-        <p:txBody>
-          <a:bodyPr/>
-          <a:lstStyle/>
-          <a:p>
-            <a:endParaRPr lang="en-VN"/>
-          </a:p>
-        </p:txBody>
-      </p:sp>
-      <p:sp>
-        <p:nvSpPr>
-          <p:cNvPr id="8" name="Shape 6"/>
-          <p:cNvSpPr/>
-          <p:nvPr/>
-        </p:nvSpPr>
-        <p:spPr>
-          <a:xfrm>
-            <a:off x="502920" y="987552"/>
-            <a:ext cx="5029200" cy="274320"/>
-          </a:xfrm>
-          <a:prstGeom prst="rect">
-            <a:avLst/>
-          </a:prstGeom>
-          <a:solidFill>
-            <a:srgbClr val="1E293B"/>
-          </a:solidFill>
-          <a:ln/>
-        </p:spPr>
-        <p:txBody>
-          <a:bodyPr/>
-          <a:lstStyle/>
-          <a:p>
-            <a:endParaRPr lang="en-VN"/>
-          </a:p>
-        </p:txBody>
-      </p:sp>
-      <p:sp>
-        <p:nvSpPr>
-          <p:cNvPr id="9" name="Text 7"/>
-          <p:cNvSpPr/>
-          <p:nvPr/>
-        </p:nvSpPr>
-        <p:spPr>
-          <a:xfrm>
-            <a:off x="640080" y="987552"/>
-            <a:ext cx="4754880" cy="274320"/>
-          </a:xfrm>
-          <a:prstGeom prst="rect">
-            <a:avLst/>
-          </a:prstGeom>
-          <a:noFill/>
-          <a:ln/>
-        </p:spPr>
-        <p:txBody>
-          <a:bodyPr wrap="square" rtlCol="0" anchor="ctr"/>
-          <a:lstStyle/>
-          <a:p>
-            <a:pPr marL="0" indent="0">
-              <a:buNone/>
-            </a:pPr>
-            <a:r>
-              <a:rPr lang="en-US" sz="880" b="1" dirty="0">
-                <a:solidFill>
-                  <a:srgbClr val="60A5FA"/>
-                </a:solidFill>
-                <a:latin typeface="Consolas" pitchFamily="34" charset="0"/>
-                <a:ea typeface="Consolas" pitchFamily="34" charset="-122"/>
-                <a:cs typeface="Consolas" pitchFamily="34" charset="-120"/>
-              </a:rPr>
-              <a:t>🔴 LIVE DEMO  •  Streamlit Real-Time Fraud Shield  |  Latency &lt; 0.5ms</a:t>
-            </a:r>
-            <a:endParaRPr lang="en-US" sz="880" dirty="0"/>
-          </a:p>
-        </p:txBody>
-      </p:sp>
-      <p:sp>
-        <p:nvSpPr>
-          <p:cNvPr id="10" name="Shape 8"/>
-          <p:cNvSpPr/>
-          <p:nvPr/>
-        </p:nvSpPr>
-        <p:spPr>
-          <a:xfrm>
-            <a:off x="676656" y="1325880"/>
-            <a:ext cx="4681728" cy="2633472"/>
-          </a:xfrm>
-          <a:prstGeom prst="rect">
-            <a:avLst/>
-          </a:prstGeom>
-          <a:solidFill>
-            <a:srgbClr val="0B1120"/>
-          </a:solidFill>
-          <a:ln w="19050">
-            <a:solidFill>
-              <a:srgbClr val="38BDF8"/>
-            </a:solidFill>
-            <a:prstDash val="solid"/>
-          </a:ln>
-        </p:spPr>
-        <p:txBody>
-          <a:bodyPr/>
-          <a:lstStyle/>
-          <a:p>
-            <a:endParaRPr lang="en-VN"/>
-          </a:p>
-        </p:txBody>
-      </p:sp>
-      <p:sp>
-        <p:nvSpPr>
-          <p:cNvPr id="11" name="Text 9"/>
-          <p:cNvSpPr/>
-          <p:nvPr/>
-        </p:nvSpPr>
-        <p:spPr>
-          <a:xfrm>
-            <a:off x="676656" y="1645920"/>
-            <a:ext cx="4681728" cy="594360"/>
-          </a:xfrm>
-          <a:prstGeom prst="rect">
-            <a:avLst/>
-          </a:prstGeom>
-          <a:noFill/>
-          <a:ln/>
-        </p:spPr>
-        <p:txBody>
-          <a:bodyPr wrap="square" rtlCol="0" anchor="ctr"/>
-          <a:lstStyle/>
-          <a:p>
-            <a:pPr marL="0" indent="0" algn="ctr">
-              <a:buNone/>
-            </a:pPr>
-            <a:r>
-              <a:rPr lang="en-US" sz="3600" b="1" dirty="0">
-                <a:solidFill>
-                  <a:srgbClr val="38BDF8"/>
-                </a:solidFill>
-              </a:rPr>
-              <a:t>▶</a:t>
-            </a:r>
-            <a:endParaRPr lang="en-US" sz="3600" dirty="0"/>
-          </a:p>
-        </p:txBody>
-      </p:sp>
-      <p:sp>
-        <p:nvSpPr>
-          <p:cNvPr id="12" name="Text 10"/>
-          <p:cNvSpPr/>
-          <p:nvPr/>
-        </p:nvSpPr>
-        <p:spPr>
-          <a:xfrm>
-            <a:off x="813816" y="2286000"/>
-            <a:ext cx="4407408" cy="502920"/>
-          </a:xfrm>
-          <a:prstGeom prst="rect">
-            <a:avLst/>
-          </a:prstGeom>
-          <a:noFill/>
-          <a:ln/>
-        </p:spPr>
-        <p:txBody>
-          <a:bodyPr wrap="square" rtlCol="0" anchor="ctr"/>
-          <a:lstStyle/>
-          <a:p>
-            <a:pPr marL="0" indent="0" algn="ctr">
-              <a:lnSpc>
-                <a:spcPct val="120000"/>
-              </a:lnSpc>
-              <a:buNone/>
-            </a:pPr>
-            <a:r>
-              <a:rPr lang="en-US" sz="1000" b="1" dirty="0">
-                <a:solidFill>
-                  <a:srgbClr val="E2E8F0"/>
-                </a:solidFill>
-                <a:latin typeface="Segoe UI" pitchFamily="34" charset="0"/>
-                <a:ea typeface="Segoe UI" pitchFamily="34" charset="-122"/>
-                <a:cs typeface="Segoe UI" pitchFamily="34" charset="-120"/>
-              </a:rPr>
-              <a:t>[ KHUNG CHÈN VIDEO DEMO STREAMLIT ]</a:t>
-            </a:r>
-            <a:endParaRPr lang="en-US" sz="1000" dirty="0"/>
-          </a:p>
-          <a:p>
-            <a:pPr marL="0" indent="0" algn="ctr">
-              <a:lnSpc>
-                <a:spcPct val="120000"/>
-              </a:lnSpc>
-              <a:buNone/>
-            </a:pPr>
-            <a:r>
-              <a:rPr lang="en-US" sz="1000" b="1" dirty="0">
-                <a:solidFill>
-                  <a:srgbClr val="E2E8F0"/>
-                </a:solidFill>
-                <a:latin typeface="Segoe UI" pitchFamily="34" charset="0"/>
-                <a:ea typeface="Segoe UI" pitchFamily="34" charset="-122"/>
-                <a:cs typeface="Segoe UI" pitchFamily="34" charset="-120"/>
-              </a:rPr>
-              <a:t>(Tỷ lệ Chuẩn 16:9 — 1920×1080 / 1280×720 MP4/GIF)</a:t>
-            </a:r>
-            <a:endParaRPr lang="en-US" sz="1000" dirty="0"/>
-          </a:p>
-        </p:txBody>
-      </p:sp>
-      <p:sp>
-        <p:nvSpPr>
-          <p:cNvPr id="13" name="Text 11"/>
-          <p:cNvSpPr/>
-          <p:nvPr/>
-        </p:nvSpPr>
-        <p:spPr>
-          <a:xfrm>
-            <a:off x="813816" y="2862072"/>
-            <a:ext cx="4407408" cy="228600"/>
-          </a:xfrm>
-          <a:prstGeom prst="rect">
-            <a:avLst/>
-          </a:prstGeom>
-          <a:noFill/>
-          <a:ln/>
-        </p:spPr>
-        <p:txBody>
-          <a:bodyPr wrap="square" rtlCol="0" anchor="ctr"/>
-          <a:lstStyle/>
-          <a:p>
-            <a:pPr marL="0" indent="0" algn="ctr">
-              <a:buNone/>
-            </a:pPr>
-            <a:r>
-              <a:rPr lang="en-US" sz="850" i="1" dirty="0">
-                <a:solidFill>
-                  <a:srgbClr val="94A3B8"/>
-                </a:solidFill>
-                <a:latin typeface="Segoe UI" pitchFamily="34" charset="0"/>
-                <a:ea typeface="Segoe UI" pitchFamily="34" charset="-122"/>
-                <a:cs typeface="Segoe UI" pitchFamily="34" charset="-120"/>
-              </a:rPr>
-              <a:t>Giao diện phân tích rủi ro thời gian thực &amp; Chấm điểm Batch CSV</a:t>
-            </a:r>
-            <a:endParaRPr lang="en-US" sz="850" dirty="0"/>
-          </a:p>
-        </p:txBody>
-      </p:sp>
-      <p:sp>
-        <p:nvSpPr>
-          <p:cNvPr id="14" name="Shape 12"/>
-          <p:cNvSpPr/>
-          <p:nvPr/>
-        </p:nvSpPr>
-        <p:spPr>
-          <a:xfrm>
-            <a:off x="2011680" y="3291840"/>
-            <a:ext cx="2011680" cy="292608"/>
-          </a:xfrm>
-          <a:prstGeom prst="roundRect">
-            <a:avLst>
-              <a:gd name="adj" fmla="val 25000"/>
-            </a:avLst>
-          </a:prstGeom>
-          <a:solidFill>
-            <a:srgbClr val="1E293B"/>
-          </a:solidFill>
-          <a:ln w="10160">
-            <a:solidFill>
-              <a:srgbClr val="64748B"/>
-            </a:solidFill>
-            <a:prstDash val="solid"/>
-          </a:ln>
-        </p:spPr>
-        <p:txBody>
-          <a:bodyPr/>
-          <a:lstStyle/>
-          <a:p>
-            <a:endParaRPr lang="en-VN"/>
-          </a:p>
-        </p:txBody>
-      </p:sp>
-      <p:sp>
-        <p:nvSpPr>
-          <p:cNvPr id="15" name="Text 13"/>
-          <p:cNvSpPr/>
-          <p:nvPr/>
-        </p:nvSpPr>
-        <p:spPr>
-          <a:xfrm>
-            <a:off x="2011680" y="3291840"/>
-            <a:ext cx="2011680" cy="292608"/>
-          </a:xfrm>
-          <a:prstGeom prst="rect">
-            <a:avLst/>
-          </a:prstGeom>
-          <a:noFill/>
-          <a:ln/>
-        </p:spPr>
-        <p:txBody>
-          <a:bodyPr wrap="square" rtlCol="0" anchor="ctr"/>
-          <a:lstStyle/>
-          <a:p>
-            <a:pPr marL="0" indent="0" algn="ctr">
-              <a:buNone/>
-            </a:pPr>
-            <a:r>
-              <a:rPr lang="en-US" sz="820" b="1" dirty="0">
-                <a:solidFill>
-                  <a:srgbClr val="38BDF8"/>
-                </a:solidFill>
-                <a:latin typeface="Consolas" pitchFamily="34" charset="0"/>
-                <a:ea typeface="Consolas" pitchFamily="34" charset="-122"/>
-                <a:cs typeface="Consolas" pitchFamily="34" charset="-120"/>
-              </a:rPr>
-              <a:t>HD 1080p  •  TỶ LỆ 16:9</a:t>
-            </a:r>
-            <a:endParaRPr lang="en-US" sz="820" dirty="0"/>
-          </a:p>
-        </p:txBody>
-      </p:sp>
-      <p:sp>
-        <p:nvSpPr>
-          <p:cNvPr id="16" name="Shape 14"/>
-          <p:cNvSpPr/>
-          <p:nvPr/>
-        </p:nvSpPr>
-        <p:spPr>
-          <a:xfrm>
-            <a:off x="640080" y="4023360"/>
-            <a:ext cx="4754880" cy="457200"/>
-          </a:xfrm>
-          <a:prstGeom prst="rect">
-            <a:avLst/>
-          </a:prstGeom>
-          <a:solidFill>
-            <a:srgbClr val="131C31"/>
-          </a:solidFill>
-          <a:ln w="12700">
-            <a:solidFill>
-              <a:srgbClr val="1E293B"/>
-            </a:solidFill>
-            <a:prstDash val="solid"/>
-          </a:ln>
-        </p:spPr>
-        <p:txBody>
-          <a:bodyPr/>
-          <a:lstStyle/>
-          <a:p>
-            <a:endParaRPr lang="en-VN"/>
-          </a:p>
-        </p:txBody>
-      </p:sp>
-      <p:sp>
-        <p:nvSpPr>
-          <p:cNvPr id="17" name="Text 15"/>
-          <p:cNvSpPr/>
-          <p:nvPr/>
-        </p:nvSpPr>
-        <p:spPr>
-          <a:xfrm>
-            <a:off x="685800" y="4023360"/>
-            <a:ext cx="4663440" cy="457200"/>
-          </a:xfrm>
-          <a:prstGeom prst="rect">
-            <a:avLst/>
-          </a:prstGeom>
-          <a:noFill/>
-          <a:ln/>
-        </p:spPr>
-        <p:txBody>
-          <a:bodyPr wrap="square" rtlCol="0" anchor="ctr"/>
-          <a:lstStyle/>
-          <a:p>
-            <a:pPr marL="0" indent="0" algn="ctr">
-              <a:buNone/>
-            </a:pPr>
-            <a:r>
-              <a:rPr lang="en-US" sz="780" dirty="0">
-                <a:solidFill>
-                  <a:srgbClr val="CBD5E1"/>
-                </a:solidFill>
-                <a:latin typeface="Consolas" pitchFamily="34" charset="0"/>
-                <a:ea typeface="Consolas" pitchFamily="34" charset="-122"/>
-                <a:cs typeface="Consolas" pitchFamily="34" charset="-120"/>
-              </a:rPr>
-              <a:t>3 Kịch bản: 1. Bình thường (Safe &lt; 0.1%)  |  2. Rút cạn số dư (Fraud &gt; 99.8%)  |  3. Batch Audit CSV</a:t>
-            </a:r>
-            <a:endParaRPr lang="en-US" sz="780" dirty="0"/>
-          </a:p>
-        </p:txBody>
-      </p:sp>
-      <p:sp>
-        <p:nvSpPr>
           <p:cNvPr id="18" name="Shape 16"/>
           <p:cNvSpPr/>
           <p:nvPr/>
@@ -19191,6 +18756,30 @@
           </a:p>
         </p:txBody>
       </p:sp>
+      <p:pic>
+        <p:nvPicPr>
+          <p:cNvPr id="24" name="Picture 23"/>
+          <p:cNvPicPr>
+            <a:picLocks noChangeAspect="1"/>
+          </p:cNvPicPr>
+          <p:nvPr/>
+        </p:nvPicPr>
+        <p:blipFill>
+          <a:blip r:embed="rId3"/>
+          <a:stretch>
+            <a:fillRect/>
+          </a:stretch>
+        </p:blipFill>
+        <p:spPr>
+          <a:xfrm>
+            <a:off x="502920" y="1563840"/>
+            <a:ext cx="5257800" cy="2354363"/>
+          </a:xfrm>
+          <a:prstGeom prst="rect">
+            <a:avLst/>
+          </a:prstGeom>
+        </p:spPr>
+      </p:pic>
     </p:spTree>
   </p:cSld>
   <p:clrMapOvr>
@@ -19703,7 +19292,7 @@
               <a:t> </a:t>
             </a:r>
             <a:r>
-              <a:rPr lang="en-US" sz="930" i="1" smtClean="0">
+              <a:rPr lang="en-US" sz="930" i="1" dirty="0" err="1" smtClean="0">
                 <a:solidFill>
                   <a:srgbClr val="FCD34D"/>
                 </a:solidFill>
@@ -19714,7 +19303,7 @@
               <a:t>bạn</a:t>
             </a:r>
             <a:r>
-              <a:rPr lang="en-US" sz="930" i="1" smtClean="0">
+              <a:rPr lang="en-US" sz="930" i="1" dirty="0" smtClean="0">
                 <a:solidFill>
                   <a:srgbClr val="FCD34D"/>
                 </a:solidFill>

</xml_diff>

<commit_message>
docs(slide): update academic presentation slides deck (#32)
Cập nhật file slide thuyết trình học thuật
[Nhom9]_Slide_FraudDetection_Academic_VN.pptx mới nhất từ local.
</commit_message>
<xml_diff>
--- a/draft/fraud-detection/slide/[Nhom9]_Slide_FraudDetection_Academic_VN.pptx
+++ b/draft/fraud-detection/slide/[Nhom9]_Slide_FraudDetection_Academic_VN.pptx
@@ -8938,10 +8938,10 @@
                 <a:ea typeface="Segoe UI" pitchFamily="34" charset="-122"/>
                 <a:cs typeface="Segoe UI" pitchFamily="34" charset="-120"/>
               </a:rPr>
-              <a:t>đ</a:t>
-            </a:r>
-            <a:r>
-              <a:rPr lang="en-US" sz="1900" b="1" dirty="0" err="1" smtClean="0">
+              <a:t>đa</a:t>
+            </a:r>
+            <a:r>
+              <a:rPr lang="en-US" sz="1900" b="1" dirty="0" smtClean="0">
                 <a:solidFill>
                   <a:srgbClr val="21295C"/>
                 </a:solidFill>
@@ -8949,10 +8949,10 @@
                 <a:ea typeface="Segoe UI" pitchFamily="34" charset="-122"/>
                 <a:cs typeface="Segoe UI" pitchFamily="34" charset="-120"/>
               </a:rPr>
-              <a:t>a</a:t>
-            </a:r>
-            <a:r>
-              <a:rPr lang="en-US" sz="1900" b="1" dirty="0" smtClean="0">
+              <a:t> </a:t>
+            </a:r>
+            <a:r>
+              <a:rPr lang="en-US" sz="1900" b="1" dirty="0" err="1" smtClean="0">
                 <a:solidFill>
                   <a:srgbClr val="21295C"/>
                 </a:solidFill>
@@ -8960,29 +8960,7 @@
                 <a:ea typeface="Segoe UI" pitchFamily="34" charset="-122"/>
                 <a:cs typeface="Segoe UI" pitchFamily="34" charset="-120"/>
               </a:rPr>
-              <a:t> </a:t>
-            </a:r>
-            <a:r>
-              <a:rPr lang="en-US" sz="1900" b="1" dirty="0" err="1" smtClean="0">
-                <a:solidFill>
-                  <a:srgbClr val="21295C"/>
-                </a:solidFill>
-                <a:latin typeface="Segoe UI" pitchFamily="34" charset="0"/>
-                <a:ea typeface="Segoe UI" pitchFamily="34" charset="-122"/>
-                <a:cs typeface="Segoe UI" pitchFamily="34" charset="-120"/>
-              </a:rPr>
-              <a:t>c</a:t>
-            </a:r>
-            <a:r>
-              <a:rPr lang="en-US" sz="1900" b="1" dirty="0" err="1" smtClean="0">
-                <a:solidFill>
-                  <a:srgbClr val="21295C"/>
-                </a:solidFill>
-                <a:latin typeface="Segoe UI" pitchFamily="34" charset="0"/>
-                <a:ea typeface="Segoe UI" pitchFamily="34" charset="-122"/>
-                <a:cs typeface="Segoe UI" pitchFamily="34" charset="-120"/>
-              </a:rPr>
-              <a:t>hỉ</a:t>
+              <a:t>chỉ</a:t>
             </a:r>
             <a:r>
               <a:rPr lang="en-US" sz="1900" b="1" dirty="0" smtClean="0">
@@ -18383,419 +18361,6 @@
       </p:sp>
       <p:sp>
         <p:nvSpPr>
-          <p:cNvPr id="7" name="Shape 5"/>
-          <p:cNvSpPr/>
-          <p:nvPr/>
-        </p:nvSpPr>
-        <p:spPr>
-          <a:xfrm>
-            <a:off x="502920" y="987552"/>
-            <a:ext cx="5029200" cy="3584448"/>
-          </a:xfrm>
-          <a:prstGeom prst="roundRect">
-            <a:avLst>
-              <a:gd name="adj" fmla="val 3061"/>
-            </a:avLst>
-          </a:prstGeom>
-          <a:solidFill>
-            <a:srgbClr val="0F172A"/>
-          </a:solidFill>
-          <a:ln w="19050">
-            <a:solidFill>
-              <a:srgbClr val="3B82F6"/>
-            </a:solidFill>
-            <a:prstDash val="solid"/>
-          </a:ln>
-        </p:spPr>
-        <p:txBody>
-          <a:bodyPr/>
-          <a:lstStyle/>
-          <a:p>
-            <a:endParaRPr lang="en-VN"/>
-          </a:p>
-        </p:txBody>
-      </p:sp>
-      <p:sp>
-        <p:nvSpPr>
-          <p:cNvPr id="8" name="Shape 6"/>
-          <p:cNvSpPr/>
-          <p:nvPr/>
-        </p:nvSpPr>
-        <p:spPr>
-          <a:xfrm>
-            <a:off x="502920" y="987552"/>
-            <a:ext cx="5029200" cy="274320"/>
-          </a:xfrm>
-          <a:prstGeom prst="rect">
-            <a:avLst/>
-          </a:prstGeom>
-          <a:solidFill>
-            <a:srgbClr val="1E293B"/>
-          </a:solidFill>
-          <a:ln/>
-        </p:spPr>
-        <p:txBody>
-          <a:bodyPr/>
-          <a:lstStyle/>
-          <a:p>
-            <a:endParaRPr lang="en-VN"/>
-          </a:p>
-        </p:txBody>
-      </p:sp>
-      <p:sp>
-        <p:nvSpPr>
-          <p:cNvPr id="9" name="Text 7"/>
-          <p:cNvSpPr/>
-          <p:nvPr/>
-        </p:nvSpPr>
-        <p:spPr>
-          <a:xfrm>
-            <a:off x="640080" y="987552"/>
-            <a:ext cx="4754880" cy="274320"/>
-          </a:xfrm>
-          <a:prstGeom prst="rect">
-            <a:avLst/>
-          </a:prstGeom>
-          <a:noFill/>
-          <a:ln/>
-        </p:spPr>
-        <p:txBody>
-          <a:bodyPr wrap="square" rtlCol="0" anchor="ctr"/>
-          <a:lstStyle/>
-          <a:p>
-            <a:pPr marL="0" indent="0">
-              <a:buNone/>
-            </a:pPr>
-            <a:r>
-              <a:rPr lang="en-US" sz="880" b="1" dirty="0">
-                <a:solidFill>
-                  <a:srgbClr val="60A5FA"/>
-                </a:solidFill>
-                <a:latin typeface="Consolas" pitchFamily="34" charset="0"/>
-                <a:ea typeface="Consolas" pitchFamily="34" charset="-122"/>
-                <a:cs typeface="Consolas" pitchFamily="34" charset="-120"/>
-              </a:rPr>
-              <a:t>🔴 LIVE DEMO  •  Streamlit Real-Time Fraud Shield  |  Latency &lt; 0.5ms</a:t>
-            </a:r>
-            <a:endParaRPr lang="en-US" sz="880" dirty="0"/>
-          </a:p>
-        </p:txBody>
-      </p:sp>
-      <p:sp>
-        <p:nvSpPr>
-          <p:cNvPr id="10" name="Shape 8"/>
-          <p:cNvSpPr/>
-          <p:nvPr/>
-        </p:nvSpPr>
-        <p:spPr>
-          <a:xfrm>
-            <a:off x="676656" y="1325880"/>
-            <a:ext cx="4681728" cy="2633472"/>
-          </a:xfrm>
-          <a:prstGeom prst="rect">
-            <a:avLst/>
-          </a:prstGeom>
-          <a:solidFill>
-            <a:srgbClr val="0B1120"/>
-          </a:solidFill>
-          <a:ln w="19050">
-            <a:solidFill>
-              <a:srgbClr val="38BDF8"/>
-            </a:solidFill>
-            <a:prstDash val="solid"/>
-          </a:ln>
-        </p:spPr>
-        <p:txBody>
-          <a:bodyPr/>
-          <a:lstStyle/>
-          <a:p>
-            <a:endParaRPr lang="en-VN"/>
-          </a:p>
-        </p:txBody>
-      </p:sp>
-      <p:sp>
-        <p:nvSpPr>
-          <p:cNvPr id="11" name="Text 9"/>
-          <p:cNvSpPr/>
-          <p:nvPr/>
-        </p:nvSpPr>
-        <p:spPr>
-          <a:xfrm>
-            <a:off x="676656" y="1645920"/>
-            <a:ext cx="4681728" cy="594360"/>
-          </a:xfrm>
-          <a:prstGeom prst="rect">
-            <a:avLst/>
-          </a:prstGeom>
-          <a:noFill/>
-          <a:ln/>
-        </p:spPr>
-        <p:txBody>
-          <a:bodyPr wrap="square" rtlCol="0" anchor="ctr"/>
-          <a:lstStyle/>
-          <a:p>
-            <a:pPr marL="0" indent="0" algn="ctr">
-              <a:buNone/>
-            </a:pPr>
-            <a:r>
-              <a:rPr lang="en-US" sz="3600" b="1" dirty="0">
-                <a:solidFill>
-                  <a:srgbClr val="38BDF8"/>
-                </a:solidFill>
-              </a:rPr>
-              <a:t>▶</a:t>
-            </a:r>
-            <a:endParaRPr lang="en-US" sz="3600" dirty="0"/>
-          </a:p>
-        </p:txBody>
-      </p:sp>
-      <p:sp>
-        <p:nvSpPr>
-          <p:cNvPr id="12" name="Text 10"/>
-          <p:cNvSpPr/>
-          <p:nvPr/>
-        </p:nvSpPr>
-        <p:spPr>
-          <a:xfrm>
-            <a:off x="813816" y="2286000"/>
-            <a:ext cx="4407408" cy="502920"/>
-          </a:xfrm>
-          <a:prstGeom prst="rect">
-            <a:avLst/>
-          </a:prstGeom>
-          <a:noFill/>
-          <a:ln/>
-        </p:spPr>
-        <p:txBody>
-          <a:bodyPr wrap="square" rtlCol="0" anchor="ctr"/>
-          <a:lstStyle/>
-          <a:p>
-            <a:pPr marL="0" indent="0" algn="ctr">
-              <a:lnSpc>
-                <a:spcPct val="120000"/>
-              </a:lnSpc>
-              <a:buNone/>
-            </a:pPr>
-            <a:r>
-              <a:rPr lang="en-US" sz="1000" b="1" dirty="0">
-                <a:solidFill>
-                  <a:srgbClr val="E2E8F0"/>
-                </a:solidFill>
-                <a:latin typeface="Segoe UI" pitchFamily="34" charset="0"/>
-                <a:ea typeface="Segoe UI" pitchFamily="34" charset="-122"/>
-                <a:cs typeface="Segoe UI" pitchFamily="34" charset="-120"/>
-              </a:rPr>
-              <a:t>[ KHUNG CHÈN VIDEO DEMO STREAMLIT ]</a:t>
-            </a:r>
-            <a:endParaRPr lang="en-US" sz="1000" dirty="0"/>
-          </a:p>
-          <a:p>
-            <a:pPr marL="0" indent="0" algn="ctr">
-              <a:lnSpc>
-                <a:spcPct val="120000"/>
-              </a:lnSpc>
-              <a:buNone/>
-            </a:pPr>
-            <a:r>
-              <a:rPr lang="en-US" sz="1000" b="1" dirty="0">
-                <a:solidFill>
-                  <a:srgbClr val="E2E8F0"/>
-                </a:solidFill>
-                <a:latin typeface="Segoe UI" pitchFamily="34" charset="0"/>
-                <a:ea typeface="Segoe UI" pitchFamily="34" charset="-122"/>
-                <a:cs typeface="Segoe UI" pitchFamily="34" charset="-120"/>
-              </a:rPr>
-              <a:t>(Tỷ lệ Chuẩn 16:9 — 1920×1080 / 1280×720 MP4/GIF)</a:t>
-            </a:r>
-            <a:endParaRPr lang="en-US" sz="1000" dirty="0"/>
-          </a:p>
-        </p:txBody>
-      </p:sp>
-      <p:sp>
-        <p:nvSpPr>
-          <p:cNvPr id="13" name="Text 11"/>
-          <p:cNvSpPr/>
-          <p:nvPr/>
-        </p:nvSpPr>
-        <p:spPr>
-          <a:xfrm>
-            <a:off x="813816" y="2862072"/>
-            <a:ext cx="4407408" cy="228600"/>
-          </a:xfrm>
-          <a:prstGeom prst="rect">
-            <a:avLst/>
-          </a:prstGeom>
-          <a:noFill/>
-          <a:ln/>
-        </p:spPr>
-        <p:txBody>
-          <a:bodyPr wrap="square" rtlCol="0" anchor="ctr"/>
-          <a:lstStyle/>
-          <a:p>
-            <a:pPr marL="0" indent="0" algn="ctr">
-              <a:buNone/>
-            </a:pPr>
-            <a:r>
-              <a:rPr lang="en-US" sz="850" i="1" dirty="0">
-                <a:solidFill>
-                  <a:srgbClr val="94A3B8"/>
-                </a:solidFill>
-                <a:latin typeface="Segoe UI" pitchFamily="34" charset="0"/>
-                <a:ea typeface="Segoe UI" pitchFamily="34" charset="-122"/>
-                <a:cs typeface="Segoe UI" pitchFamily="34" charset="-120"/>
-              </a:rPr>
-              <a:t>Giao diện phân tích rủi ro thời gian thực &amp; Chấm điểm Batch CSV</a:t>
-            </a:r>
-            <a:endParaRPr lang="en-US" sz="850" dirty="0"/>
-          </a:p>
-        </p:txBody>
-      </p:sp>
-      <p:sp>
-        <p:nvSpPr>
-          <p:cNvPr id="14" name="Shape 12"/>
-          <p:cNvSpPr/>
-          <p:nvPr/>
-        </p:nvSpPr>
-        <p:spPr>
-          <a:xfrm>
-            <a:off x="2011680" y="3291840"/>
-            <a:ext cx="2011680" cy="292608"/>
-          </a:xfrm>
-          <a:prstGeom prst="roundRect">
-            <a:avLst>
-              <a:gd name="adj" fmla="val 25000"/>
-            </a:avLst>
-          </a:prstGeom>
-          <a:solidFill>
-            <a:srgbClr val="1E293B"/>
-          </a:solidFill>
-          <a:ln w="10160">
-            <a:solidFill>
-              <a:srgbClr val="64748B"/>
-            </a:solidFill>
-            <a:prstDash val="solid"/>
-          </a:ln>
-        </p:spPr>
-        <p:txBody>
-          <a:bodyPr/>
-          <a:lstStyle/>
-          <a:p>
-            <a:endParaRPr lang="en-VN"/>
-          </a:p>
-        </p:txBody>
-      </p:sp>
-      <p:sp>
-        <p:nvSpPr>
-          <p:cNvPr id="15" name="Text 13"/>
-          <p:cNvSpPr/>
-          <p:nvPr/>
-        </p:nvSpPr>
-        <p:spPr>
-          <a:xfrm>
-            <a:off x="2011680" y="3291840"/>
-            <a:ext cx="2011680" cy="292608"/>
-          </a:xfrm>
-          <a:prstGeom prst="rect">
-            <a:avLst/>
-          </a:prstGeom>
-          <a:noFill/>
-          <a:ln/>
-        </p:spPr>
-        <p:txBody>
-          <a:bodyPr wrap="square" rtlCol="0" anchor="ctr"/>
-          <a:lstStyle/>
-          <a:p>
-            <a:pPr marL="0" indent="0" algn="ctr">
-              <a:buNone/>
-            </a:pPr>
-            <a:r>
-              <a:rPr lang="en-US" sz="820" b="1" dirty="0">
-                <a:solidFill>
-                  <a:srgbClr val="38BDF8"/>
-                </a:solidFill>
-                <a:latin typeface="Consolas" pitchFamily="34" charset="0"/>
-                <a:ea typeface="Consolas" pitchFamily="34" charset="-122"/>
-                <a:cs typeface="Consolas" pitchFamily="34" charset="-120"/>
-              </a:rPr>
-              <a:t>HD 1080p  •  TỶ LỆ 16:9</a:t>
-            </a:r>
-            <a:endParaRPr lang="en-US" sz="820" dirty="0"/>
-          </a:p>
-        </p:txBody>
-      </p:sp>
-      <p:sp>
-        <p:nvSpPr>
-          <p:cNvPr id="16" name="Shape 14"/>
-          <p:cNvSpPr/>
-          <p:nvPr/>
-        </p:nvSpPr>
-        <p:spPr>
-          <a:xfrm>
-            <a:off x="640080" y="4023360"/>
-            <a:ext cx="4754880" cy="457200"/>
-          </a:xfrm>
-          <a:prstGeom prst="rect">
-            <a:avLst/>
-          </a:prstGeom>
-          <a:solidFill>
-            <a:srgbClr val="131C31"/>
-          </a:solidFill>
-          <a:ln w="12700">
-            <a:solidFill>
-              <a:srgbClr val="1E293B"/>
-            </a:solidFill>
-            <a:prstDash val="solid"/>
-          </a:ln>
-        </p:spPr>
-        <p:txBody>
-          <a:bodyPr/>
-          <a:lstStyle/>
-          <a:p>
-            <a:endParaRPr lang="en-VN"/>
-          </a:p>
-        </p:txBody>
-      </p:sp>
-      <p:sp>
-        <p:nvSpPr>
-          <p:cNvPr id="17" name="Text 15"/>
-          <p:cNvSpPr/>
-          <p:nvPr/>
-        </p:nvSpPr>
-        <p:spPr>
-          <a:xfrm>
-            <a:off x="685800" y="4023360"/>
-            <a:ext cx="4663440" cy="457200"/>
-          </a:xfrm>
-          <a:prstGeom prst="rect">
-            <a:avLst/>
-          </a:prstGeom>
-          <a:noFill/>
-          <a:ln/>
-        </p:spPr>
-        <p:txBody>
-          <a:bodyPr wrap="square" rtlCol="0" anchor="ctr"/>
-          <a:lstStyle/>
-          <a:p>
-            <a:pPr marL="0" indent="0" algn="ctr">
-              <a:buNone/>
-            </a:pPr>
-            <a:r>
-              <a:rPr lang="en-US" sz="780" dirty="0">
-                <a:solidFill>
-                  <a:srgbClr val="CBD5E1"/>
-                </a:solidFill>
-                <a:latin typeface="Consolas" pitchFamily="34" charset="0"/>
-                <a:ea typeface="Consolas" pitchFamily="34" charset="-122"/>
-                <a:cs typeface="Consolas" pitchFamily="34" charset="-120"/>
-              </a:rPr>
-              <a:t>3 Kịch bản: 1. Bình thường (Safe &lt; 0.1%)  |  2. Rút cạn số dư (Fraud &gt; 99.8%)  |  3. Batch Audit CSV</a:t>
-            </a:r>
-            <a:endParaRPr lang="en-US" sz="780" dirty="0"/>
-          </a:p>
-        </p:txBody>
-      </p:sp>
-      <p:sp>
-        <p:nvSpPr>
           <p:cNvPr id="18" name="Shape 16"/>
           <p:cNvSpPr/>
           <p:nvPr/>
@@ -19191,6 +18756,30 @@
           </a:p>
         </p:txBody>
       </p:sp>
+      <p:pic>
+        <p:nvPicPr>
+          <p:cNvPr id="24" name="Picture 23"/>
+          <p:cNvPicPr>
+            <a:picLocks noChangeAspect="1"/>
+          </p:cNvPicPr>
+          <p:nvPr/>
+        </p:nvPicPr>
+        <p:blipFill>
+          <a:blip r:embed="rId3"/>
+          <a:stretch>
+            <a:fillRect/>
+          </a:stretch>
+        </p:blipFill>
+        <p:spPr>
+          <a:xfrm>
+            <a:off x="502920" y="1563840"/>
+            <a:ext cx="5257800" cy="2354363"/>
+          </a:xfrm>
+          <a:prstGeom prst="rect">
+            <a:avLst/>
+          </a:prstGeom>
+        </p:spPr>
+      </p:pic>
     </p:spTree>
   </p:cSld>
   <p:clrMapOvr>
@@ -19703,7 +19292,7 @@
               <a:t> </a:t>
             </a:r>
             <a:r>
-              <a:rPr lang="en-US" sz="930" i="1" smtClean="0">
+              <a:rPr lang="en-US" sz="930" i="1" dirty="0" err="1" smtClean="0">
                 <a:solidFill>
                   <a:srgbClr val="FCD34D"/>
                 </a:solidFill>
@@ -19714,7 +19303,7 @@
               <a:t>bạn</a:t>
             </a:r>
             <a:r>
-              <a:rPr lang="en-US" sz="930" i="1" smtClean="0">
+              <a:rPr lang="en-US" sz="930" i="1" dirty="0" smtClean="0">
                 <a:solidFill>
                   <a:srgbClr val="FCD34D"/>
                 </a:solidFill>

</xml_diff>

<commit_message>
fix(slide): align generator with Cam audit and restore formula/demo media
Co-authored-by: Cursor <cursoragent@cursor.com>
</commit_message>
<xml_diff>
--- a/draft/fraud-detection/slide/[Nhom9]_Slide_FraudDetection_Academic_VN.pptx
+++ b/draft/fraud-detection/slide/[Nhom9]_Slide_FraudDetection_Academic_VN.pptx
@@ -3824,7 +3824,7 @@
                   <a:srgbClr val="FFFFFF"/>
                 </a:solidFill>
               </a:rPr>
-              <a:t>B.2: Feature Eng.</a:t>
+              <a:t>B.2: Stratified Split</a:t>
             </a:r>
             <a:endParaRPr lang="en-US" sz="850" dirty="0"/>
           </a:p>
@@ -3865,7 +3865,7 @@
                   <a:srgbClr val="1F2937"/>
                 </a:solidFill>
               </a:rPr>
-              <a:t>Tính toán 14</a:t>
+              <a:t>Phân chia chuẩn</a:t>
             </a:r>
             <a:endParaRPr lang="en-US" sz="880" dirty="0"/>
           </a:p>
@@ -3882,7 +3882,7 @@
                   <a:srgbClr val="1F2937"/>
                 </a:solidFill>
               </a:rPr>
-              <a:t>engineered</a:t>
+              <a:t>80% Train /</a:t>
             </a:r>
             <a:endParaRPr lang="en-US" sz="880" dirty="0"/>
           </a:p>
@@ -3899,7 +3899,7 @@
                   <a:srgbClr val="1F2937"/>
                 </a:solidFill>
               </a:rPr>
-              <a:t>domain features</a:t>
+              <a:t>20% Test</a:t>
             </a:r>
             <a:endParaRPr lang="en-US" sz="880" dirty="0"/>
           </a:p>
@@ -4016,7 +4016,7 @@
                   <a:srgbClr val="FFFFFF"/>
                 </a:solidFill>
               </a:rPr>
-              <a:t>B.3: Stratified Split</a:t>
+              <a:t>B.3: Feature Eng.</a:t>
             </a:r>
             <a:endParaRPr lang="en-US" sz="850" dirty="0"/>
           </a:p>
@@ -4057,7 +4057,7 @@
                   <a:srgbClr val="1F2937"/>
                 </a:solidFill>
               </a:rPr>
-              <a:t>Phân chia chuẩn</a:t>
+              <a:t>7 đặc trưng dẫn xuất</a:t>
             </a:r>
             <a:endParaRPr lang="en-US" sz="880" dirty="0"/>
           </a:p>
@@ -4074,7 +4074,7 @@
                   <a:srgbClr val="1F2937"/>
                 </a:solidFill>
               </a:rPr>
-              <a:t>80% Train /</a:t>
+              <a:t>→ 14 đặc trưng</a:t>
             </a:r>
             <a:endParaRPr lang="en-US" sz="880" dirty="0"/>
           </a:p>
@@ -4091,7 +4091,7 @@
                   <a:srgbClr val="1F2937"/>
                 </a:solidFill>
               </a:rPr>
-              <a:t>20% Test</a:t>
+              <a:t>Scaler fit Train</a:t>
             </a:r>
             <a:endParaRPr lang="en-US" sz="880" dirty="0"/>
           </a:p>
@@ -4249,7 +4249,7 @@
                   <a:srgbClr val="1F2937"/>
                 </a:solidFill>
               </a:rPr>
-              <a:t>SMOTE / ADASYN</a:t>
+              <a:t>SMOTENC / ADASYN</a:t>
             </a:r>
             <a:endParaRPr lang="en-US" sz="880" dirty="0"/>
           </a:p>
@@ -4779,7 +4779,7 @@
                 <a:ea typeface="Segoe UI" pitchFamily="34" charset="-122"/>
                 <a:cs typeface="Segoe UI" pitchFamily="34" charset="-120"/>
               </a:rPr>
-              <a:t>Phân tách Tập Dữ liệu Tuyệt đối: Phân chia Stratified Train/Test (80/20) được thực hiện TRƯỚC BẤT KỲ bước resampling hay chuẩn hóa nào.</a:t>
+              <a:t>Không rò rỉ sang tập Test: Stratified Split 80/20 thực hiện TRƯỚC resampling và chuẩn hóa; scaler chỉ fit trên Train.</a:t>
             </a:r>
             <a:endParaRPr lang="en-US" sz="930" dirty="0"/>
           </a:p>
@@ -4803,7 +4803,7 @@
                 <a:ea typeface="Segoe UI" pitchFamily="34" charset="-122"/>
                 <a:cs typeface="Segoe UI" pitchFamily="34" charset="-120"/>
               </a:rPr>
-              <a:t>Resampling Phân lập: SMOTE / ADASYN tuyệt đối CHỈ áp dụng trên tập huấn luyện (Train fold). Tập Test hoàn toàn giữ nguyên phân bố tự nhiên (0.13% fraud).</a:t>
+              <a:t>Resampling chỉ trên Train (SMOTENC / ADASYN). Tập Test giữ nguyên phân bố sau downsample (4.11% fraud, 1,643 ca), không chứa mẫu nhân tạo.</a:t>
             </a:r>
             <a:endParaRPr lang="en-US" sz="930" dirty="0"/>
           </a:p>
@@ -4827,7 +4827,7 @@
                 <a:ea typeface="Segoe UI" pitchFamily="34" charset="-122"/>
                 <a:cs typeface="Segoe UI" pitchFamily="34" charset="-120"/>
               </a:rPr>
-              <a:t>Chuẩn hóa StandardScaler: Bộ biến đổi tỷ lệ chỉ được fit trên tập Train và transform mù trên tập Test, không rò rỉ bất kỳ thông tin trung bình/độ lệch chuẩn nào.</a:t>
+              <a:t>Giới hạn: oversampling chưa nằm trong từng fold CV nên điểm CV có thể lạc quan (báo cáo mục 4.8).</a:t>
             </a:r>
             <a:endParaRPr lang="en-US" sz="930" dirty="0"/>
           </a:p>
@@ -4851,7 +4851,7 @@
                 <a:ea typeface="Segoe UI" pitchFamily="34" charset="-122"/>
                 <a:cs typeface="Segoe UI" pitchFamily="34" charset="-120"/>
               </a:rPr>
-              <a:t>Không tối ưu Hyperparameter trên Test Set: Toàn bộ quá trình chọn ngưỡng và tune tham số đều tuân thủ Cross-Validation nội bộ trên tập Train.</a:t>
+              <a:t>Không tối ưu hyperparameter trên Test: chọn ngưỡng và tune tham số bằng Cross-Validation nội bộ trên tập Train.</a:t>
             </a:r>
             <a:endParaRPr lang="en-US" sz="930" dirty="0"/>
           </a:p>
@@ -5176,48 +5176,33 @@
           </a:ln>
         </p:spPr>
       </p:sp>
-      <p:sp>
-        <p:nvSpPr>
-          <p:cNvPr id="11" name="Text 9"/>
-          <p:cNvSpPr/>
-          <p:nvPr/>
-        </p:nvSpPr>
-        <p:spPr>
-          <a:xfrm>
-            <a:off x="685800" y="1463040"/>
-            <a:ext cx="3589020" cy="274320"/>
-          </a:xfrm>
-          <a:prstGeom prst="rect">
-            <a:avLst/>
-          </a:prstGeom>
-          <a:noFill/>
-          <a:ln/>
-        </p:spPr>
-        <p:txBody>
-          <a:bodyPr wrap="square" rtlCol="0" anchor="ctr"/>
-          <a:lstStyle/>
-          <a:p>
-            <a:pPr indent="0" marL="0">
-              <a:buNone/>
-            </a:pPr>
-            <a:r>
-              <a:rPr lang="en-US" sz="950" b="1" dirty="0">
-                <a:solidFill>
-                  <a:srgbClr val="2563EB"/>
-                </a:solidFill>
-                <a:latin typeface="Consolas" pitchFamily="34" charset="0"/>
-                <a:ea typeface="Consolas" pitchFamily="34" charset="-122"/>
-                <a:cs typeface="Consolas" pitchFamily="34" charset="-120"/>
-              </a:rPr>
-              <a:t>Gini(D) = 1 - ∑ (p_i)²</a:t>
-            </a:r>
-            <a:endParaRPr lang="en-US" sz="950" dirty="0"/>
-          </a:p>
-        </p:txBody>
-      </p:sp>
-      <p:sp>
-        <p:nvSpPr>
-          <p:cNvPr id="12" name="Shape 10"/>
+      <p:pic>
+        <p:nvPicPr>
+          <p:cNvPr id="11" name="Image 0" descr="D:\Trí tuệ nhân tạo\HK2\Trí tuệ nhân tạo\CS106-Team09-Fraud-Detection\draft\fraud-detection\slide\slide_assets\formula_rf_gini.png">    </p:cNvPr>
+          <p:cNvPicPr>
+            <a:picLocks noChangeAspect="1"/>
+          </p:cNvPicPr>
+          <p:nvPr/>
+        </p:nvPicPr>
+        <p:blipFill>
+          <a:blip r:embed="rId1"/>
+          <a:stretch>
+            <a:fillRect/>
+          </a:stretch>
+        </p:blipFill>
+        <p:spPr>
+          <a:xfrm>
+            <a:off x="905256" y="1463040"/>
+            <a:ext cx="2770632" cy="301752"/>
+          </a:xfrm>
+          <a:prstGeom prst="rect">
+            <a:avLst/>
+          </a:prstGeom>
+        </p:spPr>
+      </p:pic>
+      <p:sp>
+        <p:nvSpPr>
+          <p:cNvPr id="12" name="Shape 9"/>
           <p:cNvSpPr/>
           <p:nvPr/>
         </p:nvSpPr>
@@ -5242,7 +5227,7 @@
       </p:sp>
       <p:sp>
         <p:nvSpPr>
-          <p:cNvPr id="13" name="Text 11"/>
+          <p:cNvPr id="13" name="Text 10"/>
           <p:cNvSpPr/>
           <p:nvPr/>
         </p:nvSpPr>
@@ -5304,7 +5289,7 @@
       </p:sp>
       <p:sp>
         <p:nvSpPr>
-          <p:cNvPr id="14" name="Text 12"/>
+          <p:cNvPr id="14" name="Text 11"/>
           <p:cNvSpPr/>
           <p:nvPr/>
         </p:nvSpPr>
@@ -5417,7 +5402,7 @@
       </p:sp>
       <p:sp>
         <p:nvSpPr>
-          <p:cNvPr id="15" name="Shape 13"/>
+          <p:cNvPr id="15" name="Shape 12"/>
           <p:cNvSpPr/>
           <p:nvPr/>
         </p:nvSpPr>
@@ -5442,7 +5427,7 @@
       </p:sp>
       <p:sp>
         <p:nvSpPr>
-          <p:cNvPr id="16" name="Shape 14"/>
+          <p:cNvPr id="16" name="Shape 13"/>
           <p:cNvSpPr/>
           <p:nvPr/>
         </p:nvSpPr>
@@ -5462,7 +5447,7 @@
       </p:sp>
       <p:sp>
         <p:nvSpPr>
-          <p:cNvPr id="17" name="Text 15"/>
+          <p:cNvPr id="17" name="Text 14"/>
           <p:cNvSpPr/>
           <p:nvPr/>
         </p:nvSpPr>
@@ -5498,7 +5483,7 @@
       </p:sp>
       <p:sp>
         <p:nvSpPr>
-          <p:cNvPr id="18" name="Shape 16"/>
+          <p:cNvPr id="18" name="Shape 15"/>
           <p:cNvSpPr/>
           <p:nvPr/>
         </p:nvSpPr>
@@ -5521,48 +5506,33 @@
           </a:ln>
         </p:spPr>
       </p:sp>
-      <p:sp>
-        <p:nvSpPr>
-          <p:cNvPr id="19" name="Text 17"/>
-          <p:cNvSpPr/>
-          <p:nvPr/>
-        </p:nvSpPr>
-        <p:spPr>
-          <a:xfrm>
-            <a:off x="4869180" y="1463040"/>
-            <a:ext cx="3589020" cy="274320"/>
-          </a:xfrm>
-          <a:prstGeom prst="rect">
-            <a:avLst/>
-          </a:prstGeom>
-          <a:noFill/>
-          <a:ln/>
-        </p:spPr>
-        <p:txBody>
-          <a:bodyPr wrap="square" rtlCol="0" anchor="ctr"/>
-          <a:lstStyle/>
-          <a:p>
-            <a:pPr indent="0" marL="0">
-              <a:buNone/>
-            </a:pPr>
-            <a:r>
-              <a:rPr lang="en-US" sz="900" b="1" dirty="0">
-                <a:solidFill>
-                  <a:srgbClr val="2563EB"/>
-                </a:solidFill>
-                <a:latin typeface="Consolas" pitchFamily="34" charset="0"/>
-                <a:ea typeface="Consolas" pitchFamily="34" charset="-122"/>
-                <a:cs typeface="Consolas" pitchFamily="34" charset="-120"/>
-              </a:rPr>
-              <a:t>Obj^(t) ≈ ∑ [ g_i · f_t + ½ h_i · f_t² ] + Ω(f_t)</a:t>
-            </a:r>
-            <a:endParaRPr lang="en-US" sz="900" dirty="0"/>
-          </a:p>
-        </p:txBody>
-      </p:sp>
-      <p:sp>
-        <p:nvSpPr>
-          <p:cNvPr id="20" name="Shape 18"/>
+      <p:pic>
+        <p:nvPicPr>
+          <p:cNvPr id="19" name="Image 1" descr="D:\Trí tuệ nhân tạo\HK2\Trí tuệ nhân tạo\CS106-Team09-Fraud-Detection\draft\fraud-detection\slide\slide_assets\formula_xgb_objective.png">    </p:cNvPr>
+          <p:cNvPicPr>
+            <a:picLocks noChangeAspect="1"/>
+          </p:cNvPicPr>
+          <p:nvPr/>
+        </p:nvPicPr>
+        <p:blipFill>
+          <a:blip r:embed="rId2"/>
+          <a:stretch>
+            <a:fillRect/>
+          </a:stretch>
+        </p:blipFill>
+        <p:spPr>
+          <a:xfrm>
+            <a:off x="4849978" y="1463040"/>
+            <a:ext cx="3281782" cy="274320"/>
+          </a:xfrm>
+          <a:prstGeom prst="rect">
+            <a:avLst/>
+          </a:prstGeom>
+        </p:spPr>
+      </p:pic>
+      <p:sp>
+        <p:nvSpPr>
+          <p:cNvPr id="20" name="Shape 16"/>
           <p:cNvSpPr/>
           <p:nvPr/>
         </p:nvSpPr>
@@ -5587,7 +5557,7 @@
       </p:sp>
       <p:sp>
         <p:nvSpPr>
-          <p:cNvPr id="21" name="Text 19"/>
+          <p:cNvPr id="21" name="Text 17"/>
           <p:cNvSpPr/>
           <p:nvPr/>
         </p:nvSpPr>
@@ -5649,7 +5619,7 @@
       </p:sp>
       <p:sp>
         <p:nvSpPr>
-          <p:cNvPr id="22" name="Text 20"/>
+          <p:cNvPr id="22" name="Text 18"/>
           <p:cNvSpPr/>
           <p:nvPr/>
         </p:nvSpPr>
@@ -5725,7 +5695,7 @@
                   <a:srgbClr val="1F2937"/>
                 </a:solidFill>
               </a:rPr>
-              <a:t>F1-Score đạt 99.63% tương đương RF, nhưng tốc độ huấn luyện nhanh gấp khoảng 28 lần (~42s).
+              <a:t>F1-Score đạt 99.63% tương đương RF, nhưng tốc độ huấn luyện nhanh hơn ~20 lần (57.94s; xgb_smote_summary).
 </a:t>
             </a:r>
             <a:pPr indent="0" marL="0">
@@ -5754,7 +5724,7 @@
                   <a:srgbClr val="1F2937"/>
                 </a:solidFill>
               </a:rPr>
-              <a:t>Độ trễ suy luận &lt; 0.5ms, lý tưởng cho cổng thanh toán real-time.</a:t>
+              <a:t>Độ trễ suy luận cỡ nửa mili-giây (mô hình thuần, 1 giao dịch, CPU).</a:t>
             </a:r>
             <a:endParaRPr lang="en-US" sz="900" dirty="0"/>
           </a:p>
@@ -6106,8 +6076,8 @@
         </p:nvSpPr>
         <p:spPr>
           <a:xfrm>
-            <a:off x="640080" y="1645920"/>
-            <a:ext cx="4114800" cy="310896"/>
+            <a:off x="640080" y="1627632"/>
+            <a:ext cx="4114800" cy="402336"/>
           </a:xfrm>
           <a:prstGeom prst="rect">
             <a:avLst/>
@@ -6123,48 +6093,33 @@
           </a:ln>
         </p:spPr>
       </p:sp>
-      <p:sp>
-        <p:nvSpPr>
-          <p:cNvPr id="12" name="Text 10"/>
-          <p:cNvSpPr/>
-          <p:nvPr/>
-        </p:nvSpPr>
-        <p:spPr>
-          <a:xfrm>
-            <a:off x="685800" y="1673352"/>
-            <a:ext cx="4023360" cy="256032"/>
-          </a:xfrm>
-          <a:prstGeom prst="rect">
-            <a:avLst/>
-          </a:prstGeom>
-          <a:noFill/>
-          <a:ln/>
-        </p:spPr>
-        <p:txBody>
-          <a:bodyPr wrap="square" rtlCol="0" anchor="ctr"/>
-          <a:lstStyle/>
-          <a:p>
-            <a:pPr indent="0" marL="0">
-              <a:buNone/>
-            </a:pPr>
-            <a:r>
-              <a:rPr lang="en-US" sz="900" b="1" dirty="0">
-                <a:solidFill>
-                  <a:srgbClr val="DC2626"/>
-                </a:solidFill>
-                <a:latin typeface="Consolas" pitchFamily="34" charset="0"/>
-                <a:ea typeface="Consolas" pitchFamily="34" charset="-122"/>
-                <a:cs typeface="Consolas" pitchFamily="34" charset="-120"/>
-              </a:rPr>
-              <a:t>L_rec(x, x_recon) = (1 / d) · ∑ (x_j - x_recon_j)²</a:t>
-            </a:r>
-            <a:endParaRPr lang="en-US" sz="900" dirty="0"/>
-          </a:p>
-        </p:txBody>
-      </p:sp>
-      <p:sp>
-        <p:nvSpPr>
-          <p:cNvPr id="13" name="Text 11"/>
+      <p:pic>
+        <p:nvPicPr>
+          <p:cNvPr id="12" name="Image 0" descr="D:\Trí tuệ nhân tạo\HK2\Trí tuệ nhân tạo\CS106-Team09-Fraud-Detection\draft\fraud-detection\slide\slide_assets\formula_ae_reconstruction.png">    </p:cNvPr>
+          <p:cNvPicPr>
+            <a:picLocks noChangeAspect="1"/>
+          </p:cNvPicPr>
+          <p:nvPr/>
+        </p:nvPicPr>
+        <p:blipFill>
+          <a:blip r:embed="rId1"/>
+          <a:stretch>
+            <a:fillRect/>
+          </a:stretch>
+        </p:blipFill>
+        <p:spPr>
+          <a:xfrm>
+            <a:off x="1028700" y="1633118"/>
+            <a:ext cx="2251253" cy="391363"/>
+          </a:xfrm>
+          <a:prstGeom prst="rect">
+            <a:avLst/>
+          </a:prstGeom>
+        </p:spPr>
+      </p:pic>
+      <p:sp>
+        <p:nvSpPr>
+          <p:cNvPr id="13" name="Text 10"/>
           <p:cNvSpPr/>
           <p:nvPr/>
         </p:nvSpPr>
@@ -6280,7 +6235,7 @@
       </p:sp>
       <p:sp>
         <p:nvSpPr>
-          <p:cNvPr id="14" name="Shape 12"/>
+          <p:cNvPr id="14" name="Shape 11"/>
           <p:cNvSpPr/>
           <p:nvPr/>
         </p:nvSpPr>
@@ -6305,7 +6260,7 @@
       </p:sp>
       <p:sp>
         <p:nvSpPr>
-          <p:cNvPr id="15" name="Text 13"/>
+          <p:cNvPr id="15" name="Text 12"/>
           <p:cNvSpPr/>
           <p:nvPr/>
         </p:nvSpPr>
@@ -7611,7 +7566,7 @@
       </p:graphicFrame>
       <p:sp>
         <p:nvSpPr>
-          <p:cNvPr id="17" name="Shape 14"/>
+          <p:cNvPr id="17" name="Shape 13"/>
           <p:cNvSpPr/>
           <p:nvPr/>
         </p:nvSpPr>
@@ -7636,7 +7591,7 @@
       </p:sp>
       <p:sp>
         <p:nvSpPr>
-          <p:cNvPr id="18" name="Text 15"/>
+          <p:cNvPr id="18" name="Text 14"/>
           <p:cNvSpPr/>
           <p:nvPr/>
         </p:nvSpPr>
@@ -7675,7 +7630,7 @@
       </p:sp>
       <p:sp>
         <p:nvSpPr>
-          <p:cNvPr id="19" name="Text 16"/>
+          <p:cNvPr id="19" name="Text 15"/>
           <p:cNvSpPr/>
           <p:nvPr/>
         </p:nvSpPr>
@@ -7739,7 +7694,7 @@
                 <a:ea typeface="Segoe UI" pitchFamily="34" charset="-122"/>
                 <a:cs typeface="Segoe UI" pitchFamily="34" charset="-120"/>
               </a:rPr>
-              <a:t>Không phụ thuộc nhãn: Phát hiện bất thường theo nguyên lý sai số tái tạo (Reconstruction MSE).</a:t>
+              <a:t>Không phụ thuộc nhãn khi train: Phát hiện bất thường theo sai số tái tạo (nhãn chỉ dùng để chọn ngưỡng).</a:t>
             </a:r>
             <a:endParaRPr lang="en-US" sz="880" dirty="0"/>
           </a:p>
@@ -9948,7 +9903,7 @@
                           <a:ea typeface="Segoe UI" pitchFamily="34" charset="-122"/>
                           <a:cs typeface="Segoe UI" pitchFamily="34" charset="-120"/>
                         </a:rPr>
-                        <a:t>41.7s</a:t>
+                        <a:t>57.94s</a:t>
                       </a:r>
                       <a:endParaRPr lang="en-US" sz="820" dirty="0">
                         <a:latin typeface="Segoe UI" charset="0"/>
@@ -10358,7 +10313,7 @@
                           <a:ea typeface="Segoe UI" pitchFamily="34" charset="-122"/>
                           <a:cs typeface="Segoe UI" pitchFamily="34" charset="-120"/>
                         </a:rPr>
-                        <a:t>43.2s</a:t>
+                        <a:t>45.48s</a:t>
                       </a:r>
                       <a:endParaRPr lang="en-US" sz="820" dirty="0">
                         <a:latin typeface="Segoe UI" charset="0"/>
@@ -10428,7 +10383,7 @@
                           <a:ea typeface="Segoe UI" pitchFamily="34" charset="-122"/>
                           <a:cs typeface="Segoe UI" pitchFamily="34" charset="-120"/>
                         </a:rPr>
-                        <a:t>Autoencoder (Zero-Day)</a:t>
+                        <a:t>Autoencoder (Unsupervised)</a:t>
                       </a:r>
                       <a:endParaRPr lang="en-US" sz="820" dirty="0">
                         <a:latin typeface="Segoe UI" charset="0"/>
@@ -10768,7 +10723,7 @@
                           <a:ea typeface="Segoe UI" pitchFamily="34" charset="-122"/>
                           <a:cs typeface="Segoe UI" pitchFamily="34" charset="-120"/>
                         </a:rPr>
-                        <a:t>68.4s</a:t>
+                        <a:t>—</a:t>
                       </a:r>
                       <a:endParaRPr lang="en-US" sz="820" dirty="0">
                         <a:latin typeface="Segoe UI" charset="0"/>
@@ -10954,7 +10909,7 @@
                 <a:ea typeface="Segoe UI" pitchFamily="34" charset="-122"/>
                 <a:cs typeface="Segoe UI" pitchFamily="34" charset="-120"/>
               </a:rPr>
-              <a:t>XGBoost + SMOTE đạt hiệu năng tương đương (F1 = 99.63%) nhưng tốc độ huấn luyện nhanh gấp 28.5 lần.</a:t>
+              <a:t>XGBoost + SMOTE đạt hiệu năng tương đương (F1 = 99.63%) nhưng tốc độ huấn luyện nhanh hơn ~20 lần (57.94s).</a:t>
             </a:r>
             <a:endParaRPr lang="en-US" sz="860" dirty="0"/>
           </a:p>
@@ -10978,7 +10933,7 @@
                 <a:ea typeface="Segoe UI" pitchFamily="34" charset="-122"/>
                 <a:cs typeface="Segoe UI" pitchFamily="34" charset="-120"/>
               </a:rPr>
-              <a:t>Autoencoder bắt được 75.23% gian lận hoàn toàn không cần nhãn giám sát, tạo lớp phòng thủ Zero-Day vững chắc.</a:t>
+              <a:t>Autoencoder bắt được 75.23% gian lận hoàn toàn không cần nhãn giám sát, tạo lớp phòng thủ phát hiện bất thường thứ cấp.</a:t>
             </a:r>
             <a:endParaRPr lang="en-US" sz="860" dirty="0"/>
           </a:p>
@@ -11138,7 +11093,7 @@
                 <a:ea typeface="Segoe UI" pitchFamily="34" charset="-122"/>
                 <a:cs typeface="Segoe UI" pitchFamily="34" charset="-120"/>
               </a:rPr>
-              <a:t>Autoencoder hy sinh Precision (38.2%) để duy trì Recall cao (75.2%) nhằm phòng ngừa triệt để tổn thất tài chính.</a:t>
+              <a:t>Autoencoder hy sinh Precision (38.2%) để duy trì Recall cao (75.2%) nhằm giảm bỏ sót.</a:t>
             </a:r>
             <a:endParaRPr lang="en-US" sz="840" dirty="0"/>
           </a:p>
@@ -11725,7 +11680,7 @@
                   <a:srgbClr val="1F2937"/>
                 </a:solidFill>
               </a:rPr>
-              <a:t>• Độ trễ suy luận &lt; 0.5ms — cấu hình tối ưu nhất cho môi trường thực tế.</a:t>
+              <a:t>• Độ trễ cỡ nửa mili-giây (mô hình thuần, 1 giao dịch, CPU).</a:t>
             </a:r>
             <a:endParaRPr lang="en-US" sz="820" dirty="0"/>
           </a:p>
@@ -11786,7 +11741,7 @@
                   <a:srgbClr val="DC2626"/>
                 </a:solidFill>
               </a:rPr>
-              <a:t>Deep Autoencoder (Zero-Day)</a:t>
+              <a:t>Deep Autoencoder (Unsupervised)</a:t>
             </a:r>
             <a:endParaRPr lang="en-US" sz="950" dirty="0"/>
           </a:p>
@@ -14073,7 +14028,7 @@
                 <a:ea typeface="Segoe UI" pitchFamily="34" charset="-122"/>
                 <a:cs typeface="Segoe UI" pitchFamily="34" charset="-120"/>
               </a:rPr>
-              <a:t>Giao dịch gian lận (Đỏ) có sai số tái tạo trải dài sang phải do cấu trúc dòng tiền dị biệt không thể nén qua bottleneck.</a:t>
+              <a:t>Giao dịch gian lận (Đỏ) có sai số tái tạo trải dài sang phải; trục x cắt ở 0.18 nên 37.6% ca gian lận nằm ngoài hình.</a:t>
             </a:r>
             <a:endParaRPr lang="en-US" sz="830" dirty="0"/>
           </a:p>
@@ -15911,7 +15866,7 @@
                 <a:ea typeface="Segoe UI" pitchFamily="34" charset="-122"/>
                 <a:cs typeface="Segoe UI" pitchFamily="34" charset="-120"/>
               </a:rPr>
-              <a:t>Kiến trúc Dashboard Streamlit Real-Time Inference &amp; Batch CSV Scoring</a:t>
+              <a:t>Dashboard Streamlit suy luận XGBoost &amp; nhập dữ liệu mẫu CSV/JSON (tối đa 50 mẫu)</a:t>
             </a:r>
             <a:endParaRPr lang="en-US" sz="1100" dirty="0"/>
           </a:p>
@@ -16396,7 +16351,7 @@
                   <a:srgbClr val="4B5563"/>
                 </a:solidFill>
               </a:rPr>
-              <a:t>Khu biệt loại giao dịch, dấu vết rút cạn số dư và 14 engineered features.</a:t>
+              <a:t>Khu biệt loại giao dịch, dấu vết rút cạn số dư và 14 đặc trưng (7 dẫn xuất).</a:t>
             </a:r>
             <a:endParaRPr lang="en-US" sz="1250" dirty="0"/>
           </a:p>
@@ -16978,360 +16933,33 @@
           </a:ln>
         </p:spPr>
       </p:sp>
-      <p:sp>
-        <p:nvSpPr>
-          <p:cNvPr id="8" name="Shape 6"/>
-          <p:cNvSpPr/>
-          <p:nvPr/>
-        </p:nvSpPr>
-        <p:spPr>
-          <a:xfrm>
-            <a:off x="502920" y="987552"/>
-            <a:ext cx="5029200" cy="274320"/>
-          </a:xfrm>
-          <a:prstGeom prst="rect">
-            <a:avLst/>
-          </a:prstGeom>
-          <a:solidFill>
-            <a:srgbClr val="1E293B"/>
-          </a:solidFill>
-          <a:ln/>
-        </p:spPr>
-      </p:sp>
-      <p:sp>
-        <p:nvSpPr>
-          <p:cNvPr id="9" name="Text 7"/>
-          <p:cNvSpPr/>
-          <p:nvPr/>
-        </p:nvSpPr>
-        <p:spPr>
-          <a:xfrm>
-            <a:off x="640080" y="987552"/>
-            <a:ext cx="4754880" cy="274320"/>
-          </a:xfrm>
-          <a:prstGeom prst="rect">
-            <a:avLst/>
-          </a:prstGeom>
-          <a:noFill/>
-          <a:ln/>
-        </p:spPr>
-        <p:txBody>
-          <a:bodyPr wrap="square" rtlCol="0" anchor="ctr"/>
-          <a:lstStyle/>
-          <a:p>
-            <a:pPr indent="0" marL="0">
-              <a:buNone/>
-            </a:pPr>
-            <a:r>
-              <a:rPr lang="en-US" sz="880" b="1" dirty="0">
-                <a:solidFill>
-                  <a:srgbClr val="60A5FA"/>
-                </a:solidFill>
-                <a:latin typeface="Consolas" pitchFamily="34" charset="0"/>
-                <a:ea typeface="Consolas" pitchFamily="34" charset="-122"/>
-                <a:cs typeface="Consolas" pitchFamily="34" charset="-120"/>
-              </a:rPr>
-              <a:t>🔴 LIVE DEMO  •  Streamlit Real-Time Fraud Shield  |  XGBoost-SMOTE &amp; Autoencoder</a:t>
-            </a:r>
-            <a:endParaRPr lang="en-US" sz="880" dirty="0"/>
-          </a:p>
-        </p:txBody>
-      </p:sp>
-      <p:sp>
-        <p:nvSpPr>
-          <p:cNvPr id="10" name="Shape 8"/>
-          <p:cNvSpPr/>
-          <p:nvPr/>
-        </p:nvSpPr>
-        <p:spPr>
-          <a:xfrm>
-            <a:off x="676656" y="1325880"/>
-            <a:ext cx="4681728" cy="2633472"/>
-          </a:xfrm>
-          <a:prstGeom prst="rect">
-            <a:avLst/>
-          </a:prstGeom>
-          <a:solidFill>
-            <a:srgbClr val="0B1120"/>
-          </a:solidFill>
-          <a:ln w="19050">
-            <a:solidFill>
-              <a:srgbClr val="38BDF8"/>
-            </a:solidFill>
-            <a:prstDash val="solid"/>
-          </a:ln>
-        </p:spPr>
-      </p:sp>
-      <p:sp>
-        <p:nvSpPr>
-          <p:cNvPr id="11" name="Text 9"/>
-          <p:cNvSpPr/>
-          <p:nvPr/>
-        </p:nvSpPr>
-        <p:spPr>
-          <a:xfrm>
-            <a:off x="676656" y="1645920"/>
-            <a:ext cx="4681728" cy="594360"/>
-          </a:xfrm>
-          <a:prstGeom prst="rect">
-            <a:avLst/>
-          </a:prstGeom>
-          <a:noFill/>
-          <a:ln/>
-        </p:spPr>
-        <p:txBody>
-          <a:bodyPr wrap="square" rtlCol="0" anchor="ctr"/>
-          <a:lstStyle/>
-          <a:p>
-            <a:pPr algn="ctr" indent="0" marL="0">
-              <a:buNone/>
-            </a:pPr>
-            <a:r>
-              <a:rPr lang="en-US" sz="3600" b="1" dirty="0">
-                <a:solidFill>
-                  <a:srgbClr val="38BDF8"/>
-                </a:solidFill>
-              </a:rPr>
-              <a:t>▶</a:t>
-            </a:r>
-            <a:endParaRPr lang="en-US" sz="3600" dirty="0"/>
-          </a:p>
-        </p:txBody>
-      </p:sp>
-      <p:sp>
-        <p:nvSpPr>
-          <p:cNvPr id="12" name="Text 10"/>
-          <p:cNvSpPr/>
-          <p:nvPr/>
-        </p:nvSpPr>
-        <p:spPr>
-          <a:xfrm>
-            <a:off x="813816" y="2286000"/>
-            <a:ext cx="4407408" cy="502920"/>
-          </a:xfrm>
-          <a:prstGeom prst="rect">
-            <a:avLst/>
-          </a:prstGeom>
-          <a:noFill/>
-          <a:ln/>
-        </p:spPr>
-        <p:txBody>
-          <a:bodyPr wrap="square" rtlCol="0" anchor="ctr"/>
-          <a:lstStyle/>
-          <a:p>
-            <a:pPr algn="ctr" indent="0" marL="0">
-              <a:lnSpc>
-                <a:spcPct val="120000"/>
-              </a:lnSpc>
-              <a:buNone/>
-            </a:pPr>
-            <a:r>
-              <a:rPr lang="en-US" sz="1000" b="1" dirty="0">
-                <a:solidFill>
-                  <a:srgbClr val="E2E8F0"/>
-                </a:solidFill>
-                <a:latin typeface="Segoe UI" pitchFamily="34" charset="0"/>
-                <a:ea typeface="Segoe UI" pitchFamily="34" charset="-122"/>
-                <a:cs typeface="Segoe UI" pitchFamily="34" charset="-120"/>
-              </a:rPr>
-              <a:t>[ KHUNG CHÈN VIDEO DEMO STREAMLIT ]</a:t>
-            </a:r>
-            <a:endParaRPr lang="en-US" sz="1000" dirty="0"/>
-          </a:p>
-          <a:p>
-            <a:pPr algn="ctr" indent="0" marL="0">
-              <a:lnSpc>
-                <a:spcPct val="120000"/>
-              </a:lnSpc>
-              <a:buNone/>
-            </a:pPr>
-            <a:r>
-              <a:rPr lang="en-US" sz="1000" b="1" dirty="0">
-                <a:solidFill>
-                  <a:srgbClr val="E2E8F0"/>
-                </a:solidFill>
-                <a:latin typeface="Segoe UI" pitchFamily="34" charset="0"/>
-                <a:ea typeface="Segoe UI" pitchFamily="34" charset="-122"/>
-                <a:cs typeface="Segoe UI" pitchFamily="34" charset="-120"/>
-              </a:rPr>
-              <a:t>(Tỷ lệ Chuẩn 16:9 — 1920×1080 / 1280×720 MP4/GIF)</a:t>
-            </a:r>
-            <a:endParaRPr lang="en-US" sz="1000" dirty="0"/>
-          </a:p>
-        </p:txBody>
-      </p:sp>
-      <p:sp>
-        <p:nvSpPr>
-          <p:cNvPr id="13" name="Text 11"/>
-          <p:cNvSpPr/>
-          <p:nvPr/>
-        </p:nvSpPr>
-        <p:spPr>
-          <a:xfrm>
-            <a:off x="813816" y="2862072"/>
-            <a:ext cx="4407408" cy="228600"/>
-          </a:xfrm>
-          <a:prstGeom prst="rect">
-            <a:avLst/>
-          </a:prstGeom>
-          <a:noFill/>
-          <a:ln/>
-        </p:spPr>
-        <p:txBody>
-          <a:bodyPr wrap="square" rtlCol="0" anchor="ctr"/>
-          <a:lstStyle/>
-          <a:p>
-            <a:pPr algn="ctr" indent="0" marL="0">
-              <a:buNone/>
-            </a:pPr>
-            <a:r>
-              <a:rPr lang="en-US" sz="850" i="1" dirty="0">
-                <a:solidFill>
-                  <a:srgbClr val="94A3B8"/>
-                </a:solidFill>
-                <a:latin typeface="Segoe UI" pitchFamily="34" charset="0"/>
-                <a:ea typeface="Segoe UI" pitchFamily="34" charset="-122"/>
-                <a:cs typeface="Segoe UI" pitchFamily="34" charset="-120"/>
-              </a:rPr>
-              <a:t>Giao diện phân tích rủi ro thời gian thực &amp; Chấm điểm Batch CSV</a:t>
-            </a:r>
-            <a:endParaRPr lang="en-US" sz="850" dirty="0"/>
-          </a:p>
-        </p:txBody>
-      </p:sp>
-      <p:sp>
-        <p:nvSpPr>
-          <p:cNvPr id="14" name="Shape 12"/>
-          <p:cNvSpPr/>
-          <p:nvPr/>
-        </p:nvSpPr>
-        <p:spPr>
-          <a:xfrm>
-            <a:off x="2011680" y="3291840"/>
-            <a:ext cx="2011680" cy="292608"/>
-          </a:xfrm>
-          <a:prstGeom prst="roundRect">
-            <a:avLst>
-              <a:gd name="adj" fmla="val 25000"/>
-            </a:avLst>
-          </a:prstGeom>
-          <a:solidFill>
-            <a:srgbClr val="1E293B"/>
-          </a:solidFill>
-          <a:ln w="10160">
-            <a:solidFill>
-              <a:srgbClr val="64748B"/>
-            </a:solidFill>
-            <a:prstDash val="solid"/>
-          </a:ln>
-        </p:spPr>
-      </p:sp>
-      <p:sp>
-        <p:nvSpPr>
-          <p:cNvPr id="15" name="Text 13"/>
-          <p:cNvSpPr/>
-          <p:nvPr/>
-        </p:nvSpPr>
-        <p:spPr>
-          <a:xfrm>
-            <a:off x="2011680" y="3291840"/>
-            <a:ext cx="2011680" cy="292608"/>
-          </a:xfrm>
-          <a:prstGeom prst="rect">
-            <a:avLst/>
-          </a:prstGeom>
-          <a:noFill/>
-          <a:ln/>
-        </p:spPr>
-        <p:txBody>
-          <a:bodyPr wrap="square" rtlCol="0" anchor="ctr"/>
-          <a:lstStyle/>
-          <a:p>
-            <a:pPr algn="ctr" indent="0" marL="0">
-              <a:buNone/>
-            </a:pPr>
-            <a:r>
-              <a:rPr lang="en-US" sz="820" b="1" dirty="0">
-                <a:solidFill>
-                  <a:srgbClr val="38BDF8"/>
-                </a:solidFill>
-                <a:latin typeface="Consolas" pitchFamily="34" charset="0"/>
-                <a:ea typeface="Consolas" pitchFamily="34" charset="-122"/>
-                <a:cs typeface="Consolas" pitchFamily="34" charset="-120"/>
-              </a:rPr>
-              <a:t>HD 1080p  •  TỶ LỆ 16:9</a:t>
-            </a:r>
-            <a:endParaRPr lang="en-US" sz="820" dirty="0"/>
-          </a:p>
-        </p:txBody>
-      </p:sp>
-      <p:sp>
-        <p:nvSpPr>
-          <p:cNvPr id="16" name="Shape 14"/>
-          <p:cNvSpPr/>
-          <p:nvPr/>
-        </p:nvSpPr>
-        <p:spPr>
-          <a:xfrm>
-            <a:off x="640080" y="4023360"/>
-            <a:ext cx="4754880" cy="457200"/>
-          </a:xfrm>
-          <a:prstGeom prst="rect">
-            <a:avLst/>
-          </a:prstGeom>
-          <a:solidFill>
-            <a:srgbClr val="131C31"/>
-          </a:solidFill>
-          <a:ln w="12700">
-            <a:solidFill>
-              <a:srgbClr val="1E293B"/>
-            </a:solidFill>
-            <a:prstDash val="solid"/>
-          </a:ln>
-        </p:spPr>
-      </p:sp>
-      <p:sp>
-        <p:nvSpPr>
-          <p:cNvPr id="17" name="Text 15"/>
-          <p:cNvSpPr/>
-          <p:nvPr/>
-        </p:nvSpPr>
-        <p:spPr>
-          <a:xfrm>
-            <a:off x="685800" y="4023360"/>
-            <a:ext cx="4663440" cy="457200"/>
-          </a:xfrm>
-          <a:prstGeom prst="rect">
-            <a:avLst/>
-          </a:prstGeom>
-          <a:noFill/>
-          <a:ln/>
-        </p:spPr>
-        <p:txBody>
-          <a:bodyPr wrap="square" rtlCol="0" anchor="ctr"/>
-          <a:lstStyle/>
-          <a:p>
-            <a:pPr algn="ctr" indent="0" marL="0">
-              <a:buNone/>
-            </a:pPr>
-            <a:r>
-              <a:rPr lang="en-US" sz="780" dirty="0">
-                <a:solidFill>
-                  <a:srgbClr val="CBD5E1"/>
-                </a:solidFill>
-                <a:latin typeface="Consolas" pitchFamily="34" charset="0"/>
-                <a:ea typeface="Consolas" pitchFamily="34" charset="-122"/>
-                <a:cs typeface="Consolas" pitchFamily="34" charset="-120"/>
-              </a:rPr>
-              <a:t>3 Kịch bản: 1. Hợp lệ (&lt; 0.1%)  |  2. Vét cạn số dư (88.36%)  |  3. Cận biên ban đêm (~32%)</a:t>
-            </a:r>
-            <a:endParaRPr lang="en-US" sz="780" dirty="0"/>
-          </a:p>
-        </p:txBody>
-      </p:sp>
-      <p:sp>
-        <p:nvSpPr>
-          <p:cNvPr id="18" name="Shape 16"/>
+      <p:pic>
+        <p:nvPicPr>
+          <p:cNvPr id="8" name="Image 0" descr="D:\Trí tuệ nhân tạo\HK2\Trí tuệ nhân tạo\CS106-Team09-Fraud-Detection\draft\fraud-detection\slide\slide_assets\demo_ui_slide20.png">    </p:cNvPr>
+          <p:cNvPicPr>
+            <a:picLocks noChangeAspect="1"/>
+          </p:cNvPicPr>
+          <p:nvPr/>
+        </p:nvPicPr>
+        <p:blipFill>
+          <a:blip r:embed="rId1"/>
+          <a:stretch>
+            <a:fillRect/>
+          </a:stretch>
+        </p:blipFill>
+        <p:spPr>
+          <a:xfrm>
+            <a:off x="557784" y="1042416"/>
+            <a:ext cx="4919472" cy="3474720"/>
+          </a:xfrm>
+          <a:prstGeom prst="rect">
+            <a:avLst/>
+          </a:prstGeom>
+        </p:spPr>
+      </p:pic>
+      <p:sp>
+        <p:nvSpPr>
+          <p:cNvPr id="9" name="Shape 6"/>
           <p:cNvSpPr/>
           <p:nvPr/>
         </p:nvSpPr>
@@ -17356,7 +16984,7 @@
       </p:sp>
       <p:sp>
         <p:nvSpPr>
-          <p:cNvPr id="19" name="Text 17"/>
+          <p:cNvPr id="10" name="Text 7"/>
           <p:cNvSpPr/>
           <p:nvPr/>
         </p:nvSpPr>
@@ -17395,7 +17023,7 @@
       </p:sp>
       <p:sp>
         <p:nvSpPr>
-          <p:cNvPr id="20" name="Text 18"/>
+          <p:cNvPr id="11" name="Text 8"/>
           <p:cNvSpPr/>
           <p:nvPr/>
         </p:nvSpPr>
@@ -17435,7 +17063,7 @@
                 <a:ea typeface="Segoe UI" pitchFamily="34" charset="-122"/>
                 <a:cs typeface="Segoe UI" pitchFamily="34" charset="-120"/>
               </a:rPr>
-              <a:t>Quy chuẩn Leak-Free: 80/20 Stratified Split chống rò rỉ dữ liệu.</a:t>
+              <a:t>Không rò rỉ sang Test: split 80/20 trước, scaler và oversampling chỉ trên Train.</a:t>
             </a:r>
             <a:endParaRPr lang="en-US" sz="840" dirty="0"/>
           </a:p>
@@ -17459,7 +17087,7 @@
                 <a:ea typeface="Segoe UI" pitchFamily="34" charset="-122"/>
                 <a:cs typeface="Segoe UI" pitchFamily="34" charset="-120"/>
               </a:rPr>
-              <a:t>Đặc trưng Số dư: Nhóm số dư chiếm &gt; 97% split gains (ghi nhận rủi ro simulator artifact).</a:t>
+              <a:t>Đặc trưng Số dư: Nhóm số dư chiếm &gt; 97% split gains (rủi ro simulator artifact, Mục 3.6.2).</a:t>
             </a:r>
             <a:endParaRPr lang="en-US" sz="840" dirty="0"/>
           </a:p>
@@ -17507,7 +17135,7 @@
                 <a:ea typeface="Segoe UI" pitchFamily="34" charset="-122"/>
                 <a:cs typeface="Segoe UI" pitchFamily="34" charset="-120"/>
               </a:rPr>
-              <a:t>Phòng thủ Đa tầng: Phối hợp XGBoost phát hiện nhanh và Autoencoder bắt bất thường.</a:t>
+              <a:t>Demo suy luận bằng XGBoost-SMOTE; Autoencoder dùng để so sánh bất thường, không phải model chọn trên UI.</a:t>
             </a:r>
             <a:endParaRPr lang="en-US" sz="840" dirty="0"/>
           </a:p>
@@ -17515,7 +17143,7 @@
       </p:sp>
       <p:sp>
         <p:nvSpPr>
-          <p:cNvPr id="21" name="Shape 19"/>
+          <p:cNvPr id="12" name="Shape 9"/>
           <p:cNvSpPr/>
           <p:nvPr/>
         </p:nvSpPr>
@@ -17540,7 +17168,7 @@
       </p:sp>
       <p:sp>
         <p:nvSpPr>
-          <p:cNvPr id="22" name="Text 20"/>
+          <p:cNvPr id="13" name="Text 10"/>
           <p:cNvSpPr/>
           <p:nvPr/>
         </p:nvSpPr>
@@ -17579,7 +17207,7 @@
       </p:sp>
       <p:sp>
         <p:nvSpPr>
-          <p:cNvPr id="23" name="Text 21"/>
+          <p:cNvPr id="14" name="Text 11"/>
           <p:cNvSpPr/>
           <p:nvPr/>
         </p:nvSpPr>
@@ -18680,7 +18308,7 @@
                   <a:srgbClr val="1F2937"/>
                 </a:solidFill>
               </a:rPr>
-              <a:t>• Gian lận chỉ chiếm ~1 trên 800 giao dịch (8,213 ca trên 6.36M sự kiện trong PaySim).
+              <a:t>• Gian lận chỉ chiếm ~1 trên 775 giao dịch (8,213 ca trên 6.36M sự kiện trong PaySim).
 </a:t>
             </a:r>
             <a:pPr indent="0" marL="0">
@@ -19959,7 +19587,7 @@
                 <a:ea typeface="Segoe UI" pitchFamily="34" charset="-122"/>
                 <a:cs typeface="Segoe UI" pitchFamily="34" charset="-120"/>
               </a:rPr>
-              <a:t>Xây dựng end-to-end ML pipeline chuẩn, đảm bảo Leak-Free tuyệt đối.</a:t>
+              <a:t>Xây dựng end-to-end ML pipeline chuẩn, đảm bảo nguyên tắc phân lập dữ liệu Leak-Free.</a:t>
             </a:r>
             <a:endParaRPr lang="en-US" sz="950" dirty="0"/>
           </a:p>
@@ -19983,7 +19611,7 @@
                 <a:ea typeface="Segoe UI" pitchFamily="34" charset="-122"/>
                 <a:cs typeface="Segoe UI" pitchFamily="34" charset="-120"/>
               </a:rPr>
-              <a:t>Thiết kế 14 features bắt trọn sai lệch số dư tài khoản.</a:t>
+              <a:t>Thiết kế 14 đặc trưng (7 dẫn xuất) bắt trọn sai lệch số dư tài khoản.</a:t>
             </a:r>
             <a:endParaRPr lang="en-US" sz="950" dirty="0"/>
           </a:p>
@@ -20007,7 +19635,7 @@
                 <a:ea typeface="Segoe UI" pitchFamily="34" charset="-122"/>
                 <a:cs typeface="Segoe UI" pitchFamily="34" charset="-120"/>
               </a:rPr>
-              <a:t>So sánh Ensemble Trees với Unsupervised Deep Autoencoder bắt Zero-Day.</a:t>
+              <a:t>So sánh Ensemble Trees với Unsupervised Deep Autoencoder phát hiện bất thường.</a:t>
             </a:r>
             <a:endParaRPr lang="en-US" sz="950" dirty="0"/>
           </a:p>
@@ -21036,7 +20664,7 @@
                           <a:ea typeface="Segoe UI" pitchFamily="34" charset="-122"/>
                           <a:cs typeface="Segoe UI" pitchFamily="34" charset="-120"/>
                         </a:rPr>
-                        <a:t>Bước thời gian theo giờ (1..744, tương ứng 30 ngày mô phỏng)</a:t>
+                        <a:t>Bước thời gian theo giờ (1..743, tương ứng 30 ngày mô phỏng)</a:t>
                       </a:r>
                       <a:endParaRPr lang="en-US" sz="880" dirty="0">
                         <a:latin typeface="Segoe UI" charset="0"/>
@@ -22018,7 +21646,7 @@
                 <a:ea typeface="Segoe UI" pitchFamily="34" charset="-122"/>
                 <a:cs typeface="Segoe UI" pitchFamily="34" charset="-120"/>
               </a:rPr>
-              <a:t>100% tất cả các ca gian lận trong 6.36M giao dịch CHỈ xuất hiện ở 2 loại: TRANSFER và CASH_OUT. Các loại PAYMENT, CASH_IN và DEBIT hoàn toàn an toàn (0% gian lận). Do đó, bước tiền xử lý lọc chỉ giữ lại TRANSFER &amp; CASH_OUT giúp triệt tiêu 70% dữ liệu nhiễu.</a:t>
+              <a:t>100% tất cả các ca gian lận trong 6.36M giao dịch CHỈ xuất hiện ở 2 loại: TRANSFER và CASH_OUT. Các loại PAYMENT, CASH_IN và DEBIT hoàn toàn an toàn (0% gian lận). Do đó, bước tiền xử lý lọc chỉ giữ lại TRANSFER &amp; CASH_OUT giúp loại bỏ ~56.5% giao dịch hoàn toàn không có gian lận.</a:t>
             </a:r>
             <a:endParaRPr lang="en-US" sz="930" dirty="0"/>
           </a:p>
@@ -22318,7 +21946,7 @@
                 <a:ea typeface="Segoe UI" pitchFamily="34" charset="-122"/>
                 <a:cs typeface="Segoe UI" pitchFamily="34" charset="-120"/>
               </a:rPr>
-              <a:t>Công thức Toán học của 14 Engineered Domain Features</a:t>
+              <a:t>Công thức toán học của 14 đặc trưng miền (7 dẫn xuất)</a:t>
             </a:r>
             <a:endParaRPr lang="en-US" sz="1100" dirty="0"/>
           </a:p>
@@ -22771,7 +22399,7 @@
                   <a:srgbClr val="1F2937"/>
                 </a:solidFill>
               </a:rPr>
-              <a:t>Lọc tập dữ liệu chỉ giữ lại TRANSFER &amp; CASH_OUT, triệt tiêu ngay 70% dữ liệu nhiễu vô ích.</a:t>
+              <a:t>Lọc tập dữ liệu chỉ giữ lại TRANSFER &amp; CASH_OUT, loại bỏ ~56% giao dịch không có rủi ro gian lận.</a:t>
             </a:r>
             <a:endParaRPr lang="en-US" sz="980" dirty="0"/>
           </a:p>
@@ -23174,7 +22802,7 @@
                   <a:srgbClr val="1F2937"/>
                 </a:solidFill>
               </a:rPr>
-              <a:t>• Phản ánh tài khoản rác (mule account) hoặc luân chuyển rửa tiền đa tầng tức thì.
+              <a:t>• Phản ánh tài khoản rác hoặc luân chuyển rửa tiền đa tầng tức thì (diễn giải, dữ liệu mô phỏng).
 </a:t>
             </a:r>
             <a:pPr indent="0" marL="0">
@@ -25448,7 +25076,7 @@
                   <a:srgbClr val="1F2937"/>
                 </a:solidFill>
               </a:rPr>
-              <a:t>Một mô hình ngây thơ luôn dự đoán 100% là "Hợp lệ" vẫn đạt Accuracy 99.87% nhưng bỏ sót 100% gian lận! Do đó, đánh giá mô hình phải dẫn dắt bởi Precision, Recall, F1-Score và PR-AUC (Precision-Recall AUC).</a:t>
+              <a:t>Một mô hình ngây thơ luôn dự đoán 100% là "Hợp lệ" vẫn đạt Accuracy 99.87% trên PaySim gốc nhưng bỏ sót 100% gian lận! Do đó, đánh giá mô hình phải dẫn dắt bởi Precision, Recall, F1-Score và PR-AUC (Precision-Recall AUC).</a:t>
             </a:r>
             <a:endParaRPr lang="en-US" sz="930" dirty="0"/>
           </a:p>
@@ -25628,7 +25256,7 @@
                   <a:srgbClr val="1F2937"/>
                 </a:solidFill>
               </a:rPr>
-              <a:t>Nội suy mẫu nhân tạo thiểu số dọc theo đoạn thẳng nối các láng giềng k-NN trong Latent Space.
+              <a:t>Nội suy mẫu nhân tạo thiểu số dọc theo đoạn thẳng nối các láng giềng k-NN trong không gian đặc trưng.
 </a:t>
             </a:r>
             <a:pPr indent="0" marL="0">
@@ -26928,7 +26556,7 @@
                   <a:srgbClr val="2563EB"/>
                 </a:solidFill>
               </a:rPr>
-              <a:t>• Đúc kết: SMOTE ổn định và vượt trội hơn ADASYN trên cả Random Forest và XGBoost.</a:t>
+              <a:t>• Đúc kết: SMOTENC nhỉnh hơn nhẹ so với ADASYN trên RF và XGBoost (ít cảnh báo nhầm hơn).</a:t>
             </a:r>
             <a:endParaRPr lang="en-US" sz="880" dirty="0"/>
           </a:p>

</xml_diff>

<commit_message>
fix(slide): đồng bộ script sinh slide với báo cáo audit 18/18 và khôi phục ảnh (#47)
## Summary
- Đồng bộ `generate_cs106_style_slides_vn.js` với báo cáo audit của Cẩm
(18/18 nhóm A): pipeline Split trước Feature Eng, Test 4.11%, lọc
~56.5%, XGB 57.94s/45.48s (~20 lần), bỏ Zero-Day / Leak-Free tuyệt đối /
0.5ms / Batch CSV.
- Khôi phục ảnh công thức Slide 12–13 và screenshot demo UI Slide 20 từ
bản PPTX audit, rồi xuất lại PPTX/PDF từ script (không chỉnh tay
PowerPoint).

## Test plan
- [ ] Mở PPTX 21 trang, kiểm Slide 11 (thứ tự pipeline + 4.11%), Slide
12 (200 cây, 57.94s), Slide 15 (bảng thời gian), Slide 20 (ảnh UI, không
còn LIVE DEMO/ticker).
- [ ] Đối chiếu nhanh với `BAO_CAO_SUA_SLIDE_TOAN_NHOM.md` nhóm A.
- [ ] Xác nhận dung lượng PPTX ~1.7 MB (không nhúng clip 76 MB).

Co-authored-by: Cursor <cursoragent@cursor.com>
</commit_message>
<xml_diff>
--- a/draft/fraud-detection/slide/[Nhom9]_Slide_FraudDetection_Academic_VN.pptx
+++ b/draft/fraud-detection/slide/[Nhom9]_Slide_FraudDetection_Academic_VN.pptx
@@ -3824,7 +3824,7 @@
                   <a:srgbClr val="FFFFFF"/>
                 </a:solidFill>
               </a:rPr>
-              <a:t>B.2: Feature Eng.</a:t>
+              <a:t>B.2: Stratified Split</a:t>
             </a:r>
             <a:endParaRPr lang="en-US" sz="850" dirty="0"/>
           </a:p>
@@ -3865,7 +3865,7 @@
                   <a:srgbClr val="1F2937"/>
                 </a:solidFill>
               </a:rPr>
-              <a:t>Tính toán 14</a:t>
+              <a:t>Phân chia chuẩn</a:t>
             </a:r>
             <a:endParaRPr lang="en-US" sz="880" dirty="0"/>
           </a:p>
@@ -3882,7 +3882,7 @@
                   <a:srgbClr val="1F2937"/>
                 </a:solidFill>
               </a:rPr>
-              <a:t>engineered</a:t>
+              <a:t>80% Train /</a:t>
             </a:r>
             <a:endParaRPr lang="en-US" sz="880" dirty="0"/>
           </a:p>
@@ -3899,7 +3899,7 @@
                   <a:srgbClr val="1F2937"/>
                 </a:solidFill>
               </a:rPr>
-              <a:t>domain features</a:t>
+              <a:t>20% Test</a:t>
             </a:r>
             <a:endParaRPr lang="en-US" sz="880" dirty="0"/>
           </a:p>
@@ -4016,7 +4016,7 @@
                   <a:srgbClr val="FFFFFF"/>
                 </a:solidFill>
               </a:rPr>
-              <a:t>B.3: Stratified Split</a:t>
+              <a:t>B.3: Feature Eng.</a:t>
             </a:r>
             <a:endParaRPr lang="en-US" sz="850" dirty="0"/>
           </a:p>
@@ -4057,7 +4057,7 @@
                   <a:srgbClr val="1F2937"/>
                 </a:solidFill>
               </a:rPr>
-              <a:t>Phân chia chuẩn</a:t>
+              <a:t>7 đặc trưng dẫn xuất</a:t>
             </a:r>
             <a:endParaRPr lang="en-US" sz="880" dirty="0"/>
           </a:p>
@@ -4074,7 +4074,7 @@
                   <a:srgbClr val="1F2937"/>
                 </a:solidFill>
               </a:rPr>
-              <a:t>80% Train /</a:t>
+              <a:t>→ 14 đặc trưng</a:t>
             </a:r>
             <a:endParaRPr lang="en-US" sz="880" dirty="0"/>
           </a:p>
@@ -4091,7 +4091,7 @@
                   <a:srgbClr val="1F2937"/>
                 </a:solidFill>
               </a:rPr>
-              <a:t>20% Test</a:t>
+              <a:t>Scaler fit Train</a:t>
             </a:r>
             <a:endParaRPr lang="en-US" sz="880" dirty="0"/>
           </a:p>
@@ -4249,7 +4249,7 @@
                   <a:srgbClr val="1F2937"/>
                 </a:solidFill>
               </a:rPr>
-              <a:t>SMOTE / ADASYN</a:t>
+              <a:t>SMOTENC / ADASYN</a:t>
             </a:r>
             <a:endParaRPr lang="en-US" sz="880" dirty="0"/>
           </a:p>
@@ -4779,7 +4779,7 @@
                 <a:ea typeface="Segoe UI" pitchFamily="34" charset="-122"/>
                 <a:cs typeface="Segoe UI" pitchFamily="34" charset="-120"/>
               </a:rPr>
-              <a:t>Phân tách Tập Dữ liệu Tuyệt đối: Phân chia Stratified Train/Test (80/20) được thực hiện TRƯỚC BẤT KỲ bước resampling hay chuẩn hóa nào.</a:t>
+              <a:t>Không rò rỉ sang tập Test: Stratified Split 80/20 thực hiện TRƯỚC resampling và chuẩn hóa; scaler chỉ fit trên Train.</a:t>
             </a:r>
             <a:endParaRPr lang="en-US" sz="930" dirty="0"/>
           </a:p>
@@ -4803,7 +4803,7 @@
                 <a:ea typeface="Segoe UI" pitchFamily="34" charset="-122"/>
                 <a:cs typeface="Segoe UI" pitchFamily="34" charset="-120"/>
               </a:rPr>
-              <a:t>Resampling Phân lập: SMOTE / ADASYN tuyệt đối CHỈ áp dụng trên tập huấn luyện (Train fold). Tập Test hoàn toàn giữ nguyên phân bố tự nhiên (0.13% fraud).</a:t>
+              <a:t>Resampling chỉ trên Train (SMOTENC / ADASYN). Tập Test giữ nguyên phân bố sau downsample (4.11% fraud, 1,643 ca), không chứa mẫu nhân tạo.</a:t>
             </a:r>
             <a:endParaRPr lang="en-US" sz="930" dirty="0"/>
           </a:p>
@@ -4827,7 +4827,7 @@
                 <a:ea typeface="Segoe UI" pitchFamily="34" charset="-122"/>
                 <a:cs typeface="Segoe UI" pitchFamily="34" charset="-120"/>
               </a:rPr>
-              <a:t>Chuẩn hóa StandardScaler: Bộ biến đổi tỷ lệ chỉ được fit trên tập Train và transform mù trên tập Test, không rò rỉ bất kỳ thông tin trung bình/độ lệch chuẩn nào.</a:t>
+              <a:t>Giới hạn: oversampling chưa nằm trong từng fold CV nên điểm CV có thể lạc quan (báo cáo mục 4.8).</a:t>
             </a:r>
             <a:endParaRPr lang="en-US" sz="930" dirty="0"/>
           </a:p>
@@ -4851,7 +4851,7 @@
                 <a:ea typeface="Segoe UI" pitchFamily="34" charset="-122"/>
                 <a:cs typeface="Segoe UI" pitchFamily="34" charset="-120"/>
               </a:rPr>
-              <a:t>Không tối ưu Hyperparameter trên Test Set: Toàn bộ quá trình chọn ngưỡng và tune tham số đều tuân thủ Cross-Validation nội bộ trên tập Train.</a:t>
+              <a:t>Không tối ưu hyperparameter trên Test: chọn ngưỡng và tune tham số bằng Cross-Validation nội bộ trên tập Train.</a:t>
             </a:r>
             <a:endParaRPr lang="en-US" sz="930" dirty="0"/>
           </a:p>
@@ -5176,48 +5176,33 @@
           </a:ln>
         </p:spPr>
       </p:sp>
-      <p:sp>
-        <p:nvSpPr>
-          <p:cNvPr id="11" name="Text 9"/>
-          <p:cNvSpPr/>
-          <p:nvPr/>
-        </p:nvSpPr>
-        <p:spPr>
-          <a:xfrm>
-            <a:off x="685800" y="1463040"/>
-            <a:ext cx="3589020" cy="274320"/>
-          </a:xfrm>
-          <a:prstGeom prst="rect">
-            <a:avLst/>
-          </a:prstGeom>
-          <a:noFill/>
-          <a:ln/>
-        </p:spPr>
-        <p:txBody>
-          <a:bodyPr wrap="square" rtlCol="0" anchor="ctr"/>
-          <a:lstStyle/>
-          <a:p>
-            <a:pPr indent="0" marL="0">
-              <a:buNone/>
-            </a:pPr>
-            <a:r>
-              <a:rPr lang="en-US" sz="950" b="1" dirty="0">
-                <a:solidFill>
-                  <a:srgbClr val="2563EB"/>
-                </a:solidFill>
-                <a:latin typeface="Consolas" pitchFamily="34" charset="0"/>
-                <a:ea typeface="Consolas" pitchFamily="34" charset="-122"/>
-                <a:cs typeface="Consolas" pitchFamily="34" charset="-120"/>
-              </a:rPr>
-              <a:t>Gini(D) = 1 - ∑ (p_i)²</a:t>
-            </a:r>
-            <a:endParaRPr lang="en-US" sz="950" dirty="0"/>
-          </a:p>
-        </p:txBody>
-      </p:sp>
-      <p:sp>
-        <p:nvSpPr>
-          <p:cNvPr id="12" name="Shape 10"/>
+      <p:pic>
+        <p:nvPicPr>
+          <p:cNvPr id="11" name="Image 0" descr="D:\Trí tuệ nhân tạo\HK2\Trí tuệ nhân tạo\CS106-Team09-Fraud-Detection\draft\fraud-detection\slide\slide_assets\formula_rf_gini.png">    </p:cNvPr>
+          <p:cNvPicPr>
+            <a:picLocks noChangeAspect="1"/>
+          </p:cNvPicPr>
+          <p:nvPr/>
+        </p:nvPicPr>
+        <p:blipFill>
+          <a:blip r:embed="rId1"/>
+          <a:stretch>
+            <a:fillRect/>
+          </a:stretch>
+        </p:blipFill>
+        <p:spPr>
+          <a:xfrm>
+            <a:off x="905256" y="1463040"/>
+            <a:ext cx="2770632" cy="301752"/>
+          </a:xfrm>
+          <a:prstGeom prst="rect">
+            <a:avLst/>
+          </a:prstGeom>
+        </p:spPr>
+      </p:pic>
+      <p:sp>
+        <p:nvSpPr>
+          <p:cNvPr id="12" name="Shape 9"/>
           <p:cNvSpPr/>
           <p:nvPr/>
         </p:nvSpPr>
@@ -5242,7 +5227,7 @@
       </p:sp>
       <p:sp>
         <p:nvSpPr>
-          <p:cNvPr id="13" name="Text 11"/>
+          <p:cNvPr id="13" name="Text 10"/>
           <p:cNvSpPr/>
           <p:nvPr/>
         </p:nvSpPr>
@@ -5304,7 +5289,7 @@
       </p:sp>
       <p:sp>
         <p:nvSpPr>
-          <p:cNvPr id="14" name="Text 12"/>
+          <p:cNvPr id="14" name="Text 11"/>
           <p:cNvSpPr/>
           <p:nvPr/>
         </p:nvSpPr>
@@ -5417,7 +5402,7 @@
       </p:sp>
       <p:sp>
         <p:nvSpPr>
-          <p:cNvPr id="15" name="Shape 13"/>
+          <p:cNvPr id="15" name="Shape 12"/>
           <p:cNvSpPr/>
           <p:nvPr/>
         </p:nvSpPr>
@@ -5442,7 +5427,7 @@
       </p:sp>
       <p:sp>
         <p:nvSpPr>
-          <p:cNvPr id="16" name="Shape 14"/>
+          <p:cNvPr id="16" name="Shape 13"/>
           <p:cNvSpPr/>
           <p:nvPr/>
         </p:nvSpPr>
@@ -5462,7 +5447,7 @@
       </p:sp>
       <p:sp>
         <p:nvSpPr>
-          <p:cNvPr id="17" name="Text 15"/>
+          <p:cNvPr id="17" name="Text 14"/>
           <p:cNvSpPr/>
           <p:nvPr/>
         </p:nvSpPr>
@@ -5498,7 +5483,7 @@
       </p:sp>
       <p:sp>
         <p:nvSpPr>
-          <p:cNvPr id="18" name="Shape 16"/>
+          <p:cNvPr id="18" name="Shape 15"/>
           <p:cNvSpPr/>
           <p:nvPr/>
         </p:nvSpPr>
@@ -5521,48 +5506,33 @@
           </a:ln>
         </p:spPr>
       </p:sp>
-      <p:sp>
-        <p:nvSpPr>
-          <p:cNvPr id="19" name="Text 17"/>
-          <p:cNvSpPr/>
-          <p:nvPr/>
-        </p:nvSpPr>
-        <p:spPr>
-          <a:xfrm>
-            <a:off x="4869180" y="1463040"/>
-            <a:ext cx="3589020" cy="274320"/>
-          </a:xfrm>
-          <a:prstGeom prst="rect">
-            <a:avLst/>
-          </a:prstGeom>
-          <a:noFill/>
-          <a:ln/>
-        </p:spPr>
-        <p:txBody>
-          <a:bodyPr wrap="square" rtlCol="0" anchor="ctr"/>
-          <a:lstStyle/>
-          <a:p>
-            <a:pPr indent="0" marL="0">
-              <a:buNone/>
-            </a:pPr>
-            <a:r>
-              <a:rPr lang="en-US" sz="900" b="1" dirty="0">
-                <a:solidFill>
-                  <a:srgbClr val="2563EB"/>
-                </a:solidFill>
-                <a:latin typeface="Consolas" pitchFamily="34" charset="0"/>
-                <a:ea typeface="Consolas" pitchFamily="34" charset="-122"/>
-                <a:cs typeface="Consolas" pitchFamily="34" charset="-120"/>
-              </a:rPr>
-              <a:t>Obj^(t) ≈ ∑ [ g_i · f_t + ½ h_i · f_t² ] + Ω(f_t)</a:t>
-            </a:r>
-            <a:endParaRPr lang="en-US" sz="900" dirty="0"/>
-          </a:p>
-        </p:txBody>
-      </p:sp>
-      <p:sp>
-        <p:nvSpPr>
-          <p:cNvPr id="20" name="Shape 18"/>
+      <p:pic>
+        <p:nvPicPr>
+          <p:cNvPr id="19" name="Image 1" descr="D:\Trí tuệ nhân tạo\HK2\Trí tuệ nhân tạo\CS106-Team09-Fraud-Detection\draft\fraud-detection\slide\slide_assets\formula_xgb_objective.png">    </p:cNvPr>
+          <p:cNvPicPr>
+            <a:picLocks noChangeAspect="1"/>
+          </p:cNvPicPr>
+          <p:nvPr/>
+        </p:nvPicPr>
+        <p:blipFill>
+          <a:blip r:embed="rId2"/>
+          <a:stretch>
+            <a:fillRect/>
+          </a:stretch>
+        </p:blipFill>
+        <p:spPr>
+          <a:xfrm>
+            <a:off x="4849978" y="1463040"/>
+            <a:ext cx="3281782" cy="274320"/>
+          </a:xfrm>
+          <a:prstGeom prst="rect">
+            <a:avLst/>
+          </a:prstGeom>
+        </p:spPr>
+      </p:pic>
+      <p:sp>
+        <p:nvSpPr>
+          <p:cNvPr id="20" name="Shape 16"/>
           <p:cNvSpPr/>
           <p:nvPr/>
         </p:nvSpPr>
@@ -5587,7 +5557,7 @@
       </p:sp>
       <p:sp>
         <p:nvSpPr>
-          <p:cNvPr id="21" name="Text 19"/>
+          <p:cNvPr id="21" name="Text 17"/>
           <p:cNvSpPr/>
           <p:nvPr/>
         </p:nvSpPr>
@@ -5649,7 +5619,7 @@
       </p:sp>
       <p:sp>
         <p:nvSpPr>
-          <p:cNvPr id="22" name="Text 20"/>
+          <p:cNvPr id="22" name="Text 18"/>
           <p:cNvSpPr/>
           <p:nvPr/>
         </p:nvSpPr>
@@ -5725,7 +5695,7 @@
                   <a:srgbClr val="1F2937"/>
                 </a:solidFill>
               </a:rPr>
-              <a:t>F1-Score đạt 99.63% tương đương RF, nhưng tốc độ huấn luyện nhanh gấp khoảng 28 lần (~42s).
+              <a:t>F1-Score đạt 99.63% tương đương RF, nhưng tốc độ huấn luyện nhanh hơn ~20 lần (57.94s; xgb_smote_summary).
 </a:t>
             </a:r>
             <a:pPr indent="0" marL="0">
@@ -5754,7 +5724,7 @@
                   <a:srgbClr val="1F2937"/>
                 </a:solidFill>
               </a:rPr>
-              <a:t>Độ trễ suy luận &lt; 0.5ms, lý tưởng cho cổng thanh toán real-time.</a:t>
+              <a:t>Độ trễ suy luận cỡ nửa mili-giây (mô hình thuần, 1 giao dịch, CPU).</a:t>
             </a:r>
             <a:endParaRPr lang="en-US" sz="900" dirty="0"/>
           </a:p>
@@ -6106,8 +6076,8 @@
         </p:nvSpPr>
         <p:spPr>
           <a:xfrm>
-            <a:off x="640080" y="1645920"/>
-            <a:ext cx="4114800" cy="310896"/>
+            <a:off x="640080" y="1627632"/>
+            <a:ext cx="4114800" cy="402336"/>
           </a:xfrm>
           <a:prstGeom prst="rect">
             <a:avLst/>
@@ -6123,48 +6093,33 @@
           </a:ln>
         </p:spPr>
       </p:sp>
-      <p:sp>
-        <p:nvSpPr>
-          <p:cNvPr id="12" name="Text 10"/>
-          <p:cNvSpPr/>
-          <p:nvPr/>
-        </p:nvSpPr>
-        <p:spPr>
-          <a:xfrm>
-            <a:off x="685800" y="1673352"/>
-            <a:ext cx="4023360" cy="256032"/>
-          </a:xfrm>
-          <a:prstGeom prst="rect">
-            <a:avLst/>
-          </a:prstGeom>
-          <a:noFill/>
-          <a:ln/>
-        </p:spPr>
-        <p:txBody>
-          <a:bodyPr wrap="square" rtlCol="0" anchor="ctr"/>
-          <a:lstStyle/>
-          <a:p>
-            <a:pPr indent="0" marL="0">
-              <a:buNone/>
-            </a:pPr>
-            <a:r>
-              <a:rPr lang="en-US" sz="900" b="1" dirty="0">
-                <a:solidFill>
-                  <a:srgbClr val="DC2626"/>
-                </a:solidFill>
-                <a:latin typeface="Consolas" pitchFamily="34" charset="0"/>
-                <a:ea typeface="Consolas" pitchFamily="34" charset="-122"/>
-                <a:cs typeface="Consolas" pitchFamily="34" charset="-120"/>
-              </a:rPr>
-              <a:t>L_rec(x, x_recon) = (1 / d) · ∑ (x_j - x_recon_j)²</a:t>
-            </a:r>
-            <a:endParaRPr lang="en-US" sz="900" dirty="0"/>
-          </a:p>
-        </p:txBody>
-      </p:sp>
-      <p:sp>
-        <p:nvSpPr>
-          <p:cNvPr id="13" name="Text 11"/>
+      <p:pic>
+        <p:nvPicPr>
+          <p:cNvPr id="12" name="Image 0" descr="D:\Trí tuệ nhân tạo\HK2\Trí tuệ nhân tạo\CS106-Team09-Fraud-Detection\draft\fraud-detection\slide\slide_assets\formula_ae_reconstruction.png">    </p:cNvPr>
+          <p:cNvPicPr>
+            <a:picLocks noChangeAspect="1"/>
+          </p:cNvPicPr>
+          <p:nvPr/>
+        </p:nvPicPr>
+        <p:blipFill>
+          <a:blip r:embed="rId1"/>
+          <a:stretch>
+            <a:fillRect/>
+          </a:stretch>
+        </p:blipFill>
+        <p:spPr>
+          <a:xfrm>
+            <a:off x="1028700" y="1633118"/>
+            <a:ext cx="2251253" cy="391363"/>
+          </a:xfrm>
+          <a:prstGeom prst="rect">
+            <a:avLst/>
+          </a:prstGeom>
+        </p:spPr>
+      </p:pic>
+      <p:sp>
+        <p:nvSpPr>
+          <p:cNvPr id="13" name="Text 10"/>
           <p:cNvSpPr/>
           <p:nvPr/>
         </p:nvSpPr>
@@ -6280,7 +6235,7 @@
       </p:sp>
       <p:sp>
         <p:nvSpPr>
-          <p:cNvPr id="14" name="Shape 12"/>
+          <p:cNvPr id="14" name="Shape 11"/>
           <p:cNvSpPr/>
           <p:nvPr/>
         </p:nvSpPr>
@@ -6305,7 +6260,7 @@
       </p:sp>
       <p:sp>
         <p:nvSpPr>
-          <p:cNvPr id="15" name="Text 13"/>
+          <p:cNvPr id="15" name="Text 12"/>
           <p:cNvSpPr/>
           <p:nvPr/>
         </p:nvSpPr>
@@ -7611,7 +7566,7 @@
       </p:graphicFrame>
       <p:sp>
         <p:nvSpPr>
-          <p:cNvPr id="17" name="Shape 14"/>
+          <p:cNvPr id="17" name="Shape 13"/>
           <p:cNvSpPr/>
           <p:nvPr/>
         </p:nvSpPr>
@@ -7636,7 +7591,7 @@
       </p:sp>
       <p:sp>
         <p:nvSpPr>
-          <p:cNvPr id="18" name="Text 15"/>
+          <p:cNvPr id="18" name="Text 14"/>
           <p:cNvSpPr/>
           <p:nvPr/>
         </p:nvSpPr>
@@ -7675,7 +7630,7 @@
       </p:sp>
       <p:sp>
         <p:nvSpPr>
-          <p:cNvPr id="19" name="Text 16"/>
+          <p:cNvPr id="19" name="Text 15"/>
           <p:cNvSpPr/>
           <p:nvPr/>
         </p:nvSpPr>
@@ -7739,7 +7694,7 @@
                 <a:ea typeface="Segoe UI" pitchFamily="34" charset="-122"/>
                 <a:cs typeface="Segoe UI" pitchFamily="34" charset="-120"/>
               </a:rPr>
-              <a:t>Không phụ thuộc nhãn: Phát hiện bất thường theo nguyên lý sai số tái tạo (Reconstruction MSE).</a:t>
+              <a:t>Không phụ thuộc nhãn khi train: Phát hiện bất thường theo sai số tái tạo (nhãn chỉ dùng để chọn ngưỡng).</a:t>
             </a:r>
             <a:endParaRPr lang="en-US" sz="880" dirty="0"/>
           </a:p>
@@ -9948,7 +9903,7 @@
                           <a:ea typeface="Segoe UI" pitchFamily="34" charset="-122"/>
                           <a:cs typeface="Segoe UI" pitchFamily="34" charset="-120"/>
                         </a:rPr>
-                        <a:t>41.7s</a:t>
+                        <a:t>57.94s</a:t>
                       </a:r>
                       <a:endParaRPr lang="en-US" sz="820" dirty="0">
                         <a:latin typeface="Segoe UI" charset="0"/>
@@ -10358,7 +10313,7 @@
                           <a:ea typeface="Segoe UI" pitchFamily="34" charset="-122"/>
                           <a:cs typeface="Segoe UI" pitchFamily="34" charset="-120"/>
                         </a:rPr>
-                        <a:t>43.2s</a:t>
+                        <a:t>45.48s</a:t>
                       </a:r>
                       <a:endParaRPr lang="en-US" sz="820" dirty="0">
                         <a:latin typeface="Segoe UI" charset="0"/>
@@ -10428,7 +10383,7 @@
                           <a:ea typeface="Segoe UI" pitchFamily="34" charset="-122"/>
                           <a:cs typeface="Segoe UI" pitchFamily="34" charset="-120"/>
                         </a:rPr>
-                        <a:t>Autoencoder (Zero-Day)</a:t>
+                        <a:t>Autoencoder (Unsupervised)</a:t>
                       </a:r>
                       <a:endParaRPr lang="en-US" sz="820" dirty="0">
                         <a:latin typeface="Segoe UI" charset="0"/>
@@ -10768,7 +10723,7 @@
                           <a:ea typeface="Segoe UI" pitchFamily="34" charset="-122"/>
                           <a:cs typeface="Segoe UI" pitchFamily="34" charset="-120"/>
                         </a:rPr>
-                        <a:t>68.4s</a:t>
+                        <a:t>—</a:t>
                       </a:r>
                       <a:endParaRPr lang="en-US" sz="820" dirty="0">
                         <a:latin typeface="Segoe UI" charset="0"/>
@@ -10954,7 +10909,7 @@
                 <a:ea typeface="Segoe UI" pitchFamily="34" charset="-122"/>
                 <a:cs typeface="Segoe UI" pitchFamily="34" charset="-120"/>
               </a:rPr>
-              <a:t>XGBoost + SMOTE đạt hiệu năng tương đương (F1 = 99.63%) nhưng tốc độ huấn luyện nhanh gấp 28.5 lần.</a:t>
+              <a:t>XGBoost + SMOTE đạt hiệu năng tương đương (F1 = 99.63%) nhưng tốc độ huấn luyện nhanh hơn ~20 lần (57.94s).</a:t>
             </a:r>
             <a:endParaRPr lang="en-US" sz="860" dirty="0"/>
           </a:p>
@@ -10978,7 +10933,7 @@
                 <a:ea typeface="Segoe UI" pitchFamily="34" charset="-122"/>
                 <a:cs typeface="Segoe UI" pitchFamily="34" charset="-120"/>
               </a:rPr>
-              <a:t>Autoencoder bắt được 75.23% gian lận hoàn toàn không cần nhãn giám sát, tạo lớp phòng thủ Zero-Day vững chắc.</a:t>
+              <a:t>Autoencoder bắt được 75.23% gian lận hoàn toàn không cần nhãn giám sát, tạo lớp phòng thủ phát hiện bất thường thứ cấp.</a:t>
             </a:r>
             <a:endParaRPr lang="en-US" sz="860" dirty="0"/>
           </a:p>
@@ -11138,7 +11093,7 @@
                 <a:ea typeface="Segoe UI" pitchFamily="34" charset="-122"/>
                 <a:cs typeface="Segoe UI" pitchFamily="34" charset="-120"/>
               </a:rPr>
-              <a:t>Autoencoder hy sinh Precision (38.2%) để duy trì Recall cao (75.2%) nhằm phòng ngừa triệt để tổn thất tài chính.</a:t>
+              <a:t>Autoencoder hy sinh Precision (38.2%) để duy trì Recall cao (75.2%) nhằm giảm bỏ sót.</a:t>
             </a:r>
             <a:endParaRPr lang="en-US" sz="840" dirty="0"/>
           </a:p>
@@ -11725,7 +11680,7 @@
                   <a:srgbClr val="1F2937"/>
                 </a:solidFill>
               </a:rPr>
-              <a:t>• Độ trễ suy luận &lt; 0.5ms — cấu hình tối ưu nhất cho môi trường thực tế.</a:t>
+              <a:t>• Độ trễ cỡ nửa mili-giây (mô hình thuần, 1 giao dịch, CPU).</a:t>
             </a:r>
             <a:endParaRPr lang="en-US" sz="820" dirty="0"/>
           </a:p>
@@ -11786,7 +11741,7 @@
                   <a:srgbClr val="DC2626"/>
                 </a:solidFill>
               </a:rPr>
-              <a:t>Deep Autoencoder (Zero-Day)</a:t>
+              <a:t>Deep Autoencoder (Unsupervised)</a:t>
             </a:r>
             <a:endParaRPr lang="en-US" sz="950" dirty="0"/>
           </a:p>
@@ -14073,7 +14028,7 @@
                 <a:ea typeface="Segoe UI" pitchFamily="34" charset="-122"/>
                 <a:cs typeface="Segoe UI" pitchFamily="34" charset="-120"/>
               </a:rPr>
-              <a:t>Giao dịch gian lận (Đỏ) có sai số tái tạo trải dài sang phải do cấu trúc dòng tiền dị biệt không thể nén qua bottleneck.</a:t>
+              <a:t>Giao dịch gian lận (Đỏ) có sai số tái tạo trải dài sang phải; trục x cắt ở 0.18 nên 37.6% ca gian lận nằm ngoài hình.</a:t>
             </a:r>
             <a:endParaRPr lang="en-US" sz="830" dirty="0"/>
           </a:p>
@@ -15911,7 +15866,7 @@
                 <a:ea typeface="Segoe UI" pitchFamily="34" charset="-122"/>
                 <a:cs typeface="Segoe UI" pitchFamily="34" charset="-120"/>
               </a:rPr>
-              <a:t>Kiến trúc Dashboard Streamlit Real-Time Inference &amp; Batch CSV Scoring</a:t>
+              <a:t>Dashboard Streamlit suy luận XGBoost &amp; nhập dữ liệu mẫu CSV/JSON (tối đa 50 mẫu)</a:t>
             </a:r>
             <a:endParaRPr lang="en-US" sz="1100" dirty="0"/>
           </a:p>
@@ -16396,7 +16351,7 @@
                   <a:srgbClr val="4B5563"/>
                 </a:solidFill>
               </a:rPr>
-              <a:t>Khu biệt loại giao dịch, dấu vết rút cạn số dư và 14 engineered features.</a:t>
+              <a:t>Khu biệt loại giao dịch, dấu vết rút cạn số dư và 14 đặc trưng (7 dẫn xuất).</a:t>
             </a:r>
             <a:endParaRPr lang="en-US" sz="1250" dirty="0"/>
           </a:p>
@@ -16978,360 +16933,33 @@
           </a:ln>
         </p:spPr>
       </p:sp>
-      <p:sp>
-        <p:nvSpPr>
-          <p:cNvPr id="8" name="Shape 6"/>
-          <p:cNvSpPr/>
-          <p:nvPr/>
-        </p:nvSpPr>
-        <p:spPr>
-          <a:xfrm>
-            <a:off x="502920" y="987552"/>
-            <a:ext cx="5029200" cy="274320"/>
-          </a:xfrm>
-          <a:prstGeom prst="rect">
-            <a:avLst/>
-          </a:prstGeom>
-          <a:solidFill>
-            <a:srgbClr val="1E293B"/>
-          </a:solidFill>
-          <a:ln/>
-        </p:spPr>
-      </p:sp>
-      <p:sp>
-        <p:nvSpPr>
-          <p:cNvPr id="9" name="Text 7"/>
-          <p:cNvSpPr/>
-          <p:nvPr/>
-        </p:nvSpPr>
-        <p:spPr>
-          <a:xfrm>
-            <a:off x="640080" y="987552"/>
-            <a:ext cx="4754880" cy="274320"/>
-          </a:xfrm>
-          <a:prstGeom prst="rect">
-            <a:avLst/>
-          </a:prstGeom>
-          <a:noFill/>
-          <a:ln/>
-        </p:spPr>
-        <p:txBody>
-          <a:bodyPr wrap="square" rtlCol="0" anchor="ctr"/>
-          <a:lstStyle/>
-          <a:p>
-            <a:pPr indent="0" marL="0">
-              <a:buNone/>
-            </a:pPr>
-            <a:r>
-              <a:rPr lang="en-US" sz="880" b="1" dirty="0">
-                <a:solidFill>
-                  <a:srgbClr val="60A5FA"/>
-                </a:solidFill>
-                <a:latin typeface="Consolas" pitchFamily="34" charset="0"/>
-                <a:ea typeface="Consolas" pitchFamily="34" charset="-122"/>
-                <a:cs typeface="Consolas" pitchFamily="34" charset="-120"/>
-              </a:rPr>
-              <a:t>🔴 LIVE DEMO  •  Streamlit Real-Time Fraud Shield  |  XGBoost-SMOTE &amp; Autoencoder</a:t>
-            </a:r>
-            <a:endParaRPr lang="en-US" sz="880" dirty="0"/>
-          </a:p>
-        </p:txBody>
-      </p:sp>
-      <p:sp>
-        <p:nvSpPr>
-          <p:cNvPr id="10" name="Shape 8"/>
-          <p:cNvSpPr/>
-          <p:nvPr/>
-        </p:nvSpPr>
-        <p:spPr>
-          <a:xfrm>
-            <a:off x="676656" y="1325880"/>
-            <a:ext cx="4681728" cy="2633472"/>
-          </a:xfrm>
-          <a:prstGeom prst="rect">
-            <a:avLst/>
-          </a:prstGeom>
-          <a:solidFill>
-            <a:srgbClr val="0B1120"/>
-          </a:solidFill>
-          <a:ln w="19050">
-            <a:solidFill>
-              <a:srgbClr val="38BDF8"/>
-            </a:solidFill>
-            <a:prstDash val="solid"/>
-          </a:ln>
-        </p:spPr>
-      </p:sp>
-      <p:sp>
-        <p:nvSpPr>
-          <p:cNvPr id="11" name="Text 9"/>
-          <p:cNvSpPr/>
-          <p:nvPr/>
-        </p:nvSpPr>
-        <p:spPr>
-          <a:xfrm>
-            <a:off x="676656" y="1645920"/>
-            <a:ext cx="4681728" cy="594360"/>
-          </a:xfrm>
-          <a:prstGeom prst="rect">
-            <a:avLst/>
-          </a:prstGeom>
-          <a:noFill/>
-          <a:ln/>
-        </p:spPr>
-        <p:txBody>
-          <a:bodyPr wrap="square" rtlCol="0" anchor="ctr"/>
-          <a:lstStyle/>
-          <a:p>
-            <a:pPr algn="ctr" indent="0" marL="0">
-              <a:buNone/>
-            </a:pPr>
-            <a:r>
-              <a:rPr lang="en-US" sz="3600" b="1" dirty="0">
-                <a:solidFill>
-                  <a:srgbClr val="38BDF8"/>
-                </a:solidFill>
-              </a:rPr>
-              <a:t>▶</a:t>
-            </a:r>
-            <a:endParaRPr lang="en-US" sz="3600" dirty="0"/>
-          </a:p>
-        </p:txBody>
-      </p:sp>
-      <p:sp>
-        <p:nvSpPr>
-          <p:cNvPr id="12" name="Text 10"/>
-          <p:cNvSpPr/>
-          <p:nvPr/>
-        </p:nvSpPr>
-        <p:spPr>
-          <a:xfrm>
-            <a:off x="813816" y="2286000"/>
-            <a:ext cx="4407408" cy="502920"/>
-          </a:xfrm>
-          <a:prstGeom prst="rect">
-            <a:avLst/>
-          </a:prstGeom>
-          <a:noFill/>
-          <a:ln/>
-        </p:spPr>
-        <p:txBody>
-          <a:bodyPr wrap="square" rtlCol="0" anchor="ctr"/>
-          <a:lstStyle/>
-          <a:p>
-            <a:pPr algn="ctr" indent="0" marL="0">
-              <a:lnSpc>
-                <a:spcPct val="120000"/>
-              </a:lnSpc>
-              <a:buNone/>
-            </a:pPr>
-            <a:r>
-              <a:rPr lang="en-US" sz="1000" b="1" dirty="0">
-                <a:solidFill>
-                  <a:srgbClr val="E2E8F0"/>
-                </a:solidFill>
-                <a:latin typeface="Segoe UI" pitchFamily="34" charset="0"/>
-                <a:ea typeface="Segoe UI" pitchFamily="34" charset="-122"/>
-                <a:cs typeface="Segoe UI" pitchFamily="34" charset="-120"/>
-              </a:rPr>
-              <a:t>[ KHUNG CHÈN VIDEO DEMO STREAMLIT ]</a:t>
-            </a:r>
-            <a:endParaRPr lang="en-US" sz="1000" dirty="0"/>
-          </a:p>
-          <a:p>
-            <a:pPr algn="ctr" indent="0" marL="0">
-              <a:lnSpc>
-                <a:spcPct val="120000"/>
-              </a:lnSpc>
-              <a:buNone/>
-            </a:pPr>
-            <a:r>
-              <a:rPr lang="en-US" sz="1000" b="1" dirty="0">
-                <a:solidFill>
-                  <a:srgbClr val="E2E8F0"/>
-                </a:solidFill>
-                <a:latin typeface="Segoe UI" pitchFamily="34" charset="0"/>
-                <a:ea typeface="Segoe UI" pitchFamily="34" charset="-122"/>
-                <a:cs typeface="Segoe UI" pitchFamily="34" charset="-120"/>
-              </a:rPr>
-              <a:t>(Tỷ lệ Chuẩn 16:9 — 1920×1080 / 1280×720 MP4/GIF)</a:t>
-            </a:r>
-            <a:endParaRPr lang="en-US" sz="1000" dirty="0"/>
-          </a:p>
-        </p:txBody>
-      </p:sp>
-      <p:sp>
-        <p:nvSpPr>
-          <p:cNvPr id="13" name="Text 11"/>
-          <p:cNvSpPr/>
-          <p:nvPr/>
-        </p:nvSpPr>
-        <p:spPr>
-          <a:xfrm>
-            <a:off x="813816" y="2862072"/>
-            <a:ext cx="4407408" cy="228600"/>
-          </a:xfrm>
-          <a:prstGeom prst="rect">
-            <a:avLst/>
-          </a:prstGeom>
-          <a:noFill/>
-          <a:ln/>
-        </p:spPr>
-        <p:txBody>
-          <a:bodyPr wrap="square" rtlCol="0" anchor="ctr"/>
-          <a:lstStyle/>
-          <a:p>
-            <a:pPr algn="ctr" indent="0" marL="0">
-              <a:buNone/>
-            </a:pPr>
-            <a:r>
-              <a:rPr lang="en-US" sz="850" i="1" dirty="0">
-                <a:solidFill>
-                  <a:srgbClr val="94A3B8"/>
-                </a:solidFill>
-                <a:latin typeface="Segoe UI" pitchFamily="34" charset="0"/>
-                <a:ea typeface="Segoe UI" pitchFamily="34" charset="-122"/>
-                <a:cs typeface="Segoe UI" pitchFamily="34" charset="-120"/>
-              </a:rPr>
-              <a:t>Giao diện phân tích rủi ro thời gian thực &amp; Chấm điểm Batch CSV</a:t>
-            </a:r>
-            <a:endParaRPr lang="en-US" sz="850" dirty="0"/>
-          </a:p>
-        </p:txBody>
-      </p:sp>
-      <p:sp>
-        <p:nvSpPr>
-          <p:cNvPr id="14" name="Shape 12"/>
-          <p:cNvSpPr/>
-          <p:nvPr/>
-        </p:nvSpPr>
-        <p:spPr>
-          <a:xfrm>
-            <a:off x="2011680" y="3291840"/>
-            <a:ext cx="2011680" cy="292608"/>
-          </a:xfrm>
-          <a:prstGeom prst="roundRect">
-            <a:avLst>
-              <a:gd name="adj" fmla="val 25000"/>
-            </a:avLst>
-          </a:prstGeom>
-          <a:solidFill>
-            <a:srgbClr val="1E293B"/>
-          </a:solidFill>
-          <a:ln w="10160">
-            <a:solidFill>
-              <a:srgbClr val="64748B"/>
-            </a:solidFill>
-            <a:prstDash val="solid"/>
-          </a:ln>
-        </p:spPr>
-      </p:sp>
-      <p:sp>
-        <p:nvSpPr>
-          <p:cNvPr id="15" name="Text 13"/>
-          <p:cNvSpPr/>
-          <p:nvPr/>
-        </p:nvSpPr>
-        <p:spPr>
-          <a:xfrm>
-            <a:off x="2011680" y="3291840"/>
-            <a:ext cx="2011680" cy="292608"/>
-          </a:xfrm>
-          <a:prstGeom prst="rect">
-            <a:avLst/>
-          </a:prstGeom>
-          <a:noFill/>
-          <a:ln/>
-        </p:spPr>
-        <p:txBody>
-          <a:bodyPr wrap="square" rtlCol="0" anchor="ctr"/>
-          <a:lstStyle/>
-          <a:p>
-            <a:pPr algn="ctr" indent="0" marL="0">
-              <a:buNone/>
-            </a:pPr>
-            <a:r>
-              <a:rPr lang="en-US" sz="820" b="1" dirty="0">
-                <a:solidFill>
-                  <a:srgbClr val="38BDF8"/>
-                </a:solidFill>
-                <a:latin typeface="Consolas" pitchFamily="34" charset="0"/>
-                <a:ea typeface="Consolas" pitchFamily="34" charset="-122"/>
-                <a:cs typeface="Consolas" pitchFamily="34" charset="-120"/>
-              </a:rPr>
-              <a:t>HD 1080p  •  TỶ LỆ 16:9</a:t>
-            </a:r>
-            <a:endParaRPr lang="en-US" sz="820" dirty="0"/>
-          </a:p>
-        </p:txBody>
-      </p:sp>
-      <p:sp>
-        <p:nvSpPr>
-          <p:cNvPr id="16" name="Shape 14"/>
-          <p:cNvSpPr/>
-          <p:nvPr/>
-        </p:nvSpPr>
-        <p:spPr>
-          <a:xfrm>
-            <a:off x="640080" y="4023360"/>
-            <a:ext cx="4754880" cy="457200"/>
-          </a:xfrm>
-          <a:prstGeom prst="rect">
-            <a:avLst/>
-          </a:prstGeom>
-          <a:solidFill>
-            <a:srgbClr val="131C31"/>
-          </a:solidFill>
-          <a:ln w="12700">
-            <a:solidFill>
-              <a:srgbClr val="1E293B"/>
-            </a:solidFill>
-            <a:prstDash val="solid"/>
-          </a:ln>
-        </p:spPr>
-      </p:sp>
-      <p:sp>
-        <p:nvSpPr>
-          <p:cNvPr id="17" name="Text 15"/>
-          <p:cNvSpPr/>
-          <p:nvPr/>
-        </p:nvSpPr>
-        <p:spPr>
-          <a:xfrm>
-            <a:off x="685800" y="4023360"/>
-            <a:ext cx="4663440" cy="457200"/>
-          </a:xfrm>
-          <a:prstGeom prst="rect">
-            <a:avLst/>
-          </a:prstGeom>
-          <a:noFill/>
-          <a:ln/>
-        </p:spPr>
-        <p:txBody>
-          <a:bodyPr wrap="square" rtlCol="0" anchor="ctr"/>
-          <a:lstStyle/>
-          <a:p>
-            <a:pPr algn="ctr" indent="0" marL="0">
-              <a:buNone/>
-            </a:pPr>
-            <a:r>
-              <a:rPr lang="en-US" sz="780" dirty="0">
-                <a:solidFill>
-                  <a:srgbClr val="CBD5E1"/>
-                </a:solidFill>
-                <a:latin typeface="Consolas" pitchFamily="34" charset="0"/>
-                <a:ea typeface="Consolas" pitchFamily="34" charset="-122"/>
-                <a:cs typeface="Consolas" pitchFamily="34" charset="-120"/>
-              </a:rPr>
-              <a:t>3 Kịch bản: 1. Hợp lệ (&lt; 0.1%)  |  2. Vét cạn số dư (88.36%)  |  3. Cận biên ban đêm (~32%)</a:t>
-            </a:r>
-            <a:endParaRPr lang="en-US" sz="780" dirty="0"/>
-          </a:p>
-        </p:txBody>
-      </p:sp>
-      <p:sp>
-        <p:nvSpPr>
-          <p:cNvPr id="18" name="Shape 16"/>
+      <p:pic>
+        <p:nvPicPr>
+          <p:cNvPr id="8" name="Image 0" descr="D:\Trí tuệ nhân tạo\HK2\Trí tuệ nhân tạo\CS106-Team09-Fraud-Detection\draft\fraud-detection\slide\slide_assets\demo_ui_slide20.png">    </p:cNvPr>
+          <p:cNvPicPr>
+            <a:picLocks noChangeAspect="1"/>
+          </p:cNvPicPr>
+          <p:nvPr/>
+        </p:nvPicPr>
+        <p:blipFill>
+          <a:blip r:embed="rId1"/>
+          <a:stretch>
+            <a:fillRect/>
+          </a:stretch>
+        </p:blipFill>
+        <p:spPr>
+          <a:xfrm>
+            <a:off x="557784" y="1042416"/>
+            <a:ext cx="4919472" cy="3474720"/>
+          </a:xfrm>
+          <a:prstGeom prst="rect">
+            <a:avLst/>
+          </a:prstGeom>
+        </p:spPr>
+      </p:pic>
+      <p:sp>
+        <p:nvSpPr>
+          <p:cNvPr id="9" name="Shape 6"/>
           <p:cNvSpPr/>
           <p:nvPr/>
         </p:nvSpPr>
@@ -17356,7 +16984,7 @@
       </p:sp>
       <p:sp>
         <p:nvSpPr>
-          <p:cNvPr id="19" name="Text 17"/>
+          <p:cNvPr id="10" name="Text 7"/>
           <p:cNvSpPr/>
           <p:nvPr/>
         </p:nvSpPr>
@@ -17395,7 +17023,7 @@
       </p:sp>
       <p:sp>
         <p:nvSpPr>
-          <p:cNvPr id="20" name="Text 18"/>
+          <p:cNvPr id="11" name="Text 8"/>
           <p:cNvSpPr/>
           <p:nvPr/>
         </p:nvSpPr>
@@ -17435,7 +17063,7 @@
                 <a:ea typeface="Segoe UI" pitchFamily="34" charset="-122"/>
                 <a:cs typeface="Segoe UI" pitchFamily="34" charset="-120"/>
               </a:rPr>
-              <a:t>Quy chuẩn Leak-Free: 80/20 Stratified Split chống rò rỉ dữ liệu.</a:t>
+              <a:t>Không rò rỉ sang Test: split 80/20 trước, scaler và oversampling chỉ trên Train.</a:t>
             </a:r>
             <a:endParaRPr lang="en-US" sz="840" dirty="0"/>
           </a:p>
@@ -17459,7 +17087,7 @@
                 <a:ea typeface="Segoe UI" pitchFamily="34" charset="-122"/>
                 <a:cs typeface="Segoe UI" pitchFamily="34" charset="-120"/>
               </a:rPr>
-              <a:t>Đặc trưng Số dư: Nhóm số dư chiếm &gt; 97% split gains (ghi nhận rủi ro simulator artifact).</a:t>
+              <a:t>Đặc trưng Số dư: Nhóm số dư chiếm &gt; 97% split gains (rủi ro simulator artifact, Mục 3.6.2).</a:t>
             </a:r>
             <a:endParaRPr lang="en-US" sz="840" dirty="0"/>
           </a:p>
@@ -17507,7 +17135,7 @@
                 <a:ea typeface="Segoe UI" pitchFamily="34" charset="-122"/>
                 <a:cs typeface="Segoe UI" pitchFamily="34" charset="-120"/>
               </a:rPr>
-              <a:t>Phòng thủ Đa tầng: Phối hợp XGBoost phát hiện nhanh và Autoencoder bắt bất thường.</a:t>
+              <a:t>Demo suy luận bằng XGBoost-SMOTE; Autoencoder dùng để so sánh bất thường, không phải model chọn trên UI.</a:t>
             </a:r>
             <a:endParaRPr lang="en-US" sz="840" dirty="0"/>
           </a:p>
@@ -17515,7 +17143,7 @@
       </p:sp>
       <p:sp>
         <p:nvSpPr>
-          <p:cNvPr id="21" name="Shape 19"/>
+          <p:cNvPr id="12" name="Shape 9"/>
           <p:cNvSpPr/>
           <p:nvPr/>
         </p:nvSpPr>
@@ -17540,7 +17168,7 @@
       </p:sp>
       <p:sp>
         <p:nvSpPr>
-          <p:cNvPr id="22" name="Text 20"/>
+          <p:cNvPr id="13" name="Text 10"/>
           <p:cNvSpPr/>
           <p:nvPr/>
         </p:nvSpPr>
@@ -17579,7 +17207,7 @@
       </p:sp>
       <p:sp>
         <p:nvSpPr>
-          <p:cNvPr id="23" name="Text 21"/>
+          <p:cNvPr id="14" name="Text 11"/>
           <p:cNvSpPr/>
           <p:nvPr/>
         </p:nvSpPr>
@@ -18680,7 +18308,7 @@
                   <a:srgbClr val="1F2937"/>
                 </a:solidFill>
               </a:rPr>
-              <a:t>• Gian lận chỉ chiếm ~1 trên 800 giao dịch (8,213 ca trên 6.36M sự kiện trong PaySim).
+              <a:t>• Gian lận chỉ chiếm ~1 trên 775 giao dịch (8,213 ca trên 6.36M sự kiện trong PaySim).
 </a:t>
             </a:r>
             <a:pPr indent="0" marL="0">
@@ -19959,7 +19587,7 @@
                 <a:ea typeface="Segoe UI" pitchFamily="34" charset="-122"/>
                 <a:cs typeface="Segoe UI" pitchFamily="34" charset="-120"/>
               </a:rPr>
-              <a:t>Xây dựng end-to-end ML pipeline chuẩn, đảm bảo Leak-Free tuyệt đối.</a:t>
+              <a:t>Xây dựng end-to-end ML pipeline chuẩn, đảm bảo nguyên tắc phân lập dữ liệu Leak-Free.</a:t>
             </a:r>
             <a:endParaRPr lang="en-US" sz="950" dirty="0"/>
           </a:p>
@@ -19983,7 +19611,7 @@
                 <a:ea typeface="Segoe UI" pitchFamily="34" charset="-122"/>
                 <a:cs typeface="Segoe UI" pitchFamily="34" charset="-120"/>
               </a:rPr>
-              <a:t>Thiết kế 14 features bắt trọn sai lệch số dư tài khoản.</a:t>
+              <a:t>Thiết kế 14 đặc trưng (7 dẫn xuất) bắt trọn sai lệch số dư tài khoản.</a:t>
             </a:r>
             <a:endParaRPr lang="en-US" sz="950" dirty="0"/>
           </a:p>
@@ -20007,7 +19635,7 @@
                 <a:ea typeface="Segoe UI" pitchFamily="34" charset="-122"/>
                 <a:cs typeface="Segoe UI" pitchFamily="34" charset="-120"/>
               </a:rPr>
-              <a:t>So sánh Ensemble Trees với Unsupervised Deep Autoencoder bắt Zero-Day.</a:t>
+              <a:t>So sánh Ensemble Trees với Unsupervised Deep Autoencoder phát hiện bất thường.</a:t>
             </a:r>
             <a:endParaRPr lang="en-US" sz="950" dirty="0"/>
           </a:p>
@@ -21036,7 +20664,7 @@
                           <a:ea typeface="Segoe UI" pitchFamily="34" charset="-122"/>
                           <a:cs typeface="Segoe UI" pitchFamily="34" charset="-120"/>
                         </a:rPr>
-                        <a:t>Bước thời gian theo giờ (1..744, tương ứng 30 ngày mô phỏng)</a:t>
+                        <a:t>Bước thời gian theo giờ (1..743, tương ứng 30 ngày mô phỏng)</a:t>
                       </a:r>
                       <a:endParaRPr lang="en-US" sz="880" dirty="0">
                         <a:latin typeface="Segoe UI" charset="0"/>
@@ -22018,7 +21646,7 @@
                 <a:ea typeface="Segoe UI" pitchFamily="34" charset="-122"/>
                 <a:cs typeface="Segoe UI" pitchFamily="34" charset="-120"/>
               </a:rPr>
-              <a:t>100% tất cả các ca gian lận trong 6.36M giao dịch CHỈ xuất hiện ở 2 loại: TRANSFER và CASH_OUT. Các loại PAYMENT, CASH_IN và DEBIT hoàn toàn an toàn (0% gian lận). Do đó, bước tiền xử lý lọc chỉ giữ lại TRANSFER &amp; CASH_OUT giúp triệt tiêu 70% dữ liệu nhiễu.</a:t>
+              <a:t>100% tất cả các ca gian lận trong 6.36M giao dịch CHỈ xuất hiện ở 2 loại: TRANSFER và CASH_OUT. Các loại PAYMENT, CASH_IN và DEBIT hoàn toàn an toàn (0% gian lận). Do đó, bước tiền xử lý lọc chỉ giữ lại TRANSFER &amp; CASH_OUT giúp loại bỏ ~56.5% giao dịch hoàn toàn không có gian lận.</a:t>
             </a:r>
             <a:endParaRPr lang="en-US" sz="930" dirty="0"/>
           </a:p>
@@ -22318,7 +21946,7 @@
                 <a:ea typeface="Segoe UI" pitchFamily="34" charset="-122"/>
                 <a:cs typeface="Segoe UI" pitchFamily="34" charset="-120"/>
               </a:rPr>
-              <a:t>Công thức Toán học của 14 Engineered Domain Features</a:t>
+              <a:t>Công thức toán học của 14 đặc trưng miền (7 dẫn xuất)</a:t>
             </a:r>
             <a:endParaRPr lang="en-US" sz="1100" dirty="0"/>
           </a:p>
@@ -22771,7 +22399,7 @@
                   <a:srgbClr val="1F2937"/>
                 </a:solidFill>
               </a:rPr>
-              <a:t>Lọc tập dữ liệu chỉ giữ lại TRANSFER &amp; CASH_OUT, triệt tiêu ngay 70% dữ liệu nhiễu vô ích.</a:t>
+              <a:t>Lọc tập dữ liệu chỉ giữ lại TRANSFER &amp; CASH_OUT, loại bỏ ~56% giao dịch không có rủi ro gian lận.</a:t>
             </a:r>
             <a:endParaRPr lang="en-US" sz="980" dirty="0"/>
           </a:p>
@@ -23174,7 +22802,7 @@
                   <a:srgbClr val="1F2937"/>
                 </a:solidFill>
               </a:rPr>
-              <a:t>• Phản ánh tài khoản rác (mule account) hoặc luân chuyển rửa tiền đa tầng tức thì.
+              <a:t>• Phản ánh tài khoản rác hoặc luân chuyển rửa tiền đa tầng tức thì (diễn giải, dữ liệu mô phỏng).
 </a:t>
             </a:r>
             <a:pPr indent="0" marL="0">
@@ -25448,7 +25076,7 @@
                   <a:srgbClr val="1F2937"/>
                 </a:solidFill>
               </a:rPr>
-              <a:t>Một mô hình ngây thơ luôn dự đoán 100% là "Hợp lệ" vẫn đạt Accuracy 99.87% nhưng bỏ sót 100% gian lận! Do đó, đánh giá mô hình phải dẫn dắt bởi Precision, Recall, F1-Score và PR-AUC (Precision-Recall AUC).</a:t>
+              <a:t>Một mô hình ngây thơ luôn dự đoán 100% là "Hợp lệ" vẫn đạt Accuracy 99.87% trên PaySim gốc nhưng bỏ sót 100% gian lận! Do đó, đánh giá mô hình phải dẫn dắt bởi Precision, Recall, F1-Score và PR-AUC (Precision-Recall AUC).</a:t>
             </a:r>
             <a:endParaRPr lang="en-US" sz="930" dirty="0"/>
           </a:p>
@@ -25628,7 +25256,7 @@
                   <a:srgbClr val="1F2937"/>
                 </a:solidFill>
               </a:rPr>
-              <a:t>Nội suy mẫu nhân tạo thiểu số dọc theo đoạn thẳng nối các láng giềng k-NN trong Latent Space.
+              <a:t>Nội suy mẫu nhân tạo thiểu số dọc theo đoạn thẳng nối các láng giềng k-NN trong không gian đặc trưng.
 </a:t>
             </a:r>
             <a:pPr indent="0" marL="0">
@@ -26928,7 +26556,7 @@
                   <a:srgbClr val="2563EB"/>
                 </a:solidFill>
               </a:rPr>
-              <a:t>• Đúc kết: SMOTE ổn định và vượt trội hơn ADASYN trên cả Random Forest và XGBoost.</a:t>
+              <a:t>• Đúc kết: SMOTENC nhỉnh hơn nhẹ so với ADASYN trên RF và XGBoost (ít cảnh báo nhầm hơn).</a:t>
             </a:r>
             <a:endParaRPr lang="en-US" sz="880" dirty="0"/>
           </a:p>

</xml_diff>